<commit_message>
Switch POC offline testing to LinkSquares sample fixtures
Remove retired test_fixtures.json and Test_contracts_0397.json. Load
LinSquare_Contracts_100_Updated_30bb.json + agreement_9a06.json through
linksquares_fixtures, honor OverlapFlag in find_overlaps, and update
demo/tests/docs for CON-* Microsoft/AWS scenarios.

Co-authored-by: booshank <booshank@users.noreply.github.com>
</commit_message>
<xml_diff>
--- a/docs/VAL_CoPilot_Architecture_and_Process_Flow.pptx
+++ b/docs/VAL_CoPilot_Architecture_and_Process_Flow.pptx
@@ -3779,7 +3779,7 @@
                 </a:solidFill>
                 <a:latin typeface="Calibri"/>
               </a:rPr>
-              <a:t>AlphaTech C-1001..C-1003 + docs/demo_script.md</a:t>
+              <a:t>LinkSquares CON-* fixtures + docs/demo_script.md</a:t>
             </a:r>
           </a:p>
         </p:txBody>
@@ -5444,10 +5444,10 @@
                 <a:latin typeface="Calibri"/>
               </a:rPr>
               <a:t>Show contracts for vendor → search_contracts
-Details for C-1001 → get_contract_profile
+Details for CON-0002 → get_contract_profile
 Overlapping contracts → find_overlaps
 Unusual payment / high rates → explain_contract_risk
-Compare C-1001 vs C-1002 → compare_contracts
+Compare CON-0001 vs CON-0002 → compare_contracts
 Need action next 90 days → get_expiring_contracts
 Missing renewal info → check_missing_contract_fields
 Invoice spend also? → exact OOS refusal (no tools)</a:t>
@@ -6523,8 +6523,8 @@
                 </a:solidFill>
                 <a:latin typeface="Calibri"/>
               </a:rPr>
-              <a:t>AlphaTech C-1001 / C-1002 / C-1003
-Deliberate overlaps &amp; Net 90</a:t>
+              <a:t>LinkSquares 100 contracts
+Microsoft/AWS overlaps &amp; Net 180</a:t>
             </a:r>
           </a:p>
         </p:txBody>
@@ -6760,10 +6760,10 @@
               </a:rPr>
               <a:t>1. Load contracts via repository
 2. Group by vendor
-3. Intersect effective→expiration
+3. Prefer OverlapFlag=Yes pairs
 4. Emit overlap_start/end
 5. why_flagged + source
-Demo: C-1001 ∩ C-1002</a:t>
+Demo: CON-0024 ∩ CON-0029</a:t>
             </a:r>
           </a:p>
         </p:txBody>

</xml_diff>

<commit_message>
Add LinkSquares contract and agreement test fixtures (#13)
* Add LinkSquares contract and agreement fixtures for testing

Include the 100-row LinkSquares contract sample and agreement metadata
JSON alongside existing mcp_server test data for offline/local testing.

Co-authored-by: booshank <booshank@users.noreply.github.com>

* Switch POC offline testing to LinkSquares sample fixtures

Remove retired test_fixtures.json and Test_contracts_0397.json. Load
LinSquare_Contracts_100_Updated_30bb.json + agreement_9a06.json through
linksquares_fixtures, honor OverlapFlag in find_overlaps, and update
demo/tests/docs for CON-* Microsoft/AWS scenarios.

Co-authored-by: booshank <booshank@users.noreply.github.com>

---------

Co-authored-by: Cursor Agent <cursoragent@cursor.com>
Co-authored-by: booshank <booshank@users.noreply.github.com>
</commit_message>
<xml_diff>
--- a/docs/VAL_CoPilot_Architecture_and_Process_Flow.pptx
+++ b/docs/VAL_CoPilot_Architecture_and_Process_Flow.pptx
@@ -3779,7 +3779,7 @@
                 </a:solidFill>
                 <a:latin typeface="Calibri"/>
               </a:rPr>
-              <a:t>AlphaTech C-1001..C-1003 + docs/demo_script.md</a:t>
+              <a:t>LinkSquares CON-* fixtures + docs/demo_script.md</a:t>
             </a:r>
           </a:p>
         </p:txBody>
@@ -5444,10 +5444,10 @@
                 <a:latin typeface="Calibri"/>
               </a:rPr>
               <a:t>Show contracts for vendor → search_contracts
-Details for C-1001 → get_contract_profile
+Details for CON-0002 → get_contract_profile
 Overlapping contracts → find_overlaps
 Unusual payment / high rates → explain_contract_risk
-Compare C-1001 vs C-1002 → compare_contracts
+Compare CON-0001 vs CON-0002 → compare_contracts
 Need action next 90 days → get_expiring_contracts
 Missing renewal info → check_missing_contract_fields
 Invoice spend also? → exact OOS refusal (no tools)</a:t>
@@ -6523,8 +6523,8 @@
                 </a:solidFill>
                 <a:latin typeface="Calibri"/>
               </a:rPr>
-              <a:t>AlphaTech C-1001 / C-1002 / C-1003
-Deliberate overlaps &amp; Net 90</a:t>
+              <a:t>LinkSquares 100 contracts
+Microsoft/AWS overlaps &amp; Net 180</a:t>
             </a:r>
           </a:p>
         </p:txBody>
@@ -6760,10 +6760,10 @@
               </a:rPr>
               <a:t>1. Load contracts via repository
 2. Group by vendor
-3. Intersect effective→expiration
+3. Prefer OverlapFlag=Yes pairs
 4. Emit overlap_start/end
 5. why_flagged + source
-Demo: C-1001 ∩ C-1002</a:t>
+Demo: CON-0024 ∩ CON-0029</a:t>
             </a:r>
           </a:p>
         </p:txBody>

</xml_diff>

<commit_message>
docs: refresh architecture PDF/PPTX and Foundry guide for latest POC
Document persona memory, compare hard-stop, N-way compare, full MCP tool
inventory, and LinkSquares fixtures across the architecture generators and
optional Foundry deployment guide.

Co-authored-by: booshank <booshank@users.noreply.github.com>
</commit_message>
<xml_diff>
--- a/docs/VAL_CoPilot_Architecture_and_Process_Flow.pptx
+++ b/docs/VAL_CoPilot_Architecture_and_Process_Flow.pptx
@@ -15,6 +15,7 @@
     <p:sldId id="263" r:id="rId14"/>
     <p:sldId id="264" r:id="rId15"/>
     <p:sldId id="265" r:id="rId16"/>
+    <p:sldId id="266" r:id="rId17"/>
   </p:sldIdLst>
   <p:sldSz cx="12191695" cy="6858000" type="screen4x3"/>
   <p:notesSz cx="6858000" cy="9144000"/>
@@ -3288,7 +3289,7 @@
                 </a:solidFill>
                 <a:latin typeface="Calibri"/>
               </a:rPr>
-              <a:t>Current: Streamlit → Flask /api/messages → LangChain or offline router → FastMCP tools → synthetic Gold data</a:t>
+              <a:t>Current: Streamlit → Flask /api/messages → LangChain or offline router → FastMCP → LinkSquares fixtures + persona memory</a:t>
             </a:r>
           </a:p>
           <a:p>
@@ -3300,7 +3301,7 @@
                 </a:solidFill>
                 <a:latin typeface="Calibri"/>
               </a:rPr>
-              <a:t>Future: Streamlit/Teams → Azure AI Foundry Agent → same MCP/API tools → LinkSquares later</a:t>
+              <a:t>Future: Streamlit/Teams → Azure AI Foundry Agent → same MCP/API tools → live LinkSquares later</a:t>
             </a:r>
           </a:p>
           <a:p>
@@ -3312,7 +3313,7 @@
                 </a:solidFill>
                 <a:latin typeface="Calibri"/>
               </a:rPr>
-              <a:t>Not Azure AI Foundry-first today · Invoice/actual-spend systems are out of scope</a:t>
+              <a:t>Compare hard-stop when IDs missing · Invoice/actual-spend OOS · Not Foundry-first today</a:t>
             </a:r>
           </a:p>
         </p:txBody>
@@ -3409,6 +3410,761 @@
                 </a:solidFill>
                 <a:latin typeface="Calibri"/>
               </a:rPr>
+              <a:t>8. Optional Future — Azure AI Foundry Deploy</a:t>
+            </a:r>
+          </a:p>
+        </p:txBody>
+      </p:sp>
+      <p:sp>
+        <p:nvSpPr>
+          <p:cNvPr id="4" name="TextBox 3"/>
+          <p:cNvSpPr txBox="1"/>
+          <p:nvPr/>
+        </p:nvSpPr>
+        <p:spPr>
+          <a:xfrm>
+            <a:off x="365760" y="822960"/>
+            <a:ext cx="11430000" cy="320040"/>
+          </a:xfrm>
+          <a:prstGeom prst="rect">
+            <a:avLst/>
+          </a:prstGeom>
+          <a:noFill/>
+        </p:spPr>
+        <p:txBody>
+          <a:bodyPr wrap="none">
+            <a:spAutoFit/>
+          </a:bodyPr>
+          <a:lstStyle/>
+          <a:p>
+            <a:r>
+              <a:rPr sz="1200" b="0">
+                <a:solidFill>
+                  <a:srgbClr val="334155"/>
+                </a:solidFill>
+                <a:latin typeface="Calibri"/>
+              </a:rPr>
+              <a:t>deploy_to_foundry.py is optional; current POC does not require Foundry</a:t>
+            </a:r>
+          </a:p>
+        </p:txBody>
+      </p:sp>
+      <p:sp>
+        <p:nvSpPr>
+          <p:cNvPr id="5" name="Rounded Rectangle 4"/>
+          <p:cNvSpPr/>
+          <p:nvPr/>
+        </p:nvSpPr>
+        <p:spPr>
+          <a:xfrm>
+            <a:off x="365760" y="1828800"/>
+            <a:ext cx="2103120" cy="2011680"/>
+          </a:xfrm>
+          <a:prstGeom prst="roundRect">
+            <a:avLst>
+              <a:gd name="adj" fmla="val 12000"/>
+            </a:avLst>
+          </a:prstGeom>
+          <a:solidFill>
+            <a:srgbClr val="D9F3F3"/>
+          </a:solidFill>
+          <a:ln w="15875">
+            <a:solidFill>
+              <a:srgbClr val="0E6B6B"/>
+            </a:solidFill>
+          </a:ln>
+        </p:spPr>
+        <p:style>
+          <a:lnRef idx="1">
+            <a:schemeClr val="accent1"/>
+          </a:lnRef>
+          <a:fillRef idx="3">
+            <a:schemeClr val="accent1"/>
+          </a:fillRef>
+          <a:effectRef idx="2">
+            <a:schemeClr val="accent1"/>
+          </a:effectRef>
+          <a:fontRef idx="minor">
+            <a:schemeClr val="lt1"/>
+          </a:fontRef>
+        </p:style>
+        <p:txBody>
+          <a:bodyPr rtlCol="0" anchor="ctr" wrap="square"/>
+          <a:lstStyle/>
+          <a:p>
+            <a:pPr algn="ctr"/>
+            <a:r>
+              <a:rPr sz="1300" b="1">
+                <a:solidFill>
+                  <a:srgbClr val="0B1F33"/>
+                </a:solidFill>
+                <a:latin typeface="Calibri"/>
+              </a:rPr>
+              <a:t>Root .env</a:t>
+            </a:r>
+          </a:p>
+          <a:p>
+            <a:pPr algn="ctr"/>
+            <a:r>
+              <a:rPr sz="1100" b="0">
+                <a:solidFill>
+                  <a:srgbClr val="334155"/>
+                </a:solidFill>
+                <a:latin typeface="Calibri"/>
+              </a:rPr>
+              <a:t>AZURE_FOUNDRY_ CONNECTION_STRING</a:t>
+            </a:r>
+          </a:p>
+        </p:txBody>
+      </p:sp>
+      <p:sp>
+        <p:nvSpPr>
+          <p:cNvPr id="6" name="Rounded Rectangle 5"/>
+          <p:cNvSpPr/>
+          <p:nvPr/>
+        </p:nvSpPr>
+        <p:spPr>
+          <a:xfrm>
+            <a:off x="2743200" y="1828800"/>
+            <a:ext cx="2103120" cy="2011680"/>
+          </a:xfrm>
+          <a:prstGeom prst="roundRect">
+            <a:avLst>
+              <a:gd name="adj" fmla="val 12000"/>
+            </a:avLst>
+          </a:prstGeom>
+          <a:solidFill>
+            <a:srgbClr val="FFEDD5"/>
+          </a:solidFill>
+          <a:ln w="15875">
+            <a:solidFill>
+              <a:srgbClr val="C2410C"/>
+            </a:solidFill>
+          </a:ln>
+        </p:spPr>
+        <p:style>
+          <a:lnRef idx="1">
+            <a:schemeClr val="accent1"/>
+          </a:lnRef>
+          <a:fillRef idx="3">
+            <a:schemeClr val="accent1"/>
+          </a:fillRef>
+          <a:effectRef idx="2">
+            <a:schemeClr val="accent1"/>
+          </a:effectRef>
+          <a:fontRef idx="minor">
+            <a:schemeClr val="lt1"/>
+          </a:fontRef>
+        </p:style>
+        <p:txBody>
+          <a:bodyPr rtlCol="0" anchor="ctr" wrap="square"/>
+          <a:lstStyle/>
+          <a:p>
+            <a:pPr algn="ctr"/>
+            <a:r>
+              <a:rPr sz="1300" b="1">
+                <a:solidFill>
+                  <a:srgbClr val="0B1F33"/>
+                </a:solidFill>
+                <a:latin typeface="Calibri"/>
+              </a:rPr>
+              <a:t>Entra auth</a:t>
+            </a:r>
+          </a:p>
+          <a:p>
+            <a:pPr algn="ctr"/>
+            <a:r>
+              <a:rPr sz="1100" b="0">
+                <a:solidFill>
+                  <a:srgbClr val="334155"/>
+                </a:solidFill>
+                <a:latin typeface="Calibri"/>
+              </a:rPr>
+              <a:t>DefaultAzureCredential</a:t>
+            </a:r>
+          </a:p>
+        </p:txBody>
+      </p:sp>
+      <p:sp>
+        <p:nvSpPr>
+          <p:cNvPr id="7" name="Rounded Rectangle 6"/>
+          <p:cNvSpPr/>
+          <p:nvPr/>
+        </p:nvSpPr>
+        <p:spPr>
+          <a:xfrm>
+            <a:off x="5120640" y="1828800"/>
+            <a:ext cx="2103120" cy="2011680"/>
+          </a:xfrm>
+          <a:prstGeom prst="roundRect">
+            <a:avLst>
+              <a:gd name="adj" fmla="val 12000"/>
+            </a:avLst>
+          </a:prstGeom>
+          <a:solidFill>
+            <a:srgbClr val="D1FAE5"/>
+          </a:solidFill>
+          <a:ln w="15875">
+            <a:solidFill>
+              <a:srgbClr val="047857"/>
+            </a:solidFill>
+          </a:ln>
+        </p:spPr>
+        <p:style>
+          <a:lnRef idx="1">
+            <a:schemeClr val="accent1"/>
+          </a:lnRef>
+          <a:fillRef idx="3">
+            <a:schemeClr val="accent1"/>
+          </a:fillRef>
+          <a:effectRef idx="2">
+            <a:schemeClr val="accent1"/>
+          </a:effectRef>
+          <a:fontRef idx="minor">
+            <a:schemeClr val="lt1"/>
+          </a:fontRef>
+        </p:style>
+        <p:txBody>
+          <a:bodyPr rtlCol="0" anchor="ctr" wrap="square"/>
+          <a:lstStyle/>
+          <a:p>
+            <a:pPr algn="ctr"/>
+            <a:r>
+              <a:rPr sz="1300" b="1">
+                <a:solidFill>
+                  <a:srgbClr val="0B1F33"/>
+                </a:solidFill>
+                <a:latin typeface="Calibri"/>
+              </a:rPr>
+              <a:t>Wrap tools</a:t>
+            </a:r>
+          </a:p>
+          <a:p>
+            <a:pPr algn="ctr"/>
+            <a:r>
+              <a:rPr sz="1100" b="0">
+                <a:solidFill>
+                  <a:srgbClr val="334155"/>
+                </a:solidFill>
+                <a:latin typeface="Calibri"/>
+              </a:rPr>
+              <a:t>FunctionTool ToolSet (7 MCP tools)</a:t>
+            </a:r>
+          </a:p>
+        </p:txBody>
+      </p:sp>
+      <p:sp>
+        <p:nvSpPr>
+          <p:cNvPr id="8" name="Rounded Rectangle 7"/>
+          <p:cNvSpPr/>
+          <p:nvPr/>
+        </p:nvSpPr>
+        <p:spPr>
+          <a:xfrm>
+            <a:off x="7498079" y="1828800"/>
+            <a:ext cx="2103120" cy="2011680"/>
+          </a:xfrm>
+          <a:prstGeom prst="roundRect">
+            <a:avLst>
+              <a:gd name="adj" fmla="val 12000"/>
+            </a:avLst>
+          </a:prstGeom>
+          <a:solidFill>
+            <a:srgbClr val="DBEAFE"/>
+          </a:solidFill>
+          <a:ln w="15875">
+            <a:solidFill>
+              <a:srgbClr val="1D4ED8"/>
+            </a:solidFill>
+          </a:ln>
+        </p:spPr>
+        <p:style>
+          <a:lnRef idx="1">
+            <a:schemeClr val="accent1"/>
+          </a:lnRef>
+          <a:fillRef idx="3">
+            <a:schemeClr val="accent1"/>
+          </a:fillRef>
+          <a:effectRef idx="2">
+            <a:schemeClr val="accent1"/>
+          </a:effectRef>
+          <a:fontRef idx="minor">
+            <a:schemeClr val="lt1"/>
+          </a:fontRef>
+        </p:style>
+        <p:txBody>
+          <a:bodyPr rtlCol="0" anchor="ctr" wrap="square"/>
+          <a:lstStyle/>
+          <a:p>
+            <a:pPr algn="ctr"/>
+            <a:r>
+              <a:rPr sz="1300" b="1">
+                <a:solidFill>
+                  <a:srgbClr val="0B1F33"/>
+                </a:solidFill>
+                <a:latin typeface="Calibri"/>
+              </a:rPr>
+              <a:t>create_agent</a:t>
+            </a:r>
+          </a:p>
+          <a:p>
+            <a:pPr algn="ctr"/>
+            <a:r>
+              <a:rPr sz="1100" b="0">
+                <a:solidFill>
+                  <a:srgbClr val="334155"/>
+                </a:solidFill>
+                <a:latin typeface="Calibri"/>
+              </a:rPr>
+              <a:t>SYSTEM_PROMPT hard-stop + OOS</a:t>
+            </a:r>
+          </a:p>
+        </p:txBody>
+      </p:sp>
+      <p:sp>
+        <p:nvSpPr>
+          <p:cNvPr id="9" name="Rounded Rectangle 8"/>
+          <p:cNvSpPr/>
+          <p:nvPr/>
+        </p:nvSpPr>
+        <p:spPr>
+          <a:xfrm>
+            <a:off x="9875520" y="1828800"/>
+            <a:ext cx="2103120" cy="2011680"/>
+          </a:xfrm>
+          <a:prstGeom prst="roundRect">
+            <a:avLst>
+              <a:gd name="adj" fmla="val 12000"/>
+            </a:avLst>
+          </a:prstGeom>
+          <a:solidFill>
+            <a:srgbClr val="EDE9FE"/>
+          </a:solidFill>
+          <a:ln w="15875">
+            <a:solidFill>
+              <a:srgbClr val="6D28D9"/>
+            </a:solidFill>
+          </a:ln>
+        </p:spPr>
+        <p:style>
+          <a:lnRef idx="1">
+            <a:schemeClr val="accent1"/>
+          </a:lnRef>
+          <a:fillRef idx="3">
+            <a:schemeClr val="accent1"/>
+          </a:fillRef>
+          <a:effectRef idx="2">
+            <a:schemeClr val="accent1"/>
+          </a:effectRef>
+          <a:fontRef idx="minor">
+            <a:schemeClr val="lt1"/>
+          </a:fontRef>
+        </p:style>
+        <p:txBody>
+          <a:bodyPr rtlCol="0" anchor="ctr" wrap="square"/>
+          <a:lstStyle/>
+          <a:p>
+            <a:pPr algn="ctr"/>
+            <a:r>
+              <a:rPr sz="1300" b="1">
+                <a:solidFill>
+                  <a:srgbClr val="0B1F33"/>
+                </a:solidFill>
+                <a:latin typeface="Calibri"/>
+              </a:rPr>
+              <a:t>Future host</a:t>
+            </a:r>
+          </a:p>
+          <a:p>
+            <a:pPr algn="ctr"/>
+            <a:r>
+              <a:rPr sz="1100" b="0">
+                <a:solidFill>
+                  <a:srgbClr val="334155"/>
+                </a:solidFill>
+                <a:latin typeface="Calibri"/>
+              </a:rPr>
+              <a:t>Teams / Foundry UI extend ToolSet</a:t>
+            </a:r>
+          </a:p>
+        </p:txBody>
+      </p:sp>
+      <p:sp>
+        <p:nvSpPr>
+          <p:cNvPr id="10" name="Right Arrow 9"/>
+          <p:cNvSpPr/>
+          <p:nvPr/>
+        </p:nvSpPr>
+        <p:spPr>
+          <a:xfrm>
+            <a:off x="2514600" y="2743200"/>
+            <a:ext cx="201168" cy="182880"/>
+          </a:xfrm>
+          <a:prstGeom prst="rightArrow">
+            <a:avLst/>
+          </a:prstGeom>
+          <a:solidFill>
+            <a:srgbClr val="94A3B8"/>
+          </a:solidFill>
+          <a:ln>
+            <a:solidFill>
+              <a:srgbClr val="94A3B8"/>
+            </a:solidFill>
+          </a:ln>
+        </p:spPr>
+        <p:style>
+          <a:lnRef idx="1">
+            <a:schemeClr val="accent1"/>
+          </a:lnRef>
+          <a:fillRef idx="3">
+            <a:schemeClr val="accent1"/>
+          </a:fillRef>
+          <a:effectRef idx="2">
+            <a:schemeClr val="accent1"/>
+          </a:effectRef>
+          <a:fontRef idx="minor">
+            <a:schemeClr val="lt1"/>
+          </a:fontRef>
+        </p:style>
+        <p:txBody>
+          <a:bodyPr rtlCol="0" anchor="ctr"/>
+          <a:lstStyle/>
+          <a:p>
+            <a:pPr algn="ctr"/>
+          </a:p>
+        </p:txBody>
+      </p:sp>
+      <p:sp>
+        <p:nvSpPr>
+          <p:cNvPr id="11" name="Right Arrow 10"/>
+          <p:cNvSpPr/>
+          <p:nvPr/>
+        </p:nvSpPr>
+        <p:spPr>
+          <a:xfrm>
+            <a:off x="4892040" y="2743200"/>
+            <a:ext cx="201168" cy="182880"/>
+          </a:xfrm>
+          <a:prstGeom prst="rightArrow">
+            <a:avLst/>
+          </a:prstGeom>
+          <a:solidFill>
+            <a:srgbClr val="94A3B8"/>
+          </a:solidFill>
+          <a:ln>
+            <a:solidFill>
+              <a:srgbClr val="94A3B8"/>
+            </a:solidFill>
+          </a:ln>
+        </p:spPr>
+        <p:style>
+          <a:lnRef idx="1">
+            <a:schemeClr val="accent1"/>
+          </a:lnRef>
+          <a:fillRef idx="3">
+            <a:schemeClr val="accent1"/>
+          </a:fillRef>
+          <a:effectRef idx="2">
+            <a:schemeClr val="accent1"/>
+          </a:effectRef>
+          <a:fontRef idx="minor">
+            <a:schemeClr val="lt1"/>
+          </a:fontRef>
+        </p:style>
+        <p:txBody>
+          <a:bodyPr rtlCol="0" anchor="ctr"/>
+          <a:lstStyle/>
+          <a:p>
+            <a:pPr algn="ctr"/>
+          </a:p>
+        </p:txBody>
+      </p:sp>
+      <p:sp>
+        <p:nvSpPr>
+          <p:cNvPr id="12" name="Right Arrow 11"/>
+          <p:cNvSpPr/>
+          <p:nvPr/>
+        </p:nvSpPr>
+        <p:spPr>
+          <a:xfrm>
+            <a:off x="7269480" y="2743200"/>
+            <a:ext cx="201168" cy="182880"/>
+          </a:xfrm>
+          <a:prstGeom prst="rightArrow">
+            <a:avLst/>
+          </a:prstGeom>
+          <a:solidFill>
+            <a:srgbClr val="94A3B8"/>
+          </a:solidFill>
+          <a:ln>
+            <a:solidFill>
+              <a:srgbClr val="94A3B8"/>
+            </a:solidFill>
+          </a:ln>
+        </p:spPr>
+        <p:style>
+          <a:lnRef idx="1">
+            <a:schemeClr val="accent1"/>
+          </a:lnRef>
+          <a:fillRef idx="3">
+            <a:schemeClr val="accent1"/>
+          </a:fillRef>
+          <a:effectRef idx="2">
+            <a:schemeClr val="accent1"/>
+          </a:effectRef>
+          <a:fontRef idx="minor">
+            <a:schemeClr val="lt1"/>
+          </a:fontRef>
+        </p:style>
+        <p:txBody>
+          <a:bodyPr rtlCol="0" anchor="ctr"/>
+          <a:lstStyle/>
+          <a:p>
+            <a:pPr algn="ctr"/>
+          </a:p>
+        </p:txBody>
+      </p:sp>
+      <p:sp>
+        <p:nvSpPr>
+          <p:cNvPr id="13" name="Right Arrow 12"/>
+          <p:cNvSpPr/>
+          <p:nvPr/>
+        </p:nvSpPr>
+        <p:spPr>
+          <a:xfrm>
+            <a:off x="9646920" y="2743200"/>
+            <a:ext cx="201168" cy="182880"/>
+          </a:xfrm>
+          <a:prstGeom prst="rightArrow">
+            <a:avLst/>
+          </a:prstGeom>
+          <a:solidFill>
+            <a:srgbClr val="94A3B8"/>
+          </a:solidFill>
+          <a:ln>
+            <a:solidFill>
+              <a:srgbClr val="94A3B8"/>
+            </a:solidFill>
+          </a:ln>
+        </p:spPr>
+        <p:style>
+          <a:lnRef idx="1">
+            <a:schemeClr val="accent1"/>
+          </a:lnRef>
+          <a:fillRef idx="3">
+            <a:schemeClr val="accent1"/>
+          </a:fillRef>
+          <a:effectRef idx="2">
+            <a:schemeClr val="accent1"/>
+          </a:effectRef>
+          <a:fontRef idx="minor">
+            <a:schemeClr val="lt1"/>
+          </a:fontRef>
+        </p:style>
+        <p:txBody>
+          <a:bodyPr rtlCol="0" anchor="ctr"/>
+          <a:lstStyle/>
+          <a:p>
+            <a:pPr algn="ctr"/>
+          </a:p>
+        </p:txBody>
+      </p:sp>
+      <p:sp>
+        <p:nvSpPr>
+          <p:cNvPr id="14" name="Rounded Rectangle 13"/>
+          <p:cNvSpPr/>
+          <p:nvPr/>
+        </p:nvSpPr>
+        <p:spPr>
+          <a:xfrm>
+            <a:off x="457200" y="4206240"/>
+            <a:ext cx="11247120" cy="1645920"/>
+          </a:xfrm>
+          <a:prstGeom prst="roundRect">
+            <a:avLst>
+              <a:gd name="adj" fmla="val 12000"/>
+            </a:avLst>
+          </a:prstGeom>
+          <a:solidFill>
+            <a:srgbClr val="F1F5F9"/>
+          </a:solidFill>
+          <a:ln w="15875">
+            <a:solidFill>
+              <a:srgbClr val="94A3B8"/>
+            </a:solidFill>
+          </a:ln>
+        </p:spPr>
+        <p:style>
+          <a:lnRef idx="1">
+            <a:schemeClr val="accent1"/>
+          </a:lnRef>
+          <a:fillRef idx="3">
+            <a:schemeClr val="accent1"/>
+          </a:fillRef>
+          <a:effectRef idx="2">
+            <a:schemeClr val="accent1"/>
+          </a:effectRef>
+          <a:fontRef idx="minor">
+            <a:schemeClr val="lt1"/>
+          </a:fontRef>
+        </p:style>
+        <p:txBody>
+          <a:bodyPr rtlCol="0" anchor="ctr" wrap="square"/>
+          <a:lstStyle/>
+          <a:p>
+            <a:pPr algn="ctr"/>
+            <a:r>
+              <a:rPr sz="1300" b="1">
+                <a:solidFill>
+                  <a:srgbClr val="0B1F33"/>
+                </a:solidFill>
+                <a:latin typeface="Calibri"/>
+              </a:rPr>
+              <a:t>Deploy script ToolSet today (7 tools) — extend next to full MCP inventory</a:t>
+            </a:r>
+          </a:p>
+          <a:p>
+            <a:pPr algn="ctr"/>
+            <a:r>
+              <a:rPr sz="1100" b="0">
+                <a:solidFill>
+                  <a:srgbClr val="334155"/>
+                </a:solidFill>
+                <a:latin typeface="Calibri"/>
+              </a:rPr>
+              <a:t>search_contracts · get_contract_profile · get_expiring_contracts · get_vendor_spend_summary · find_overlaps · explain_contract_risk · search_cloud_blob_contracts
+Local FastMCP also has compare_contracts + check_missing_contract_fields. SYSTEM_PROMPT encodes compare hard-stop + persona-memory guidance.</a:t>
+            </a:r>
+          </a:p>
+        </p:txBody>
+      </p:sp>
+      <p:sp>
+        <p:nvSpPr>
+          <p:cNvPr id="15" name="TextBox 14"/>
+          <p:cNvSpPr txBox="1"/>
+          <p:nvPr/>
+        </p:nvSpPr>
+        <p:spPr>
+          <a:xfrm>
+            <a:off x="365760" y="6492240"/>
+            <a:ext cx="11430000" cy="274320"/>
+          </a:xfrm>
+          <a:prstGeom prst="rect">
+            <a:avLst/>
+          </a:prstGeom>
+          <a:noFill/>
+        </p:spPr>
+        <p:txBody>
+          <a:bodyPr wrap="none">
+            <a:spAutoFit/>
+          </a:bodyPr>
+          <a:lstStyle/>
+          <a:p>
+            <a:pPr algn="ctr"/>
+            <a:r>
+              <a:rPr sz="900" b="0">
+                <a:solidFill>
+                  <a:srgbClr val="94A3B8"/>
+                </a:solidFill>
+                <a:latin typeface="Calibri"/>
+              </a:rPr>
+              <a:t>Synthetic Contract Intelligence Tool-Layer POC · Slide 10</a:t>
+            </a:r>
+          </a:p>
+        </p:txBody>
+      </p:sp>
+    </p:spTree>
+  </p:cSld>
+  <p:clrMapOvr>
+    <a:masterClrMapping/>
+  </p:clrMapOvr>
+</p:sld>
+</file>
+
+<file path=ppt/slides/slide11.xml><?xml version="1.0" encoding="utf-8"?>
+<p:sld xmlns:a="http://schemas.openxmlformats.org/drawingml/2006/main" xmlns:p="http://schemas.openxmlformats.org/presentationml/2006/main" xmlns:r="http://schemas.openxmlformats.org/officeDocument/2006/relationships">
+  <p:cSld>
+    <p:spTree>
+      <p:nvGrpSpPr>
+        <p:cNvPr id="1" name=""/>
+        <p:cNvGrpSpPr/>
+        <p:nvPr/>
+      </p:nvGrpSpPr>
+      <p:grpSpPr/>
+      <p:sp>
+        <p:nvSpPr>
+          <p:cNvPr id="2" name="Rectangle 1"/>
+          <p:cNvSpPr/>
+          <p:nvPr/>
+        </p:nvSpPr>
+        <p:spPr>
+          <a:xfrm>
+            <a:off x="0" y="0"/>
+            <a:ext cx="12191695" cy="777240"/>
+          </a:xfrm>
+          <a:prstGeom prst="rect">
+            <a:avLst/>
+          </a:prstGeom>
+          <a:solidFill>
+            <a:srgbClr val="0B1F33"/>
+          </a:solidFill>
+          <a:ln>
+            <a:solidFill>
+              <a:srgbClr val="0B1F33"/>
+            </a:solidFill>
+          </a:ln>
+        </p:spPr>
+        <p:style>
+          <a:lnRef idx="1">
+            <a:schemeClr val="accent1"/>
+          </a:lnRef>
+          <a:fillRef idx="3">
+            <a:schemeClr val="accent1"/>
+          </a:fillRef>
+          <a:effectRef idx="2">
+            <a:schemeClr val="accent1"/>
+          </a:effectRef>
+          <a:fontRef idx="minor">
+            <a:schemeClr val="lt1"/>
+          </a:fontRef>
+        </p:style>
+        <p:txBody>
+          <a:bodyPr rtlCol="0" anchor="ctr"/>
+          <a:lstStyle/>
+          <a:p>
+            <a:pPr algn="ctr"/>
+          </a:p>
+        </p:txBody>
+      </p:sp>
+      <p:sp>
+        <p:nvSpPr>
+          <p:cNvPr id="3" name="TextBox 2"/>
+          <p:cNvSpPr txBox="1"/>
+          <p:nvPr/>
+        </p:nvSpPr>
+        <p:spPr>
+          <a:xfrm>
+            <a:off x="365760" y="164592"/>
+            <a:ext cx="11430000" cy="502920"/>
+          </a:xfrm>
+          <a:prstGeom prst="rect">
+            <a:avLst/>
+          </a:prstGeom>
+          <a:noFill/>
+        </p:spPr>
+        <p:txBody>
+          <a:bodyPr wrap="none">
+            <a:spAutoFit/>
+          </a:bodyPr>
+          <a:lstStyle/>
+          <a:p>
+            <a:r>
+              <a:rPr sz="2000" b="1">
+                <a:solidFill>
+                  <a:srgbClr val="FFFFFF"/>
+                </a:solidFill>
+                <a:latin typeface="Calibri"/>
+              </a:rPr>
               <a:t>9. Demo-Ready Slice Summary</a:t>
             </a:r>
           </a:p>
@@ -3555,7 +4311,7 @@
                 </a:solidFill>
                 <a:latin typeface="Calibri"/>
               </a:rPr>
-              <a:t>Invoice/AP/JDE/NetSuite asks → exact OOS refusal; ACV never labeled as invoices</a:t>
+              <a:t>Invoice OOS + compare hard-stop (exact messages; no default CON-* pair)</a:t>
             </a:r>
           </a:p>
         </p:txBody>
@@ -3667,7 +4423,7 @@
                 </a:solidFill>
                 <a:latin typeface="Calibri"/>
               </a:rPr>
-              <a:t>search / profile / overlaps / risk via ContractRepository</a:t>
+              <a:t>search / profile / N-way compare / overlaps / risk via ContractRepository</a:t>
             </a:r>
           </a:p>
         </p:txBody>
@@ -3723,7 +4479,7 @@
                 </a:solidFill>
                 <a:latin typeface="Calibri"/>
               </a:rPr>
-              <a:t>Deterministic demo</a:t>
+              <a:t>Persona memory</a:t>
             </a:r>
           </a:p>
         </p:txBody>
@@ -3779,7 +4535,7 @@
                 </a:solidFill>
                 <a:latin typeface="Calibri"/>
               </a:rPr>
-              <a:t>LinkSquares CON-* fixtures + docs/demo_script.md</a:t>
+              <a:t>SQLite save / pin / filter / recall previous searches per persona</a:t>
             </a:r>
           </a:p>
         </p:txBody>
@@ -3835,7 +4591,7 @@
                 </a:solidFill>
                 <a:latin typeface="Calibri"/>
               </a:rPr>
-              <a:t>Replaceable data</a:t>
+              <a:t>LinkSquares fixtures</a:t>
             </a:r>
           </a:p>
         </p:txBody>
@@ -3891,7 +4647,7 @@
                 </a:solidFill>
                 <a:latin typeface="Calibri"/>
               </a:rPr>
-              <a:t>ContractRepository ready for LinkSquares later</a:t>
+              <a:t>CON-* offline data + docs/demo_script.md; live CLM later</a:t>
             </a:r>
           </a:p>
         </p:txBody>
@@ -4003,7 +4759,7 @@
                 </a:solidFill>
                 <a:latin typeface="Calibri"/>
               </a:rPr>
-              <a:t>Current runtime is Flask+LangChain/offline router, not Foundry-first</a:t>
+              <a:t>Flask + offline router today; Foundry ToolSet wraps 7 tools</a:t>
             </a:r>
           </a:p>
         </p:txBody>
@@ -4038,7 +4794,7 @@
                 </a:solidFill>
                 <a:latin typeface="Calibri"/>
               </a:rPr>
-              <a:t>Synthetic Contract Intelligence Tool-Layer POC · Slide 10</a:t>
+              <a:t>Synthetic Contract Intelligence Tool-Layer POC · Slide 11</a:t>
             </a:r>
           </a:p>
         </p:txBody>
@@ -4237,14 +4993,14 @@
                 </a:solidFill>
                 <a:latin typeface="Calibri"/>
               </a:rPr>
-              <a:t>Streamlit UI
+              <a:t>Streamlit UI + Saved searches
 → Flask POST /api/messages
 → LangChain AgentExecutor
    or offline cognitive router
 → FastMCP tool server
 → ContractRepository
-→ Synthetic Gold fixtures
-   (Fabric SQL / AI Search later)</a:t>
+→ LinkSquares offline fixtures
+→ SQLite persona memory</a:t>
             </a:r>
           </a:p>
         </p:txBody>
@@ -4484,7 +5240,7 @@
                 </a:solidFill>
                 <a:latin typeface="Calibri"/>
               </a:rPr>
-              <a:t>Three layers + replaceable ContractRepository + invoice OOS guardrail</a:t>
+              <a:t>Four layers + persona memory + replaceable ContractRepository</a:t>
             </a:r>
           </a:p>
         </p:txBody>
@@ -4497,8 +5253,8 @@
         </p:nvSpPr>
         <p:spPr>
           <a:xfrm>
-            <a:off x="320040" y="1143000"/>
-            <a:ext cx="11521440" cy="1051560"/>
+            <a:off x="320040" y="1097280"/>
+            <a:ext cx="11521440" cy="960120"/>
           </a:xfrm>
           <a:prstGeom prst="roundRect">
             <a:avLst>
@@ -4534,7 +5290,7 @@
           <a:p>
             <a:pPr algn="ctr"/>
             <a:r>
-              <a:rPr sz="1400" b="1">
+              <a:rPr sz="1300" b="1">
                 <a:solidFill>
                   <a:srgbClr val="0B1F33"/>
                 </a:solidFill>
@@ -4546,13 +5302,13 @@
           <a:p>
             <a:pPr algn="ctr"/>
             <a:r>
-              <a:rPr sz="1200" b="0">
+              <a:rPr sz="1100" b="0">
                 <a:solidFill>
                   <a:srgbClr val="334155"/>
                 </a:solidFill>
                 <a:latin typeface="Calibri"/>
               </a:rPr>
-              <a:t>Streamlit Bot Framework harness → COPILOT_MESSAGES_URL</a:t>
+              <a:t>Streamlit chat · persona picker · Saved searches sidebar → COPILOT_MESSAGES_URL</a:t>
             </a:r>
           </a:p>
         </p:txBody>
@@ -4565,8 +5321,8 @@
         </p:nvSpPr>
         <p:spPr>
           <a:xfrm>
-            <a:off x="320040" y="2331720"/>
-            <a:ext cx="11521440" cy="1554480"/>
+            <a:off x="320040" y="2148840"/>
+            <a:ext cx="11521440" cy="1143000"/>
           </a:xfrm>
           <a:prstGeom prst="roundRect">
             <a:avLst>
@@ -4602,25 +5358,25 @@
           <a:p>
             <a:pPr algn="ctr"/>
             <a:r>
-              <a:rPr sz="1400" b="1">
+              <a:rPr sz="1300" b="1">
                 <a:solidFill>
                   <a:srgbClr val="0B1F33"/>
                 </a:solidFill>
                 <a:latin typeface="Calibri"/>
               </a:rPr>
-              <a:t>Layer 2 — Cognitive Routing (copilot_agent)</a:t>
-            </a:r>
-          </a:p>
-          <a:p>
-            <a:pPr algn="ctr"/>
-            <a:r>
-              <a:rPr sz="1200" b="0">
+              <a:t>Layer 2 — Cognitive Routing + Memory (copilot_agent + memory/)</a:t>
+            </a:r>
+          </a:p>
+          <a:p>
+            <a:pPr algn="ctr"/>
+            <a:r>
+              <a:rPr sz="1100" b="0">
                 <a:solidFill>
                   <a:srgbClr val="334155"/>
                 </a:solidFill>
                 <a:latin typeface="Calibri"/>
               </a:rPr>
-              <a:t>Flask /api/messages · LangChain AzureChatOpenAI / offline_router · SYSTEM_PROMPT · invoice OOS hard-match before tools</a:t>
+              <a:t>Flask /api/messages · /api/memory/* · LangChain / offline_router · SYSTEM_PROMPT · invoice OOS · compare hard-stop · SQLite persona store</a:t>
             </a:r>
           </a:p>
         </p:txBody>
@@ -4633,8 +5389,8 @@
         </p:nvSpPr>
         <p:spPr>
           <a:xfrm>
-            <a:off x="320040" y="4023360"/>
-            <a:ext cx="11521440" cy="2103120"/>
+            <a:off x="320040" y="3429000"/>
+            <a:ext cx="11521440" cy="1417320"/>
           </a:xfrm>
           <a:prstGeom prst="roundRect">
             <a:avLst>
@@ -4670,7 +5426,7 @@
           <a:p>
             <a:pPr algn="ctr"/>
             <a:r>
-              <a:rPr sz="1400" b="1">
+              <a:rPr sz="1300" b="1">
                 <a:solidFill>
                   <a:srgbClr val="0B1F33"/>
                 </a:solidFill>
@@ -4688,15 +5444,83 @@
                 </a:solidFill>
                 <a:latin typeface="Calibri"/>
               </a:rPr>
-              <a:t>ContractRepository → FabricContractRepository (synthetic Gold today)
-Tools: search_contracts · get_contract_profile · find_overlaps · explain_contract_risk · compare_contracts · check_missing_contract_fields · get_expiring_contracts · get_vendor_spend_summary · search_cloud_blob_contracts</a:t>
-            </a:r>
-          </a:p>
-        </p:txBody>
-      </p:sp>
-      <p:sp>
-        <p:nvSpPr>
-          <p:cNvPr id="8" name="TextBox 7"/>
+              <a:t>ContractRepository → analytics / risk helpers
+Tools: search · profile · compare (N-way) · missing-fields · expiring · spend rollup · overlaps · risk · blob search · health</a:t>
+            </a:r>
+          </a:p>
+        </p:txBody>
+      </p:sp>
+      <p:sp>
+        <p:nvSpPr>
+          <p:cNvPr id="8" name="Rounded Rectangle 7"/>
+          <p:cNvSpPr/>
+          <p:nvPr/>
+        </p:nvSpPr>
+        <p:spPr>
+          <a:xfrm>
+            <a:off x="320040" y="4983480"/>
+            <a:ext cx="11521440" cy="1051560"/>
+          </a:xfrm>
+          <a:prstGeom prst="roundRect">
+            <a:avLst>
+              <a:gd name="adj" fmla="val 12000"/>
+            </a:avLst>
+          </a:prstGeom>
+          <a:solidFill>
+            <a:srgbClr val="FEF3C7"/>
+          </a:solidFill>
+          <a:ln w="15875">
+            <a:solidFill>
+              <a:srgbClr val="B45309"/>
+            </a:solidFill>
+          </a:ln>
+        </p:spPr>
+        <p:style>
+          <a:lnRef idx="1">
+            <a:schemeClr val="accent1"/>
+          </a:lnRef>
+          <a:fillRef idx="3">
+            <a:schemeClr val="accent1"/>
+          </a:fillRef>
+          <a:effectRef idx="2">
+            <a:schemeClr val="accent1"/>
+          </a:effectRef>
+          <a:fontRef idx="minor">
+            <a:schemeClr val="lt1"/>
+          </a:fontRef>
+        </p:style>
+        <p:txBody>
+          <a:bodyPr rtlCol="0" anchor="ctr" wrap="square"/>
+          <a:lstStyle/>
+          <a:p>
+            <a:pPr algn="ctr"/>
+            <a:r>
+              <a:rPr sz="1300" b="1">
+                <a:solidFill>
+                  <a:srgbClr val="0B1F33"/>
+                </a:solidFill>
+                <a:latin typeface="Calibri"/>
+              </a:rPr>
+              <a:t>Layer 4 — Synthetic Gold (LinkSquares fixtures)</a:t>
+            </a:r>
+          </a:p>
+          <a:p>
+            <a:pPr algn="ctr"/>
+            <a:r>
+              <a:rPr sz="1100" b="0">
+                <a:solidFill>
+                  <a:srgbClr val="334155"/>
+                </a:solidFill>
+                <a:latin typeface="Calibri"/>
+              </a:rPr>
+              <a:t>LinSquare_Contracts_100_Updated_30bb.json + agreement_9a06.json · future live Fabric / LinkSquares</a:t>
+            </a:r>
+          </a:p>
+        </p:txBody>
+      </p:sp>
+      <p:sp>
+        <p:nvSpPr>
+          <p:cNvPr id="9" name="TextBox 8"/>
           <p:cNvSpPr txBox="1"/>
           <p:nvPr/>
         </p:nvSpPr>
@@ -4868,8 +5692,8 @@
         </p:nvSpPr>
         <p:spPr>
           <a:xfrm>
-            <a:off x="320040" y="1554480"/>
-            <a:ext cx="2148840" cy="1280160"/>
+            <a:off x="320040" y="1417320"/>
+            <a:ext cx="2148840" cy="1143000"/>
           </a:xfrm>
           <a:prstGeom prst="roundRect">
             <a:avLst>
@@ -4905,7 +5729,7 @@
           <a:p>
             <a:pPr algn="ctr"/>
             <a:r>
-              <a:rPr sz="1300" b="1">
+              <a:rPr sz="1200" b="1">
                 <a:solidFill>
                   <a:srgbClr val="0B1F33"/>
                 </a:solidFill>
@@ -4917,7 +5741,7 @@
           <a:p>
             <a:pPr algn="ctr"/>
             <a:r>
-              <a:rPr sz="1100" b="0">
+              <a:rPr sz="1000" b="0">
                 <a:solidFill>
                   <a:srgbClr val="334155"/>
                 </a:solidFill>
@@ -4936,8 +5760,8 @@
         </p:nvSpPr>
         <p:spPr>
           <a:xfrm>
-            <a:off x="2651760" y="1554480"/>
-            <a:ext cx="2148840" cy="1280160"/>
+            <a:off x="2651760" y="1417320"/>
+            <a:ext cx="2148840" cy="1143000"/>
           </a:xfrm>
           <a:prstGeom prst="roundRect">
             <a:avLst>
@@ -4973,25 +5797,25 @@
           <a:p>
             <a:pPr algn="ctr"/>
             <a:r>
-              <a:rPr sz="1300" b="1">
+              <a:rPr sz="1200" b="1">
                 <a:solidFill>
                   <a:srgbClr val="0B1F33"/>
                 </a:solidFill>
                 <a:latin typeface="Calibri"/>
               </a:rPr>
-              <a:t>2. Invoice OOS?</a:t>
-            </a:r>
-          </a:p>
-          <a:p>
-            <a:pPr algn="ctr"/>
-            <a:r>
-              <a:rPr sz="1100" b="0">
+              <a:t>2. Guardrails</a:t>
+            </a:r>
+          </a:p>
+          <a:p>
+            <a:pPr algn="ctr"/>
+            <a:r>
+              <a:rPr sz="1000" b="0">
                 <a:solidFill>
                   <a:srgbClr val="334155"/>
                 </a:solidFill>
                 <a:latin typeface="Calibri"/>
               </a:rPr>
-              <a:t>Hard refuse if invoice/AP</a:t>
+              <a:t>OOS / hard-stop / memory</a:t>
             </a:r>
           </a:p>
         </p:txBody>
@@ -5004,8 +5828,8 @@
         </p:nvSpPr>
         <p:spPr>
           <a:xfrm>
-            <a:off x="4983480" y="1554480"/>
-            <a:ext cx="2148840" cy="1280160"/>
+            <a:off x="4983480" y="1417320"/>
+            <a:ext cx="2148840" cy="1143000"/>
           </a:xfrm>
           <a:prstGeom prst="roundRect">
             <a:avLst>
@@ -5041,7 +5865,7 @@
           <a:p>
             <a:pPr algn="ctr"/>
             <a:r>
-              <a:rPr sz="1300" b="1">
+              <a:rPr sz="1200" b="1">
                 <a:solidFill>
                   <a:srgbClr val="0B1F33"/>
                 </a:solidFill>
@@ -5053,13 +5877,13 @@
           <a:p>
             <a:pPr algn="ctr"/>
             <a:r>
-              <a:rPr sz="1100" b="0">
+              <a:rPr sz="1000" b="0">
                 <a:solidFill>
                   <a:srgbClr val="334155"/>
                 </a:solidFill>
                 <a:latin typeface="Calibri"/>
               </a:rPr>
-              <a:t>offline_router / LLM tools</a:t>
+              <a:t>offline_router / LLM</a:t>
             </a:r>
           </a:p>
         </p:txBody>
@@ -5072,8 +5896,8 @@
         </p:nvSpPr>
         <p:spPr>
           <a:xfrm>
-            <a:off x="7315200" y="1554480"/>
-            <a:ext cx="2148840" cy="1280160"/>
+            <a:off x="7315200" y="1417320"/>
+            <a:ext cx="2148840" cy="1143000"/>
           </a:xfrm>
           <a:prstGeom prst="roundRect">
             <a:avLst>
@@ -5109,7 +5933,7 @@
           <a:p>
             <a:pPr algn="ctr"/>
             <a:r>
-              <a:rPr sz="1300" b="1">
+              <a:rPr sz="1200" b="1">
                 <a:solidFill>
                   <a:srgbClr val="0B1F33"/>
                 </a:solidFill>
@@ -5121,7 +5945,7 @@
           <a:p>
             <a:pPr algn="ctr"/>
             <a:r>
-              <a:rPr sz="1100" b="0">
+              <a:rPr sz="1000" b="0">
                 <a:solidFill>
                   <a:srgbClr val="334155"/>
                 </a:solidFill>
@@ -5140,8 +5964,8 @@
         </p:nvSpPr>
         <p:spPr>
           <a:xfrm>
-            <a:off x="9646920" y="1554480"/>
-            <a:ext cx="2148840" cy="1280160"/>
+            <a:off x="9646920" y="1417320"/>
+            <a:ext cx="2148840" cy="1143000"/>
           </a:xfrm>
           <a:prstGeom prst="roundRect">
             <a:avLst>
@@ -5177,25 +6001,25 @@
           <a:p>
             <a:pPr algn="ctr"/>
             <a:r>
-              <a:rPr sz="1300" b="1">
+              <a:rPr sz="1200" b="1">
                 <a:solidFill>
                   <a:srgbClr val="0B1F33"/>
                 </a:solidFill>
                 <a:latin typeface="Calibri"/>
               </a:rPr>
-              <a:t>5. Markdown reply</a:t>
-            </a:r>
-          </a:p>
-          <a:p>
-            <a:pPr algn="ctr"/>
-            <a:r>
-              <a:rPr sz="1100" b="0">
+              <a:t>5. Reply + save</a:t>
+            </a:r>
+          </a:p>
+          <a:p>
+            <a:pPr algn="ctr"/>
+            <a:r>
+              <a:rPr sz="1000" b="0">
                 <a:solidFill>
                   <a:srgbClr val="334155"/>
                 </a:solidFill>
                 <a:latin typeface="Calibri"/>
               </a:rPr>
-              <a:t>Grounded sections</a:t>
+              <a:t>Markdown · auto-save</a:t>
             </a:r>
           </a:p>
         </p:txBody>
@@ -5208,7 +6032,7 @@
         </p:nvSpPr>
         <p:spPr>
           <a:xfrm>
-            <a:off x="2331720" y="2103120"/>
+            <a:off x="2331720" y="1874519"/>
             <a:ext cx="274320" cy="164592"/>
           </a:xfrm>
           <a:prstGeom prst="rightArrow">
@@ -5253,7 +6077,7 @@
         </p:nvSpPr>
         <p:spPr>
           <a:xfrm>
-            <a:off x="4663440" y="2103120"/>
+            <a:off x="4663440" y="1874519"/>
             <a:ext cx="274320" cy="164592"/>
           </a:xfrm>
           <a:prstGeom prst="rightArrow">
@@ -5298,7 +6122,7 @@
         </p:nvSpPr>
         <p:spPr>
           <a:xfrm>
-            <a:off x="6995160" y="2103120"/>
+            <a:off x="6995160" y="1874519"/>
             <a:ext cx="274320" cy="164592"/>
           </a:xfrm>
           <a:prstGeom prst="rightArrow">
@@ -5343,7 +6167,7 @@
         </p:nvSpPr>
         <p:spPr>
           <a:xfrm>
-            <a:off x="9326880" y="2103120"/>
+            <a:off x="9326880" y="1874519"/>
             <a:ext cx="274320" cy="164592"/>
           </a:xfrm>
           <a:prstGeom prst="rightArrow">
@@ -5388,8 +6212,8 @@
         </p:nvSpPr>
         <p:spPr>
           <a:xfrm>
-            <a:off x="365760" y="3200400"/>
-            <a:ext cx="11430000" cy="2834640"/>
+            <a:off x="365760" y="2788920"/>
+            <a:ext cx="11430000" cy="3246120"/>
           </a:xfrm>
           <a:prstGeom prst="roundRect">
             <a:avLst>
@@ -5425,19 +6249,19 @@
           <a:p>
             <a:pPr algn="ctr"/>
             <a:r>
-              <a:rPr sz="1400" b="1">
+              <a:rPr sz="1300" b="1">
                 <a:solidFill>
                   <a:srgbClr val="0B1F33"/>
                 </a:solidFill>
                 <a:latin typeface="Calibri"/>
               </a:rPr>
-              <a:t>Intent → primary tool</a:t>
-            </a:r>
-          </a:p>
-          <a:p>
-            <a:pPr algn="ctr"/>
-            <a:r>
-              <a:rPr sz="1200" b="0">
+              <a:t>Intent → primary tool / outcome</a:t>
+            </a:r>
+          </a:p>
+          <a:p>
+            <a:pPr algn="ctr"/>
+            <a:r>
+              <a:rPr sz="1100" b="0">
                 <a:solidFill>
                   <a:srgbClr val="334155"/>
                 </a:solidFill>
@@ -5447,9 +6271,10 @@
 Details for CON-0002 → get_contract_profile
 Overlapping contracts → find_overlaps
 Unusual payment / high rates → explain_contract_risk
-Compare CON-0001 vs CON-0002 → compare_contracts
+Compare CON-0001 vs CON-0002 → compare_contracts (N-way any IDs)
+Compare unknown vendor/ID → hard-stop message only (no table / no recommendation)
 Need action next 90 days → get_expiring_contracts
-Missing renewal info → check_missing_contract_fields
+Previous / saved searches → persona memory recall (/api/memory/*)
 Invoice spend also? → exact OOS refusal (no tools)</a:t>
             </a:r>
           </a:p>
@@ -5582,7 +6407,7 @@
                 </a:solidFill>
                 <a:latin typeface="Calibri"/>
               </a:rPr>
-              <a:t>4. ContractRepository Abstraction</a:t>
+              <a:t>3b. Compare Hard-Stop &amp; Persona Memory</a:t>
             </a:r>
           </a:p>
         </p:txBody>
@@ -5616,7 +6441,7 @@
                 </a:solidFill>
                 <a:latin typeface="Calibri"/>
               </a:rPr>
-              <a:t>Data source is replaceable without changing tool contracts</a:t>
+              <a:t>Deterministic offline paths — no LLM default pairs, no invented history</a:t>
             </a:r>
           </a:p>
         </p:txBody>
@@ -5629,8 +6454,85 @@
         </p:nvSpPr>
         <p:spPr>
           <a:xfrm>
-            <a:off x="457200" y="1280160"/>
-            <a:ext cx="3657600" cy="4754880"/>
+            <a:off x="365760" y="1234440"/>
+            <a:ext cx="5669280" cy="4846320"/>
+          </a:xfrm>
+          <a:prstGeom prst="roundRect">
+            <a:avLst>
+              <a:gd name="adj" fmla="val 12000"/>
+            </a:avLst>
+          </a:prstGeom>
+          <a:solidFill>
+            <a:srgbClr val="FEE2E2"/>
+          </a:solidFill>
+          <a:ln w="15875">
+            <a:solidFill>
+              <a:srgbClr val="B91C1C"/>
+            </a:solidFill>
+          </a:ln>
+        </p:spPr>
+        <p:style>
+          <a:lnRef idx="1">
+            <a:schemeClr val="accent1"/>
+          </a:lnRef>
+          <a:fillRef idx="3">
+            <a:schemeClr val="accent1"/>
+          </a:fillRef>
+          <a:effectRef idx="2">
+            <a:schemeClr val="accent1"/>
+          </a:effectRef>
+          <a:fontRef idx="minor">
+            <a:schemeClr val="lt1"/>
+          </a:fontRef>
+        </p:style>
+        <p:txBody>
+          <a:bodyPr rtlCol="0" anchor="ctr" wrap="square"/>
+          <a:lstStyle/>
+          <a:p>
+            <a:pPr algn="ctr"/>
+            <a:r>
+              <a:rPr sz="1500" b="1">
+                <a:solidFill>
+                  <a:srgbClr val="0B1F33"/>
+                </a:solidFill>
+                <a:latin typeface="Calibri"/>
+              </a:rPr>
+              <a:t>Compare hard-stop</a:t>
+            </a:r>
+          </a:p>
+          <a:p>
+            <a:pPr algn="ctr"/>
+            <a:r>
+              <a:rPr sz="1200" b="0">
+                <a:solidFill>
+                  <a:srgbClr val="334155"/>
+                </a:solidFill>
+                <a:latin typeface="Calibri"/>
+              </a:rPr>
+              <a:t>If any requested supplier or contract ID
+cannot be resolved:
+Return ONLY:
+“The contract information requested
+for the comparison is not available
+at the moment”
+• No comparative table
+• No ## Recommendation
+• No CON-0001 vs CON-0002 default
+• Compare intents → offline_router</a:t>
+            </a:r>
+          </a:p>
+        </p:txBody>
+      </p:sp>
+      <p:sp>
+        <p:nvSpPr>
+          <p:cNvPr id="6" name="Rounded Rectangle 5"/>
+          <p:cNvSpPr/>
+          <p:nvPr/>
+        </p:nvSpPr>
+        <p:spPr>
+          <a:xfrm>
+            <a:off x="6309360" y="1234440"/>
+            <a:ext cx="5486400" cy="4846320"/>
           </a:xfrm>
           <a:prstGeom prst="roundRect">
             <a:avLst>
@@ -5666,292 +6568,41 @@
           <a:p>
             <a:pPr algn="ctr"/>
             <a:r>
-              <a:rPr sz="1600" b="1">
+              <a:rPr sz="1500" b="1">
                 <a:solidFill>
                   <a:srgbClr val="0B1F33"/>
                 </a:solidFill>
                 <a:latin typeface="Calibri"/>
               </a:rPr>
-              <a:t>ContractRepository</a:t>
-            </a:r>
-          </a:p>
-          <a:p>
-            <a:pPr algn="ctr"/>
-            <a:r>
-              <a:rPr sz="1400" b="0">
+              <a:t>Persona memory</a:t>
+            </a:r>
+          </a:p>
+          <a:p>
+            <a:pPr algn="ctr"/>
+            <a:r>
+              <a:rPr sz="1200" b="0">
                 <a:solidFill>
                   <a:srgbClr val="334155"/>
                 </a:solidFill>
                 <a:latin typeface="Calibri"/>
               </a:rPr>
-              <a:t>list_all()
-get_by_id(contract_id)
-search(filters)
-get_by_vendor(vendor)</a:t>
-            </a:r>
-          </a:p>
-        </p:txBody>
-      </p:sp>
-      <p:sp>
-        <p:nvSpPr>
-          <p:cNvPr id="6" name="Right Arrow 5"/>
-          <p:cNvSpPr/>
-          <p:nvPr/>
-        </p:nvSpPr>
-        <p:spPr>
-          <a:xfrm>
-            <a:off x="4297680" y="3383280"/>
-            <a:ext cx="457200" cy="256032"/>
-          </a:xfrm>
-          <a:prstGeom prst="rightArrow">
-            <a:avLst/>
-          </a:prstGeom>
-          <a:solidFill>
-            <a:srgbClr val="94A3B8"/>
-          </a:solidFill>
-          <a:ln>
-            <a:solidFill>
-              <a:srgbClr val="94A3B8"/>
-            </a:solidFill>
-          </a:ln>
-        </p:spPr>
-        <p:style>
-          <a:lnRef idx="1">
-            <a:schemeClr val="accent1"/>
-          </a:lnRef>
-          <a:fillRef idx="3">
-            <a:schemeClr val="accent1"/>
-          </a:fillRef>
-          <a:effectRef idx="2">
-            <a:schemeClr val="accent1"/>
-          </a:effectRef>
-          <a:fontRef idx="minor">
-            <a:schemeClr val="lt1"/>
-          </a:fontRef>
-        </p:style>
-        <p:txBody>
-          <a:bodyPr rtlCol="0" anchor="ctr"/>
-          <a:lstStyle/>
-          <a:p>
-            <a:pPr algn="ctr"/>
-          </a:p>
-        </p:txBody>
-      </p:sp>
-      <p:sp>
-        <p:nvSpPr>
-          <p:cNvPr id="7" name="Rounded Rectangle 6"/>
-          <p:cNvSpPr/>
-          <p:nvPr/>
-        </p:nvSpPr>
-        <p:spPr>
-          <a:xfrm>
-            <a:off x="4937760" y="1280160"/>
-            <a:ext cx="3291840" cy="2103120"/>
-          </a:xfrm>
-          <a:prstGeom prst="roundRect">
-            <a:avLst>
-              <a:gd name="adj" fmla="val 12000"/>
-            </a:avLst>
-          </a:prstGeom>
-          <a:solidFill>
-            <a:srgbClr val="D1FAE5"/>
-          </a:solidFill>
-          <a:ln w="15875">
-            <a:solidFill>
-              <a:srgbClr val="047857"/>
-            </a:solidFill>
-          </a:ln>
-        </p:spPr>
-        <p:style>
-          <a:lnRef idx="1">
-            <a:schemeClr val="accent1"/>
-          </a:lnRef>
-          <a:fillRef idx="3">
-            <a:schemeClr val="accent1"/>
-          </a:fillRef>
-          <a:effectRef idx="2">
-            <a:schemeClr val="accent1"/>
-          </a:effectRef>
-          <a:fontRef idx="minor">
-            <a:schemeClr val="lt1"/>
-          </a:fontRef>
-        </p:style>
-        <p:txBody>
-          <a:bodyPr rtlCol="0" anchor="ctr" wrap="square"/>
-          <a:lstStyle/>
-          <a:p>
-            <a:pPr algn="ctr"/>
-            <a:r>
-              <a:rPr sz="1500" b="1">
-                <a:solidFill>
-                  <a:srgbClr val="0B1F33"/>
-                </a:solidFill>
-                <a:latin typeface="Calibri"/>
-              </a:rPr>
-              <a:t>Today</a:t>
-            </a:r>
-          </a:p>
-          <a:p>
-            <a:pPr algn="ctr"/>
-            <a:r>
-              <a:rPr sz="1300" b="0">
-                <a:solidFill>
-                  <a:srgbClr val="334155"/>
-                </a:solidFill>
-                <a:latin typeface="Calibri"/>
-              </a:rPr>
-              <a:t>FabricContractRepository
-→ Gold_Vendor_Contracts
-→ offline fixtures</a:t>
-            </a:r>
-          </a:p>
-        </p:txBody>
-      </p:sp>
-      <p:sp>
-        <p:nvSpPr>
-          <p:cNvPr id="8" name="Rounded Rectangle 7"/>
-          <p:cNvSpPr/>
-          <p:nvPr/>
-        </p:nvSpPr>
-        <p:spPr>
-          <a:xfrm>
-            <a:off x="4937760" y="3657600"/>
-            <a:ext cx="3291840" cy="2377440"/>
-          </a:xfrm>
-          <a:prstGeom prst="roundRect">
-            <a:avLst>
-              <a:gd name="adj" fmla="val 12000"/>
-            </a:avLst>
-          </a:prstGeom>
-          <a:solidFill>
-            <a:srgbClr val="EDE9FE"/>
-          </a:solidFill>
-          <a:ln w="15875">
-            <a:solidFill>
-              <a:srgbClr val="6D28D9"/>
-            </a:solidFill>
-          </a:ln>
-        </p:spPr>
-        <p:style>
-          <a:lnRef idx="1">
-            <a:schemeClr val="accent1"/>
-          </a:lnRef>
-          <a:fillRef idx="3">
-            <a:schemeClr val="accent1"/>
-          </a:fillRef>
-          <a:effectRef idx="2">
-            <a:schemeClr val="accent1"/>
-          </a:effectRef>
-          <a:fontRef idx="minor">
-            <a:schemeClr val="lt1"/>
-          </a:fontRef>
-        </p:style>
-        <p:txBody>
-          <a:bodyPr rtlCol="0" anchor="ctr" wrap="square"/>
-          <a:lstStyle/>
-          <a:p>
-            <a:pPr algn="ctr"/>
-            <a:r>
-              <a:rPr sz="1500" b="1">
-                <a:solidFill>
-                  <a:srgbClr val="0B1F33"/>
-                </a:solidFill>
-                <a:latin typeface="Calibri"/>
-              </a:rPr>
-              <a:t>Later</a:t>
-            </a:r>
-          </a:p>
-          <a:p>
-            <a:pPr algn="ctr"/>
-            <a:r>
-              <a:rPr sz="1300" b="0">
-                <a:solidFill>
-                  <a:srgbClr val="334155"/>
-                </a:solidFill>
-                <a:latin typeface="Calibri"/>
-              </a:rPr>
-              <a:t>LinkSquares / CLM adapter
-same tool signatures
-same snake_case projections</a:t>
-            </a:r>
-          </a:p>
-        </p:txBody>
-      </p:sp>
-      <p:sp>
-        <p:nvSpPr>
-          <p:cNvPr id="9" name="Rounded Rectangle 8"/>
-          <p:cNvSpPr/>
-          <p:nvPr/>
-        </p:nvSpPr>
-        <p:spPr>
-          <a:xfrm>
-            <a:off x="8503920" y="1280160"/>
-            <a:ext cx="3200400" cy="4754880"/>
-          </a:xfrm>
-          <a:prstGeom prst="roundRect">
-            <a:avLst>
-              <a:gd name="adj" fmla="val 12000"/>
-            </a:avLst>
-          </a:prstGeom>
-          <a:solidFill>
-            <a:srgbClr val="FEF3C7"/>
-          </a:solidFill>
-          <a:ln w="15875">
-            <a:solidFill>
-              <a:srgbClr val="B45309"/>
-            </a:solidFill>
-          </a:ln>
-        </p:spPr>
-        <p:style>
-          <a:lnRef idx="1">
-            <a:schemeClr val="accent1"/>
-          </a:lnRef>
-          <a:fillRef idx="3">
-            <a:schemeClr val="accent1"/>
-          </a:fillRef>
-          <a:effectRef idx="2">
-            <a:schemeClr val="accent1"/>
-          </a:effectRef>
-          <a:fontRef idx="minor">
-            <a:schemeClr val="lt1"/>
-          </a:fontRef>
-        </p:style>
-        <p:txBody>
-          <a:bodyPr rtlCol="0" anchor="ctr" wrap="square"/>
-          <a:lstStyle/>
-          <a:p>
-            <a:pPr algn="ctr"/>
-            <a:r>
-              <a:rPr sz="1500" b="1">
-                <a:solidFill>
-                  <a:srgbClr val="0B1F33"/>
-                </a:solidFill>
-                <a:latin typeface="Calibri"/>
-              </a:rPr>
-              <a:t>Consumers</a:t>
-            </a:r>
-          </a:p>
-          <a:p>
-            <a:pPr algn="ctr"/>
-            <a:r>
-              <a:rPr sz="1200" b="0">
-                <a:solidFill>
-                  <a:srgbClr val="334155"/>
-                </a:solidFill>
-                <a:latin typeface="Calibri"/>
-              </a:rPr>
-              <a:t>search_contracts
-get_contract_profile
-find_overlaps
-explain_contract_risk
-compare / missing / expiring</a:t>
-            </a:r>
-          </a:p>
-        </p:txBody>
-      </p:sp>
-      <p:sp>
-        <p:nvSpPr>
-          <p:cNvPr id="10" name="TextBox 9"/>
+              <a:t>SQLite: data/persona_memory.sqlite
+(override VAL_MEMORY_DB)
+• Auto-save search-like queries
+• Pin / filter / delete in sidebar
+• GET/POST /api/memory/searches
+• GET /api/memory/recall
+• Memory-recall → offline store
+• Streamlit owns writes when
+  clientPersistsMemory is set
+memory/store.py + test_ui sidebar</a:t>
+            </a:r>
+          </a:p>
+        </p:txBody>
+      </p:sp>
+      <p:sp>
+        <p:nvSpPr>
+          <p:cNvPr id="7" name="TextBox 6"/>
           <p:cNvSpPr txBox="1"/>
           <p:nvPr/>
         </p:nvSpPr>
@@ -6076,7 +6727,7 @@
                 </a:solidFill>
                 <a:latin typeface="Calibri"/>
               </a:rPr>
-              <a:t>5. Structured Intelligence Tools (P0/P1)</a:t>
+              <a:t>4. ContractRepository Abstraction</a:t>
             </a:r>
           </a:p>
         </p:txBody>
@@ -6110,7 +6761,7 @@
                 </a:solidFill>
                 <a:latin typeface="Calibri"/>
               </a:rPr>
-              <a:t>Grounded metadata tools — not document search</a:t>
+              <a:t>Data source is replaceable without changing tool contracts</a:t>
             </a:r>
           </a:p>
         </p:txBody>
@@ -6123,8 +6774,124 @@
         </p:nvSpPr>
         <p:spPr>
           <a:xfrm>
-            <a:off x="365760" y="1188720"/>
-            <a:ext cx="3566160" cy="2103120"/>
+            <a:off x="457200" y="1280160"/>
+            <a:ext cx="3657600" cy="4754880"/>
+          </a:xfrm>
+          <a:prstGeom prst="roundRect">
+            <a:avLst>
+              <a:gd name="adj" fmla="val 12000"/>
+            </a:avLst>
+          </a:prstGeom>
+          <a:solidFill>
+            <a:srgbClr val="D9F3F3"/>
+          </a:solidFill>
+          <a:ln w="15875">
+            <a:solidFill>
+              <a:srgbClr val="0E6B6B"/>
+            </a:solidFill>
+          </a:ln>
+        </p:spPr>
+        <p:style>
+          <a:lnRef idx="1">
+            <a:schemeClr val="accent1"/>
+          </a:lnRef>
+          <a:fillRef idx="3">
+            <a:schemeClr val="accent1"/>
+          </a:fillRef>
+          <a:effectRef idx="2">
+            <a:schemeClr val="accent1"/>
+          </a:effectRef>
+          <a:fontRef idx="minor">
+            <a:schemeClr val="lt1"/>
+          </a:fontRef>
+        </p:style>
+        <p:txBody>
+          <a:bodyPr rtlCol="0" anchor="ctr" wrap="square"/>
+          <a:lstStyle/>
+          <a:p>
+            <a:pPr algn="ctr"/>
+            <a:r>
+              <a:rPr sz="1600" b="1">
+                <a:solidFill>
+                  <a:srgbClr val="0B1F33"/>
+                </a:solidFill>
+                <a:latin typeface="Calibri"/>
+              </a:rPr>
+              <a:t>ContractRepository</a:t>
+            </a:r>
+          </a:p>
+          <a:p>
+            <a:pPr algn="ctr"/>
+            <a:r>
+              <a:rPr sz="1400" b="0">
+                <a:solidFill>
+                  <a:srgbClr val="334155"/>
+                </a:solidFill>
+                <a:latin typeface="Calibri"/>
+              </a:rPr>
+              <a:t>list_all()
+get_by_id(contract_id)
+search(filters)
+get_by_vendor(vendor)</a:t>
+            </a:r>
+          </a:p>
+        </p:txBody>
+      </p:sp>
+      <p:sp>
+        <p:nvSpPr>
+          <p:cNvPr id="6" name="Right Arrow 5"/>
+          <p:cNvSpPr/>
+          <p:nvPr/>
+        </p:nvSpPr>
+        <p:spPr>
+          <a:xfrm>
+            <a:off x="4297680" y="3383280"/>
+            <a:ext cx="457200" cy="256032"/>
+          </a:xfrm>
+          <a:prstGeom prst="rightArrow">
+            <a:avLst/>
+          </a:prstGeom>
+          <a:solidFill>
+            <a:srgbClr val="94A3B8"/>
+          </a:solidFill>
+          <a:ln>
+            <a:solidFill>
+              <a:srgbClr val="94A3B8"/>
+            </a:solidFill>
+          </a:ln>
+        </p:spPr>
+        <p:style>
+          <a:lnRef idx="1">
+            <a:schemeClr val="accent1"/>
+          </a:lnRef>
+          <a:fillRef idx="3">
+            <a:schemeClr val="accent1"/>
+          </a:fillRef>
+          <a:effectRef idx="2">
+            <a:schemeClr val="accent1"/>
+          </a:effectRef>
+          <a:fontRef idx="minor">
+            <a:schemeClr val="lt1"/>
+          </a:fontRef>
+        </p:style>
+        <p:txBody>
+          <a:bodyPr rtlCol="0" anchor="ctr"/>
+          <a:lstStyle/>
+          <a:p>
+            <a:pPr algn="ctr"/>
+          </a:p>
+        </p:txBody>
+      </p:sp>
+      <p:sp>
+        <p:nvSpPr>
+          <p:cNvPr id="7" name="Rounded Rectangle 6"/>
+          <p:cNvSpPr/>
+          <p:nvPr/>
+        </p:nvSpPr>
+        <p:spPr>
+          <a:xfrm>
+            <a:off x="4937760" y="1280160"/>
+            <a:ext cx="3291840" cy="2103120"/>
           </a:xfrm>
           <a:prstGeom prst="roundRect">
             <a:avLst>
@@ -6160,164 +6927,27 @@
           <a:p>
             <a:pPr algn="ctr"/>
             <a:r>
-              <a:rPr sz="1400" b="1">
+              <a:rPr sz="1500" b="1">
                 <a:solidFill>
                   <a:srgbClr val="0B1F33"/>
                 </a:solidFill>
                 <a:latin typeface="Calibri"/>
               </a:rPr>
-              <a:t>search_contracts</a:t>
-            </a:r>
-          </a:p>
-          <a:p>
-            <a:pPr algn="ctr"/>
-            <a:r>
-              <a:rPr sz="1200" b="0">
+              <a:t>Today</a:t>
+            </a:r>
+          </a:p>
+          <a:p>
+            <a:pPr algn="ctr"/>
+            <a:r>
+              <a:rPr sz="1300" b="0">
                 <a:solidFill>
                   <a:srgbClr val="334155"/>
                 </a:solidFill>
                 <a:latin typeface="Calibri"/>
               </a:rPr>
-              <a:t>Vendor/BU/status/type filters
-Stable snake_case catalog rows</a:t>
-            </a:r>
-          </a:p>
-        </p:txBody>
-      </p:sp>
-      <p:sp>
-        <p:nvSpPr>
-          <p:cNvPr id="6" name="Rounded Rectangle 5"/>
-          <p:cNvSpPr/>
-          <p:nvPr/>
-        </p:nvSpPr>
-        <p:spPr>
-          <a:xfrm>
-            <a:off x="4206240" y="1188720"/>
-            <a:ext cx="3566160" cy="2103120"/>
-          </a:xfrm>
-          <a:prstGeom prst="roundRect">
-            <a:avLst>
-              <a:gd name="adj" fmla="val 12000"/>
-            </a:avLst>
-          </a:prstGeom>
-          <a:solidFill>
-            <a:srgbClr val="D9F3F3"/>
-          </a:solidFill>
-          <a:ln w="15875">
-            <a:solidFill>
-              <a:srgbClr val="0E6B6B"/>
-            </a:solidFill>
-          </a:ln>
-        </p:spPr>
-        <p:style>
-          <a:lnRef idx="1">
-            <a:schemeClr val="accent1"/>
-          </a:lnRef>
-          <a:fillRef idx="3">
-            <a:schemeClr val="accent1"/>
-          </a:fillRef>
-          <a:effectRef idx="2">
-            <a:schemeClr val="accent1"/>
-          </a:effectRef>
-          <a:fontRef idx="minor">
-            <a:schemeClr val="lt1"/>
-          </a:fontRef>
-        </p:style>
-        <p:txBody>
-          <a:bodyPr rtlCol="0" anchor="ctr" wrap="square"/>
-          <a:lstStyle/>
-          <a:p>
-            <a:pPr algn="ctr"/>
-            <a:r>
-              <a:rPr sz="1400" b="1">
-                <a:solidFill>
-                  <a:srgbClr val="0B1F33"/>
-                </a:solidFill>
-                <a:latin typeface="Calibri"/>
-              </a:rPr>
-              <a:t>get_contract_profile</a:t>
-            </a:r>
-          </a:p>
-          <a:p>
-            <a:pPr algn="ctr"/>
-            <a:r>
-              <a:rPr sz="1200" b="0">
-                <a:solidFill>
-                  <a:srgbClr val="334155"/>
-                </a:solidFill>
-                <a:latin typeface="Calibri"/>
-              </a:rPr>
-              <a:t>One contract_id profile
-+ missing_fields</a:t>
-            </a:r>
-          </a:p>
-        </p:txBody>
-      </p:sp>
-      <p:sp>
-        <p:nvSpPr>
-          <p:cNvPr id="7" name="Rounded Rectangle 6"/>
-          <p:cNvSpPr/>
-          <p:nvPr/>
-        </p:nvSpPr>
-        <p:spPr>
-          <a:xfrm>
-            <a:off x="8046720" y="1188720"/>
-            <a:ext cx="3566160" cy="2103120"/>
-          </a:xfrm>
-          <a:prstGeom prst="roundRect">
-            <a:avLst>
-              <a:gd name="adj" fmla="val 12000"/>
-            </a:avLst>
-          </a:prstGeom>
-          <a:solidFill>
-            <a:srgbClr val="FFEDD5"/>
-          </a:solidFill>
-          <a:ln w="15875">
-            <a:solidFill>
-              <a:srgbClr val="C2410C"/>
-            </a:solidFill>
-          </a:ln>
-        </p:spPr>
-        <p:style>
-          <a:lnRef idx="1">
-            <a:schemeClr val="accent1"/>
-          </a:lnRef>
-          <a:fillRef idx="3">
-            <a:schemeClr val="accent1"/>
-          </a:fillRef>
-          <a:effectRef idx="2">
-            <a:schemeClr val="accent1"/>
-          </a:effectRef>
-          <a:fontRef idx="minor">
-            <a:schemeClr val="lt1"/>
-          </a:fontRef>
-        </p:style>
-        <p:txBody>
-          <a:bodyPr rtlCol="0" anchor="ctr" wrap="square"/>
-          <a:lstStyle/>
-          <a:p>
-            <a:pPr algn="ctr"/>
-            <a:r>
-              <a:rPr sz="1400" b="1">
-                <a:solidFill>
-                  <a:srgbClr val="0B1F33"/>
-                </a:solidFill>
-                <a:latin typeface="Calibri"/>
-              </a:rPr>
-              <a:t>find_overlaps</a:t>
-            </a:r>
-          </a:p>
-          <a:p>
-            <a:pPr algn="ctr"/>
-            <a:r>
-              <a:rPr sz="1200" b="0">
-                <a:solidFill>
-                  <a:srgbClr val="334155"/>
-                </a:solidFill>
-                <a:latin typeface="Calibri"/>
-              </a:rPr>
-              <a:t>Same-vendor date overlaps
-contract_a/b + window + why</a:t>
+              <a:t>FabricContractRepository
+→ LinkSquares fixtures
+→ Gold-shaped projections</a:t>
             </a:r>
           </a:p>
         </p:txBody>
@@ -6330,8 +6960,8 @@
         </p:nvSpPr>
         <p:spPr>
           <a:xfrm>
-            <a:off x="365760" y="3657600"/>
-            <a:ext cx="3566160" cy="2103120"/>
+            <a:off x="4937760" y="3657600"/>
+            <a:ext cx="3291840" cy="2377440"/>
           </a:xfrm>
           <a:prstGeom prst="roundRect">
             <a:avLst>
@@ -6367,26 +6997,27 @@
           <a:p>
             <a:pPr algn="ctr"/>
             <a:r>
-              <a:rPr sz="1400" b="1">
+              <a:rPr sz="1500" b="1">
                 <a:solidFill>
                   <a:srgbClr val="0B1F33"/>
                 </a:solidFill>
                 <a:latin typeface="Calibri"/>
               </a:rPr>
-              <a:t>explain_contract_risk</a:t>
-            </a:r>
-          </a:p>
-          <a:p>
-            <a:pPr algn="ctr"/>
-            <a:r>
-              <a:rPr sz="1200" b="0">
+              <a:t>Later</a:t>
+            </a:r>
+          </a:p>
+          <a:p>
+            <a:pPr algn="ctr"/>
+            <a:r>
+              <a:rPr sz="1300" b="0">
                 <a:solidFill>
                   <a:srgbClr val="334155"/>
                 </a:solidFill>
                 <a:latin typeface="Calibri"/>
               </a:rPr>
-              <a:t>known_facts vs computed_risks
-missing_data + review action</a:t>
+              <a:t>Live LinkSquares / CLM
+same tool signatures
+same snake_case projections</a:t>
             </a:r>
           </a:p>
         </p:txBody>
@@ -6399,77 +7030,8 @@
         </p:nvSpPr>
         <p:spPr>
           <a:xfrm>
-            <a:off x="4206240" y="3657600"/>
-            <a:ext cx="3566160" cy="2103120"/>
-          </a:xfrm>
-          <a:prstGeom prst="roundRect">
-            <a:avLst>
-              <a:gd name="adj" fmla="val 12000"/>
-            </a:avLst>
-          </a:prstGeom>
-          <a:solidFill>
-            <a:srgbClr val="FEE2E2"/>
-          </a:solidFill>
-          <a:ln w="15875">
-            <a:solidFill>
-              <a:srgbClr val="B91C1C"/>
-            </a:solidFill>
-          </a:ln>
-        </p:spPr>
-        <p:style>
-          <a:lnRef idx="1">
-            <a:schemeClr val="accent1"/>
-          </a:lnRef>
-          <a:fillRef idx="3">
-            <a:schemeClr val="accent1"/>
-          </a:fillRef>
-          <a:effectRef idx="2">
-            <a:schemeClr val="accent1"/>
-          </a:effectRef>
-          <a:fontRef idx="minor">
-            <a:schemeClr val="lt1"/>
-          </a:fontRef>
-        </p:style>
-        <p:txBody>
-          <a:bodyPr rtlCol="0" anchor="ctr" wrap="square"/>
-          <a:lstStyle/>
-          <a:p>
-            <a:pPr algn="ctr"/>
-            <a:r>
-              <a:rPr sz="1400" b="1">
-                <a:solidFill>
-                  <a:srgbClr val="0B1F33"/>
-                </a:solidFill>
-                <a:latin typeface="Calibri"/>
-              </a:rPr>
-              <a:t>Invoice OOS guardrail</a:t>
-            </a:r>
-          </a:p>
-          <a:p>
-            <a:pPr algn="ctr"/>
-            <a:r>
-              <a:rPr sz="1200" b="0">
-                <a:solidFill>
-                  <a:srgbClr val="334155"/>
-                </a:solidFill>
-                <a:latin typeface="Calibri"/>
-              </a:rPr>
-              <a:t>Exact refusal before tools
-Never treat ACV as invoices</a:t>
-            </a:r>
-          </a:p>
-        </p:txBody>
-      </p:sp>
-      <p:sp>
-        <p:nvSpPr>
-          <p:cNvPr id="10" name="Rounded Rectangle 9"/>
-          <p:cNvSpPr/>
-          <p:nvPr/>
-        </p:nvSpPr>
-        <p:spPr>
-          <a:xfrm>
-            <a:off x="8046720" y="3657600"/>
-            <a:ext cx="3566160" cy="2103120"/>
+            <a:off x="8503920" y="1280160"/>
+            <a:ext cx="3200400" cy="4754880"/>
           </a:xfrm>
           <a:prstGeom prst="roundRect">
             <a:avLst>
@@ -6505,13 +7067,13 @@
           <a:p>
             <a:pPr algn="ctr"/>
             <a:r>
-              <a:rPr sz="1400" b="1">
+              <a:rPr sz="1500" b="1">
                 <a:solidFill>
                   <a:srgbClr val="0B1F33"/>
                 </a:solidFill>
                 <a:latin typeface="Calibri"/>
               </a:rPr>
-              <a:t>Demo fixtures</a:t>
+              <a:t>Consumers</a:t>
             </a:r>
           </a:p>
           <a:p>
@@ -6523,15 +7085,18 @@
                 </a:solidFill>
                 <a:latin typeface="Calibri"/>
               </a:rPr>
-              <a:t>LinkSquares 100 contracts
-Microsoft/AWS overlaps &amp; Net 180</a:t>
-            </a:r>
-          </a:p>
-        </p:txBody>
-      </p:sp>
-      <p:sp>
-        <p:nvSpPr>
-          <p:cNvPr id="11" name="TextBox 10"/>
+              <a:t>search_contracts
+get_contract_profile
+find_overlaps
+explain_contract_risk
+compare / missing / expiring</a:t>
+            </a:r>
+          </a:p>
+        </p:txBody>
+      </p:sp>
+      <p:sp>
+        <p:nvSpPr>
+          <p:cNvPr id="10" name="TextBox 9"/>
           <p:cNvSpPr txBox="1"/>
           <p:nvPr/>
         </p:nvSpPr>
@@ -6656,7 +7221,7 @@
                 </a:solidFill>
                 <a:latin typeface="Calibri"/>
               </a:rPr>
-              <a:t>6. Overlap &amp; Risk Explanation Process Flow</a:t>
+              <a:t>5. Structured Intelligence Tools (P0/P1)</a:t>
             </a:r>
           </a:p>
         </p:txBody>
@@ -6690,7 +7255,7 @@
                 </a:solidFill>
                 <a:latin typeface="Calibri"/>
               </a:rPr>
-              <a:t>Separate facts from computed risks — no invented findings</a:t>
+              <a:t>Grounded metadata tools — not document search</a:t>
             </a:r>
           </a:p>
         </p:txBody>
@@ -6703,8 +7268,146 @@
         </p:nvSpPr>
         <p:spPr>
           <a:xfrm>
-            <a:off x="365760" y="1280160"/>
-            <a:ext cx="3657600" cy="4754880"/>
+            <a:off x="365760" y="1188720"/>
+            <a:ext cx="3566160" cy="2103120"/>
+          </a:xfrm>
+          <a:prstGeom prst="roundRect">
+            <a:avLst>
+              <a:gd name="adj" fmla="val 12000"/>
+            </a:avLst>
+          </a:prstGeom>
+          <a:solidFill>
+            <a:srgbClr val="D1FAE5"/>
+          </a:solidFill>
+          <a:ln w="15875">
+            <a:solidFill>
+              <a:srgbClr val="047857"/>
+            </a:solidFill>
+          </a:ln>
+        </p:spPr>
+        <p:style>
+          <a:lnRef idx="1">
+            <a:schemeClr val="accent1"/>
+          </a:lnRef>
+          <a:fillRef idx="3">
+            <a:schemeClr val="accent1"/>
+          </a:fillRef>
+          <a:effectRef idx="2">
+            <a:schemeClr val="accent1"/>
+          </a:effectRef>
+          <a:fontRef idx="minor">
+            <a:schemeClr val="lt1"/>
+          </a:fontRef>
+        </p:style>
+        <p:txBody>
+          <a:bodyPr rtlCol="0" anchor="ctr" wrap="square"/>
+          <a:lstStyle/>
+          <a:p>
+            <a:pPr algn="ctr"/>
+            <a:r>
+              <a:rPr sz="1400" b="1">
+                <a:solidFill>
+                  <a:srgbClr val="0B1F33"/>
+                </a:solidFill>
+                <a:latin typeface="Calibri"/>
+              </a:rPr>
+              <a:t>search_contracts</a:t>
+            </a:r>
+          </a:p>
+          <a:p>
+            <a:pPr algn="ctr"/>
+            <a:r>
+              <a:rPr sz="1200" b="0">
+                <a:solidFill>
+                  <a:srgbClr val="334155"/>
+                </a:solidFill>
+                <a:latin typeface="Calibri"/>
+              </a:rPr>
+              <a:t>Vendor/BU/status/type filters
+Stable snake_case catalog rows</a:t>
+            </a:r>
+          </a:p>
+        </p:txBody>
+      </p:sp>
+      <p:sp>
+        <p:nvSpPr>
+          <p:cNvPr id="6" name="Rounded Rectangle 5"/>
+          <p:cNvSpPr/>
+          <p:nvPr/>
+        </p:nvSpPr>
+        <p:spPr>
+          <a:xfrm>
+            <a:off x="4206240" y="1188720"/>
+            <a:ext cx="3566160" cy="2103120"/>
+          </a:xfrm>
+          <a:prstGeom prst="roundRect">
+            <a:avLst>
+              <a:gd name="adj" fmla="val 12000"/>
+            </a:avLst>
+          </a:prstGeom>
+          <a:solidFill>
+            <a:srgbClr val="D9F3F3"/>
+          </a:solidFill>
+          <a:ln w="15875">
+            <a:solidFill>
+              <a:srgbClr val="0E6B6B"/>
+            </a:solidFill>
+          </a:ln>
+        </p:spPr>
+        <p:style>
+          <a:lnRef idx="1">
+            <a:schemeClr val="accent1"/>
+          </a:lnRef>
+          <a:fillRef idx="3">
+            <a:schemeClr val="accent1"/>
+          </a:fillRef>
+          <a:effectRef idx="2">
+            <a:schemeClr val="accent1"/>
+          </a:effectRef>
+          <a:fontRef idx="minor">
+            <a:schemeClr val="lt1"/>
+          </a:fontRef>
+        </p:style>
+        <p:txBody>
+          <a:bodyPr rtlCol="0" anchor="ctr" wrap="square"/>
+          <a:lstStyle/>
+          <a:p>
+            <a:pPr algn="ctr"/>
+            <a:r>
+              <a:rPr sz="1400" b="1">
+                <a:solidFill>
+                  <a:srgbClr val="0B1F33"/>
+                </a:solidFill>
+                <a:latin typeface="Calibri"/>
+              </a:rPr>
+              <a:t>get_contract_profile</a:t>
+            </a:r>
+          </a:p>
+          <a:p>
+            <a:pPr algn="ctr"/>
+            <a:r>
+              <a:rPr sz="1200" b="0">
+                <a:solidFill>
+                  <a:srgbClr val="334155"/>
+                </a:solidFill>
+                <a:latin typeface="Calibri"/>
+              </a:rPr>
+              <a:t>One contract_id profile
++ missing_fields</a:t>
+            </a:r>
+          </a:p>
+        </p:txBody>
+      </p:sp>
+      <p:sp>
+        <p:nvSpPr>
+          <p:cNvPr id="7" name="Rounded Rectangle 6"/>
+          <p:cNvSpPr/>
+          <p:nvPr/>
+        </p:nvSpPr>
+        <p:spPr>
+          <a:xfrm>
+            <a:off x="8046720" y="1188720"/>
+            <a:ext cx="3566160" cy="2103120"/>
           </a:xfrm>
           <a:prstGeom prst="roundRect">
             <a:avLst>
@@ -6740,13 +7443,13 @@
           <a:p>
             <a:pPr algn="ctr"/>
             <a:r>
-              <a:rPr sz="1500" b="1">
+              <a:rPr sz="1400" b="1">
                 <a:solidFill>
                   <a:srgbClr val="0B1F33"/>
                 </a:solidFill>
                 <a:latin typeface="Calibri"/>
               </a:rPr>
-              <a:t>find_overlaps</a:t>
+              <a:t>compare_contracts</a:t>
             </a:r>
           </a:p>
           <a:p>
@@ -6758,26 +7461,22 @@
                 </a:solidFill>
                 <a:latin typeface="Calibri"/>
               </a:rPr>
-              <a:t>1. Load contracts via repository
-2. Group by vendor
-3. Prefer OverlapFlag=Yes pairs
-4. Emit overlap_start/end
-5. why_flagged + source
-Demo: CON-0024 ∩ CON-0029</a:t>
-            </a:r>
-          </a:p>
-        </p:txBody>
-      </p:sp>
-      <p:sp>
-        <p:nvSpPr>
-          <p:cNvPr id="6" name="Rounded Rectangle 5"/>
+              <a:t>Pairwise / N-way any IDs
+Hard-stop if unresolved</a:t>
+            </a:r>
+          </a:p>
+        </p:txBody>
+      </p:sp>
+      <p:sp>
+        <p:nvSpPr>
+          <p:cNvPr id="8" name="Rounded Rectangle 7"/>
           <p:cNvSpPr/>
           <p:nvPr/>
         </p:nvSpPr>
         <p:spPr>
           <a:xfrm>
-            <a:off x="4297680" y="1280160"/>
-            <a:ext cx="3657600" cy="4754880"/>
+            <a:off x="365760" y="3657600"/>
+            <a:ext cx="3566160" cy="2103120"/>
           </a:xfrm>
           <a:prstGeom prst="roundRect">
             <a:avLst>
@@ -6813,7 +7512,7 @@
           <a:p>
             <a:pPr algn="ctr"/>
             <a:r>
-              <a:rPr sz="1500" b="1">
+              <a:rPr sz="1400" b="1">
                 <a:solidFill>
                   <a:srgbClr val="0B1F33"/>
                 </a:solidFill>
@@ -6831,28 +7530,22 @@
                 </a:solidFill>
                 <a:latin typeface="Calibri"/>
               </a:rPr>
-              <a:t>Flags only if data supports:
-• missing renewal
-• missing rate card
-• expiring soon
-• Net 90+ terms
-• high ACV outlier
-• high supplier risk
-• overlapping contract</a:t>
-            </a:r>
-          </a:p>
-        </p:txBody>
-      </p:sp>
-      <p:sp>
-        <p:nvSpPr>
-          <p:cNvPr id="7" name="Rounded Rectangle 6"/>
+              <a:t>known_facts vs computed_risks
+missing_data + review action</a:t>
+            </a:r>
+          </a:p>
+        </p:txBody>
+      </p:sp>
+      <p:sp>
+        <p:nvSpPr>
+          <p:cNvPr id="9" name="Rounded Rectangle 8"/>
           <p:cNvSpPr/>
           <p:nvPr/>
         </p:nvSpPr>
         <p:spPr>
           <a:xfrm>
-            <a:off x="8229600" y="1280160"/>
-            <a:ext cx="3566160" cy="4754880"/>
+            <a:off x="4206240" y="3657600"/>
+            <a:ext cx="3566160" cy="2103120"/>
           </a:xfrm>
           <a:prstGeom prst="roundRect">
             <a:avLst>
@@ -6860,11 +7553,11 @@
             </a:avLst>
           </a:prstGeom>
           <a:solidFill>
-            <a:srgbClr val="D9F3F3"/>
+            <a:srgbClr val="DBEAFE"/>
           </a:solidFill>
           <a:ln w="15875">
             <a:solidFill>
-              <a:srgbClr val="0E6B6B"/>
+              <a:srgbClr val="1D4ED8"/>
             </a:solidFill>
           </a:ln>
         </p:spPr>
@@ -6888,13 +7581,13 @@
           <a:p>
             <a:pPr algn="ctr"/>
             <a:r>
-              <a:rPr sz="1500" b="1">
+              <a:rPr sz="1400" b="1">
                 <a:solidFill>
                   <a:srgbClr val="0B1F33"/>
                 </a:solidFill>
                 <a:latin typeface="Calibri"/>
               </a:rPr>
-              <a:t>Response sections</a:t>
+              <a:t>find_overlaps</a:t>
             </a:r>
           </a:p>
           <a:p>
@@ -6906,19 +7599,84 @@
                 </a:solidFill>
                 <a:latin typeface="Calibri"/>
               </a:rPr>
-              <a:t>known_facts
-computed_risks
-missing_data
-recommended_review_action
-source
-Never invent unsupported risks</a:t>
-            </a:r>
-          </a:p>
-        </p:txBody>
-      </p:sp>
-      <p:sp>
-        <p:nvSpPr>
-          <p:cNvPr id="8" name="TextBox 7"/>
+              <a:t>Same-vendor date overlaps
+OverlapFlag-aware pairs</a:t>
+            </a:r>
+          </a:p>
+        </p:txBody>
+      </p:sp>
+      <p:sp>
+        <p:nvSpPr>
+          <p:cNvPr id="10" name="Rounded Rectangle 9"/>
+          <p:cNvSpPr/>
+          <p:nvPr/>
+        </p:nvSpPr>
+        <p:spPr>
+          <a:xfrm>
+            <a:off x="8046720" y="3657600"/>
+            <a:ext cx="3566160" cy="2103120"/>
+          </a:xfrm>
+          <a:prstGeom prst="roundRect">
+            <a:avLst>
+              <a:gd name="adj" fmla="val 12000"/>
+            </a:avLst>
+          </a:prstGeom>
+          <a:solidFill>
+            <a:srgbClr val="FEF3C7"/>
+          </a:solidFill>
+          <a:ln w="15875">
+            <a:solidFill>
+              <a:srgbClr val="B45309"/>
+            </a:solidFill>
+          </a:ln>
+        </p:spPr>
+        <p:style>
+          <a:lnRef idx="1">
+            <a:schemeClr val="accent1"/>
+          </a:lnRef>
+          <a:fillRef idx="3">
+            <a:schemeClr val="accent1"/>
+          </a:fillRef>
+          <a:effectRef idx="2">
+            <a:schemeClr val="accent1"/>
+          </a:effectRef>
+          <a:fontRef idx="minor">
+            <a:schemeClr val="lt1"/>
+          </a:fontRef>
+        </p:style>
+        <p:txBody>
+          <a:bodyPr rtlCol="0" anchor="ctr" wrap="square"/>
+          <a:lstStyle/>
+          <a:p>
+            <a:pPr algn="ctr"/>
+            <a:r>
+              <a:rPr sz="1400" b="1">
+                <a:solidFill>
+                  <a:srgbClr val="0B1F33"/>
+                </a:solidFill>
+                <a:latin typeface="Calibri"/>
+              </a:rPr>
+              <a:t>Demo fixtures</a:t>
+            </a:r>
+          </a:p>
+          <a:p>
+            <a:pPr algn="ctr"/>
+            <a:r>
+              <a:rPr sz="1200" b="0">
+                <a:solidFill>
+                  <a:srgbClr val="334155"/>
+                </a:solidFill>
+                <a:latin typeface="Calibri"/>
+              </a:rPr>
+              <a:t>LinkSquares 100 contracts
+Microsoft/AWS overlaps &amp; Net 180</a:t>
+            </a:r>
+          </a:p>
+        </p:txBody>
+      </p:sp>
+      <p:sp>
+        <p:nvSpPr>
+          <p:cNvPr id="11" name="TextBox 10"/>
           <p:cNvSpPr txBox="1"/>
           <p:nvPr/>
         </p:nvSpPr>
@@ -7043,7 +7801,7 @@
                 </a:solidFill>
                 <a:latin typeface="Calibri"/>
               </a:rPr>
-              <a:t>7. Full MCP Tool Inventory</a:t>
+              <a:t>6. Overlap &amp; Risk Explanation Process Flow</a:t>
             </a:r>
           </a:p>
         </p:txBody>
@@ -7077,7 +7835,7 @@
                 </a:solidFill>
                 <a:latin typeface="Calibri"/>
               </a:rPr>
-              <a:t>fabric_data FastMCP server</a:t>
+              <a:t>Separate facts from computed risks — no invented findings</a:t>
             </a:r>
           </a:p>
         </p:txBody>
@@ -7090,8 +7848,8 @@
         </p:nvSpPr>
         <p:spPr>
           <a:xfrm>
-            <a:off x="457200" y="1280160"/>
-            <a:ext cx="5486400" cy="4389120"/>
+            <a:off x="365760" y="1280160"/>
+            <a:ext cx="3657600" cy="4754880"/>
           </a:xfrm>
           <a:prstGeom prst="roundRect">
             <a:avLst>
@@ -7099,11 +7857,11 @@
             </a:avLst>
           </a:prstGeom>
           <a:solidFill>
-            <a:srgbClr val="D1FAE5"/>
+            <a:srgbClr val="FFEDD5"/>
           </a:solidFill>
           <a:ln w="15875">
             <a:solidFill>
-              <a:srgbClr val="047857"/>
+              <a:srgbClr val="C2410C"/>
             </a:solidFill>
           </a:ln>
         </p:spPr>
@@ -7133,23 +7891,24 @@
                 </a:solidFill>
                 <a:latin typeface="Calibri"/>
               </a:rPr>
-              <a:t>Structured / analytics</a:t>
-            </a:r>
-          </a:p>
-          <a:p>
-            <a:pPr algn="ctr"/>
-            <a:r>
-              <a:rPr sz="1300" b="0">
+              <a:t>find_overlaps</a:t>
+            </a:r>
+          </a:p>
+          <a:p>
+            <a:pPr algn="ctr"/>
+            <a:r>
+              <a:rPr sz="1200" b="0">
                 <a:solidFill>
                   <a:srgbClr val="334155"/>
                 </a:solidFill>
                 <a:latin typeface="Calibri"/>
               </a:rPr>
-              <a:t>search_contracts
-get_contract_profile
-find_overlaps
-explain_contract_risk
-compare_contracts</a:t>
+              <a:t>1. Load contracts via repository
+2. Group by vendor
+3. Prefer OverlapFlag=Yes pairs
+4. Emit overlap_start/end
+5. why_flagged + source
+Demo: CON-0024 ∩ CON-0029</a:t>
             </a:r>
           </a:p>
         </p:txBody>
@@ -7162,8 +7921,8 @@
         </p:nvSpPr>
         <p:spPr>
           <a:xfrm>
-            <a:off x="6309360" y="1280160"/>
-            <a:ext cx="5394960" cy="4389120"/>
+            <a:off x="4297680" y="1280160"/>
+            <a:ext cx="3657600" cy="4754880"/>
           </a:xfrm>
           <a:prstGeom prst="roundRect">
             <a:avLst>
@@ -7171,11 +7930,11 @@
             </a:avLst>
           </a:prstGeom>
           <a:solidFill>
-            <a:srgbClr val="DBEAFE"/>
+            <a:srgbClr val="EDE9FE"/>
           </a:solidFill>
           <a:ln w="15875">
             <a:solidFill>
-              <a:srgbClr val="1D4ED8"/>
+              <a:srgbClr val="6D28D9"/>
             </a:solidFill>
           </a:ln>
         </p:spPr>
@@ -7205,30 +7964,106 @@
                 </a:solidFill>
                 <a:latin typeface="Calibri"/>
               </a:rPr>
-              <a:t>Commercial / docs / health</a:t>
-            </a:r>
-          </a:p>
-          <a:p>
-            <a:pPr algn="ctr"/>
-            <a:r>
-              <a:rPr sz="1300" b="0">
+              <a:t>explain_contract_risk</a:t>
+            </a:r>
+          </a:p>
+          <a:p>
+            <a:pPr algn="ctr"/>
+            <a:r>
+              <a:rPr sz="1200" b="0">
                 <a:solidFill>
                   <a:srgbClr val="334155"/>
                 </a:solidFill>
                 <a:latin typeface="Calibri"/>
               </a:rPr>
-              <a:t>check_missing_contract_fields
-get_expiring_contracts
-get_vendor_spend_summary (ACV rollup only)
-search_cloud_blob_contracts (docs)
-fabric_health_check</a:t>
-            </a:r>
-          </a:p>
-        </p:txBody>
-      </p:sp>
-      <p:sp>
-        <p:nvSpPr>
-          <p:cNvPr id="7" name="TextBox 6"/>
+              <a:t>Flags only if data supports:
+• missing renewal
+• missing rate card
+• expiring soon
+• Net 90+ terms
+• high ACV outlier
+• high supplier risk
+• overlapping contract</a:t>
+            </a:r>
+          </a:p>
+        </p:txBody>
+      </p:sp>
+      <p:sp>
+        <p:nvSpPr>
+          <p:cNvPr id="7" name="Rounded Rectangle 6"/>
+          <p:cNvSpPr/>
+          <p:nvPr/>
+        </p:nvSpPr>
+        <p:spPr>
+          <a:xfrm>
+            <a:off x="8229600" y="1280160"/>
+            <a:ext cx="3566160" cy="4754880"/>
+          </a:xfrm>
+          <a:prstGeom prst="roundRect">
+            <a:avLst>
+              <a:gd name="adj" fmla="val 12000"/>
+            </a:avLst>
+          </a:prstGeom>
+          <a:solidFill>
+            <a:srgbClr val="D9F3F3"/>
+          </a:solidFill>
+          <a:ln w="15875">
+            <a:solidFill>
+              <a:srgbClr val="0E6B6B"/>
+            </a:solidFill>
+          </a:ln>
+        </p:spPr>
+        <p:style>
+          <a:lnRef idx="1">
+            <a:schemeClr val="accent1"/>
+          </a:lnRef>
+          <a:fillRef idx="3">
+            <a:schemeClr val="accent1"/>
+          </a:fillRef>
+          <a:effectRef idx="2">
+            <a:schemeClr val="accent1"/>
+          </a:effectRef>
+          <a:fontRef idx="minor">
+            <a:schemeClr val="lt1"/>
+          </a:fontRef>
+        </p:style>
+        <p:txBody>
+          <a:bodyPr rtlCol="0" anchor="ctr" wrap="square"/>
+          <a:lstStyle/>
+          <a:p>
+            <a:pPr algn="ctr"/>
+            <a:r>
+              <a:rPr sz="1500" b="1">
+                <a:solidFill>
+                  <a:srgbClr val="0B1F33"/>
+                </a:solidFill>
+                <a:latin typeface="Calibri"/>
+              </a:rPr>
+              <a:t>Response sections</a:t>
+            </a:r>
+          </a:p>
+          <a:p>
+            <a:pPr algn="ctr"/>
+            <a:r>
+              <a:rPr sz="1200" b="0">
+                <a:solidFill>
+                  <a:srgbClr val="334155"/>
+                </a:solidFill>
+                <a:latin typeface="Calibri"/>
+              </a:rPr>
+              <a:t>known_facts
+computed_risks
+missing_data
+recommended_review_action
+source
+Never invent unsupported risks</a:t>
+            </a:r>
+          </a:p>
+        </p:txBody>
+      </p:sp>
+      <p:sp>
+        <p:nvSpPr>
+          <p:cNvPr id="8" name="TextBox 7"/>
           <p:cNvSpPr txBox="1"/>
           <p:nvPr/>
         </p:nvSpPr>
@@ -7353,7 +8188,7 @@
                 </a:solidFill>
                 <a:latin typeface="Calibri"/>
               </a:rPr>
-              <a:t>8. Optional Future — Azure AI Foundry Deploy</a:t>
+              <a:t>7. Full MCP Tool Inventory</a:t>
             </a:r>
           </a:p>
         </p:txBody>
@@ -7387,7 +8222,7 @@
                 </a:solidFill>
                 <a:latin typeface="Calibri"/>
               </a:rPr>
-              <a:t>deploy_to_foundry.py is optional; current POC does not require Foundry</a:t>
+              <a:t>fabric_data FastMCP server</a:t>
             </a:r>
           </a:p>
         </p:txBody>
@@ -7400,144 +8235,8 @@
         </p:nvSpPr>
         <p:spPr>
           <a:xfrm>
-            <a:off x="365760" y="1828800"/>
-            <a:ext cx="2103120" cy="2011680"/>
-          </a:xfrm>
-          <a:prstGeom prst="roundRect">
-            <a:avLst>
-              <a:gd name="adj" fmla="val 12000"/>
-            </a:avLst>
-          </a:prstGeom>
-          <a:solidFill>
-            <a:srgbClr val="D9F3F3"/>
-          </a:solidFill>
-          <a:ln w="15875">
-            <a:solidFill>
-              <a:srgbClr val="0E6B6B"/>
-            </a:solidFill>
-          </a:ln>
-        </p:spPr>
-        <p:style>
-          <a:lnRef idx="1">
-            <a:schemeClr val="accent1"/>
-          </a:lnRef>
-          <a:fillRef idx="3">
-            <a:schemeClr val="accent1"/>
-          </a:fillRef>
-          <a:effectRef idx="2">
-            <a:schemeClr val="accent1"/>
-          </a:effectRef>
-          <a:fontRef idx="minor">
-            <a:schemeClr val="lt1"/>
-          </a:fontRef>
-        </p:style>
-        <p:txBody>
-          <a:bodyPr rtlCol="0" anchor="ctr" wrap="square"/>
-          <a:lstStyle/>
-          <a:p>
-            <a:pPr algn="ctr"/>
-            <a:r>
-              <a:rPr sz="1300" b="1">
-                <a:solidFill>
-                  <a:srgbClr val="0B1F33"/>
-                </a:solidFill>
-                <a:latin typeface="Calibri"/>
-              </a:rPr>
-              <a:t>Root .env</a:t>
-            </a:r>
-          </a:p>
-          <a:p>
-            <a:pPr algn="ctr"/>
-            <a:r>
-              <a:rPr sz="1100" b="0">
-                <a:solidFill>
-                  <a:srgbClr val="334155"/>
-                </a:solidFill>
-                <a:latin typeface="Calibri"/>
-              </a:rPr>
-              <a:t>AZURE_FOUNDRY_ CONNECTION_STRING</a:t>
-            </a:r>
-          </a:p>
-        </p:txBody>
-      </p:sp>
-      <p:sp>
-        <p:nvSpPr>
-          <p:cNvPr id="6" name="Rounded Rectangle 5"/>
-          <p:cNvSpPr/>
-          <p:nvPr/>
-        </p:nvSpPr>
-        <p:spPr>
-          <a:xfrm>
-            <a:off x="2743200" y="1828800"/>
-            <a:ext cx="2103120" cy="2011680"/>
-          </a:xfrm>
-          <a:prstGeom prst="roundRect">
-            <a:avLst>
-              <a:gd name="adj" fmla="val 12000"/>
-            </a:avLst>
-          </a:prstGeom>
-          <a:solidFill>
-            <a:srgbClr val="FFEDD5"/>
-          </a:solidFill>
-          <a:ln w="15875">
-            <a:solidFill>
-              <a:srgbClr val="C2410C"/>
-            </a:solidFill>
-          </a:ln>
-        </p:spPr>
-        <p:style>
-          <a:lnRef idx="1">
-            <a:schemeClr val="accent1"/>
-          </a:lnRef>
-          <a:fillRef idx="3">
-            <a:schemeClr val="accent1"/>
-          </a:fillRef>
-          <a:effectRef idx="2">
-            <a:schemeClr val="accent1"/>
-          </a:effectRef>
-          <a:fontRef idx="minor">
-            <a:schemeClr val="lt1"/>
-          </a:fontRef>
-        </p:style>
-        <p:txBody>
-          <a:bodyPr rtlCol="0" anchor="ctr" wrap="square"/>
-          <a:lstStyle/>
-          <a:p>
-            <a:pPr algn="ctr"/>
-            <a:r>
-              <a:rPr sz="1300" b="1">
-                <a:solidFill>
-                  <a:srgbClr val="0B1F33"/>
-                </a:solidFill>
-                <a:latin typeface="Calibri"/>
-              </a:rPr>
-              <a:t>Entra auth</a:t>
-            </a:r>
-          </a:p>
-          <a:p>
-            <a:pPr algn="ctr"/>
-            <a:r>
-              <a:rPr sz="1100" b="0">
-                <a:solidFill>
-                  <a:srgbClr val="334155"/>
-                </a:solidFill>
-                <a:latin typeface="Calibri"/>
-              </a:rPr>
-              <a:t>DefaultAzureCredential</a:t>
-            </a:r>
-          </a:p>
-        </p:txBody>
-      </p:sp>
-      <p:sp>
-        <p:nvSpPr>
-          <p:cNvPr id="7" name="Rounded Rectangle 6"/>
-          <p:cNvSpPr/>
-          <p:nvPr/>
-        </p:nvSpPr>
-        <p:spPr>
-          <a:xfrm>
-            <a:off x="5120640" y="1828800"/>
-            <a:ext cx="2103120" cy="2011680"/>
+            <a:off x="457200" y="1280160"/>
+            <a:ext cx="5486400" cy="4389120"/>
           </a:xfrm>
           <a:prstGeom prst="roundRect">
             <a:avLst>
@@ -7573,39 +8272,43 @@
           <a:p>
             <a:pPr algn="ctr"/>
             <a:r>
-              <a:rPr sz="1300" b="1">
+              <a:rPr sz="1500" b="1">
                 <a:solidFill>
                   <a:srgbClr val="0B1F33"/>
                 </a:solidFill>
                 <a:latin typeface="Calibri"/>
               </a:rPr>
-              <a:t>Wrap tools</a:t>
-            </a:r>
-          </a:p>
-          <a:p>
-            <a:pPr algn="ctr"/>
-            <a:r>
-              <a:rPr sz="1100" b="0">
+              <a:t>Structured / analytics</a:t>
+            </a:r>
+          </a:p>
+          <a:p>
+            <a:pPr algn="ctr"/>
+            <a:r>
+              <a:rPr sz="1300" b="0">
                 <a:solidFill>
                   <a:srgbClr val="334155"/>
                 </a:solidFill>
                 <a:latin typeface="Calibri"/>
               </a:rPr>
-              <a:t>FunctionTool ToolSet (7 MCP tools)</a:t>
-            </a:r>
-          </a:p>
-        </p:txBody>
-      </p:sp>
-      <p:sp>
-        <p:nvSpPr>
-          <p:cNvPr id="8" name="Rounded Rectangle 7"/>
+              <a:t>search_contracts
+get_contract_profile
+find_overlaps
+explain_contract_risk
+compare_contracts (N-way; hard-stop)</a:t>
+            </a:r>
+          </a:p>
+        </p:txBody>
+      </p:sp>
+      <p:sp>
+        <p:nvSpPr>
+          <p:cNvPr id="6" name="Rounded Rectangle 5"/>
           <p:cNvSpPr/>
           <p:nvPr/>
         </p:nvSpPr>
         <p:spPr>
           <a:xfrm>
-            <a:off x="7498079" y="1828800"/>
-            <a:ext cx="2103120" cy="2011680"/>
+            <a:off x="6309360" y="1280160"/>
+            <a:ext cx="5394960" cy="4389120"/>
           </a:xfrm>
           <a:prstGeom prst="roundRect">
             <a:avLst>
@@ -7641,349 +8344,36 @@
           <a:p>
             <a:pPr algn="ctr"/>
             <a:r>
-              <a:rPr sz="1300" b="1">
+              <a:rPr sz="1500" b="1">
                 <a:solidFill>
                   <a:srgbClr val="0B1F33"/>
                 </a:solidFill>
                 <a:latin typeface="Calibri"/>
               </a:rPr>
-              <a:t>create_agent</a:t>
-            </a:r>
-          </a:p>
-          <a:p>
-            <a:pPr algn="ctr"/>
-            <a:r>
-              <a:rPr sz="1100" b="0">
+              <a:t>Commercial / docs / health</a:t>
+            </a:r>
+          </a:p>
+          <a:p>
+            <a:pPr algn="ctr"/>
+            <a:r>
+              <a:rPr sz="1300" b="0">
                 <a:solidFill>
                   <a:srgbClr val="334155"/>
                 </a:solidFill>
                 <a:latin typeface="Calibri"/>
               </a:rPr>
-              <a:t>SYSTEM_PROMPT + OOS guardrail</a:t>
-            </a:r>
-          </a:p>
-        </p:txBody>
-      </p:sp>
-      <p:sp>
-        <p:nvSpPr>
-          <p:cNvPr id="9" name="Rounded Rectangle 8"/>
-          <p:cNvSpPr/>
-          <p:nvPr/>
-        </p:nvSpPr>
-        <p:spPr>
-          <a:xfrm>
-            <a:off x="9875520" y="1828800"/>
-            <a:ext cx="2103120" cy="2011680"/>
-          </a:xfrm>
-          <a:prstGeom prst="roundRect">
-            <a:avLst>
-              <a:gd name="adj" fmla="val 12000"/>
-            </a:avLst>
-          </a:prstGeom>
-          <a:solidFill>
-            <a:srgbClr val="EDE9FE"/>
-          </a:solidFill>
-          <a:ln w="15875">
-            <a:solidFill>
-              <a:srgbClr val="6D28D9"/>
-            </a:solidFill>
-          </a:ln>
-        </p:spPr>
-        <p:style>
-          <a:lnRef idx="1">
-            <a:schemeClr val="accent1"/>
-          </a:lnRef>
-          <a:fillRef idx="3">
-            <a:schemeClr val="accent1"/>
-          </a:fillRef>
-          <a:effectRef idx="2">
-            <a:schemeClr val="accent1"/>
-          </a:effectRef>
-          <a:fontRef idx="minor">
-            <a:schemeClr val="lt1"/>
-          </a:fontRef>
-        </p:style>
-        <p:txBody>
-          <a:bodyPr rtlCol="0" anchor="ctr" wrap="square"/>
-          <a:lstStyle/>
-          <a:p>
-            <a:pPr algn="ctr"/>
-            <a:r>
-              <a:rPr sz="1300" b="1">
-                <a:solidFill>
-                  <a:srgbClr val="0B1F33"/>
-                </a:solidFill>
-                <a:latin typeface="Calibri"/>
-              </a:rPr>
-              <a:t>Future host</a:t>
-            </a:r>
-          </a:p>
-          <a:p>
-            <a:pPr algn="ctr"/>
-            <a:r>
-              <a:rPr sz="1100" b="0">
-                <a:solidFill>
-                  <a:srgbClr val="334155"/>
-                </a:solidFill>
-                <a:latin typeface="Calibri"/>
-              </a:rPr>
-              <a:t>Teams / Foundry UI same tool contracts</a:t>
-            </a:r>
-          </a:p>
-        </p:txBody>
-      </p:sp>
-      <p:sp>
-        <p:nvSpPr>
-          <p:cNvPr id="10" name="Right Arrow 9"/>
-          <p:cNvSpPr/>
-          <p:nvPr/>
-        </p:nvSpPr>
-        <p:spPr>
-          <a:xfrm>
-            <a:off x="2514600" y="2743200"/>
-            <a:ext cx="201168" cy="182880"/>
-          </a:xfrm>
-          <a:prstGeom prst="rightArrow">
-            <a:avLst/>
-          </a:prstGeom>
-          <a:solidFill>
-            <a:srgbClr val="94A3B8"/>
-          </a:solidFill>
-          <a:ln>
-            <a:solidFill>
-              <a:srgbClr val="94A3B8"/>
-            </a:solidFill>
-          </a:ln>
-        </p:spPr>
-        <p:style>
-          <a:lnRef idx="1">
-            <a:schemeClr val="accent1"/>
-          </a:lnRef>
-          <a:fillRef idx="3">
-            <a:schemeClr val="accent1"/>
-          </a:fillRef>
-          <a:effectRef idx="2">
-            <a:schemeClr val="accent1"/>
-          </a:effectRef>
-          <a:fontRef idx="minor">
-            <a:schemeClr val="lt1"/>
-          </a:fontRef>
-        </p:style>
-        <p:txBody>
-          <a:bodyPr rtlCol="0" anchor="ctr"/>
-          <a:lstStyle/>
-          <a:p>
-            <a:pPr algn="ctr"/>
-          </a:p>
-        </p:txBody>
-      </p:sp>
-      <p:sp>
-        <p:nvSpPr>
-          <p:cNvPr id="11" name="Right Arrow 10"/>
-          <p:cNvSpPr/>
-          <p:nvPr/>
-        </p:nvSpPr>
-        <p:spPr>
-          <a:xfrm>
-            <a:off x="4892040" y="2743200"/>
-            <a:ext cx="201168" cy="182880"/>
-          </a:xfrm>
-          <a:prstGeom prst="rightArrow">
-            <a:avLst/>
-          </a:prstGeom>
-          <a:solidFill>
-            <a:srgbClr val="94A3B8"/>
-          </a:solidFill>
-          <a:ln>
-            <a:solidFill>
-              <a:srgbClr val="94A3B8"/>
-            </a:solidFill>
-          </a:ln>
-        </p:spPr>
-        <p:style>
-          <a:lnRef idx="1">
-            <a:schemeClr val="accent1"/>
-          </a:lnRef>
-          <a:fillRef idx="3">
-            <a:schemeClr val="accent1"/>
-          </a:fillRef>
-          <a:effectRef idx="2">
-            <a:schemeClr val="accent1"/>
-          </a:effectRef>
-          <a:fontRef idx="minor">
-            <a:schemeClr val="lt1"/>
-          </a:fontRef>
-        </p:style>
-        <p:txBody>
-          <a:bodyPr rtlCol="0" anchor="ctr"/>
-          <a:lstStyle/>
-          <a:p>
-            <a:pPr algn="ctr"/>
-          </a:p>
-        </p:txBody>
-      </p:sp>
-      <p:sp>
-        <p:nvSpPr>
-          <p:cNvPr id="12" name="Right Arrow 11"/>
-          <p:cNvSpPr/>
-          <p:nvPr/>
-        </p:nvSpPr>
-        <p:spPr>
-          <a:xfrm>
-            <a:off x="7269480" y="2743200"/>
-            <a:ext cx="201168" cy="182880"/>
-          </a:xfrm>
-          <a:prstGeom prst="rightArrow">
-            <a:avLst/>
-          </a:prstGeom>
-          <a:solidFill>
-            <a:srgbClr val="94A3B8"/>
-          </a:solidFill>
-          <a:ln>
-            <a:solidFill>
-              <a:srgbClr val="94A3B8"/>
-            </a:solidFill>
-          </a:ln>
-        </p:spPr>
-        <p:style>
-          <a:lnRef idx="1">
-            <a:schemeClr val="accent1"/>
-          </a:lnRef>
-          <a:fillRef idx="3">
-            <a:schemeClr val="accent1"/>
-          </a:fillRef>
-          <a:effectRef idx="2">
-            <a:schemeClr val="accent1"/>
-          </a:effectRef>
-          <a:fontRef idx="minor">
-            <a:schemeClr val="lt1"/>
-          </a:fontRef>
-        </p:style>
-        <p:txBody>
-          <a:bodyPr rtlCol="0" anchor="ctr"/>
-          <a:lstStyle/>
-          <a:p>
-            <a:pPr algn="ctr"/>
-          </a:p>
-        </p:txBody>
-      </p:sp>
-      <p:sp>
-        <p:nvSpPr>
-          <p:cNvPr id="13" name="Right Arrow 12"/>
-          <p:cNvSpPr/>
-          <p:nvPr/>
-        </p:nvSpPr>
-        <p:spPr>
-          <a:xfrm>
-            <a:off x="9646920" y="2743200"/>
-            <a:ext cx="201168" cy="182880"/>
-          </a:xfrm>
-          <a:prstGeom prst="rightArrow">
-            <a:avLst/>
-          </a:prstGeom>
-          <a:solidFill>
-            <a:srgbClr val="94A3B8"/>
-          </a:solidFill>
-          <a:ln>
-            <a:solidFill>
-              <a:srgbClr val="94A3B8"/>
-            </a:solidFill>
-          </a:ln>
-        </p:spPr>
-        <p:style>
-          <a:lnRef idx="1">
-            <a:schemeClr val="accent1"/>
-          </a:lnRef>
-          <a:fillRef idx="3">
-            <a:schemeClr val="accent1"/>
-          </a:fillRef>
-          <a:effectRef idx="2">
-            <a:schemeClr val="accent1"/>
-          </a:effectRef>
-          <a:fontRef idx="minor">
-            <a:schemeClr val="lt1"/>
-          </a:fontRef>
-        </p:style>
-        <p:txBody>
-          <a:bodyPr rtlCol="0" anchor="ctr"/>
-          <a:lstStyle/>
-          <a:p>
-            <a:pPr algn="ctr"/>
-          </a:p>
-        </p:txBody>
-      </p:sp>
-      <p:sp>
-        <p:nvSpPr>
-          <p:cNvPr id="14" name="Rounded Rectangle 13"/>
-          <p:cNvSpPr/>
-          <p:nvPr/>
-        </p:nvSpPr>
-        <p:spPr>
-          <a:xfrm>
-            <a:off x="457200" y="4206240"/>
-            <a:ext cx="11247120" cy="1645920"/>
-          </a:xfrm>
-          <a:prstGeom prst="roundRect">
-            <a:avLst>
-              <a:gd name="adj" fmla="val 12000"/>
-            </a:avLst>
-          </a:prstGeom>
-          <a:solidFill>
-            <a:srgbClr val="F1F5F9"/>
-          </a:solidFill>
-          <a:ln w="15875">
-            <a:solidFill>
-              <a:srgbClr val="94A3B8"/>
-            </a:solidFill>
-          </a:ln>
-        </p:spPr>
-        <p:style>
-          <a:lnRef idx="1">
-            <a:schemeClr val="accent1"/>
-          </a:lnRef>
-          <a:fillRef idx="3">
-            <a:schemeClr val="accent1"/>
-          </a:fillRef>
-          <a:effectRef idx="2">
-            <a:schemeClr val="accent1"/>
-          </a:effectRef>
-          <a:fontRef idx="minor">
-            <a:schemeClr val="lt1"/>
-          </a:fontRef>
-        </p:style>
-        <p:txBody>
-          <a:bodyPr rtlCol="0" anchor="ctr" wrap="square"/>
-          <a:lstStyle/>
-          <a:p>
-            <a:pPr algn="ctr"/>
-            <a:r>
-              <a:rPr sz="1400" b="1">
-                <a:solidFill>
-                  <a:srgbClr val="0B1F33"/>
-                </a:solidFill>
-                <a:latin typeface="Calibri"/>
-              </a:rPr>
-              <a:t>Deploy script ToolSet (aligned with POC structured surface)</a:t>
-            </a:r>
-          </a:p>
-          <a:p>
-            <a:pPr algn="ctr"/>
-            <a:r>
-              <a:rPr sz="1200" b="0">
-                <a:solidFill>
-                  <a:srgbClr val="334155"/>
-                </a:solidFill>
-                <a:latin typeface="Calibri"/>
-              </a:rPr>
-              <a:t>search_contracts · get_contract_profile · get_expiring_contracts · get_vendor_spend_summary · find_overlaps · explain_contract_risk · search_cloud_blob_contracts
-Current demos still use Flask + FastMCP locally; Foundry is optional hosting for the same tools.</a:t>
-            </a:r>
-          </a:p>
-        </p:txBody>
-      </p:sp>
-      <p:sp>
-        <p:nvSpPr>
-          <p:cNvPr id="15" name="TextBox 14"/>
+              <a:t>check_missing_contract_fields
+get_expiring_contracts
+get_vendor_spend_summary (ACV rollup only)
+search_cloud_blob_contracts (docs)
+fabric_health_check</a:t>
+            </a:r>
+          </a:p>
+        </p:txBody>
+      </p:sp>
+      <p:sp>
+        <p:nvSpPr>
+          <p:cNvPr id="7" name="TextBox 6"/>
           <p:cNvSpPr txBox="1"/>
           <p:nvPr/>
         </p:nvSpPr>

</xml_diff>

<commit_message>
docs: refresh architecture PDF/PPTX and Foundry guide for latest POC (#20)
Document persona memory, compare hard-stop, N-way compare, full MCP tool
inventory, and LinkSquares fixtures across the architecture generators and
optional Foundry deployment guide.

Co-authored-by: Cursor Agent <cursoragent@cursor.com>
Co-authored-by: booshank <booshank@users.noreply.github.com>
</commit_message>
<xml_diff>
--- a/docs/VAL_CoPilot_Architecture_and_Process_Flow.pptx
+++ b/docs/VAL_CoPilot_Architecture_and_Process_Flow.pptx
@@ -15,6 +15,7 @@
     <p:sldId id="263" r:id="rId14"/>
     <p:sldId id="264" r:id="rId15"/>
     <p:sldId id="265" r:id="rId16"/>
+    <p:sldId id="266" r:id="rId17"/>
   </p:sldIdLst>
   <p:sldSz cx="12191695" cy="6858000" type="screen4x3"/>
   <p:notesSz cx="6858000" cy="9144000"/>
@@ -3288,7 +3289,7 @@
                 </a:solidFill>
                 <a:latin typeface="Calibri"/>
               </a:rPr>
-              <a:t>Current: Streamlit → Flask /api/messages → LangChain or offline router → FastMCP tools → synthetic Gold data</a:t>
+              <a:t>Current: Streamlit → Flask /api/messages → LangChain or offline router → FastMCP → LinkSquares fixtures + persona memory</a:t>
             </a:r>
           </a:p>
           <a:p>
@@ -3300,7 +3301,7 @@
                 </a:solidFill>
                 <a:latin typeface="Calibri"/>
               </a:rPr>
-              <a:t>Future: Streamlit/Teams → Azure AI Foundry Agent → same MCP/API tools → LinkSquares later</a:t>
+              <a:t>Future: Streamlit/Teams → Azure AI Foundry Agent → same MCP/API tools → live LinkSquares later</a:t>
             </a:r>
           </a:p>
           <a:p>
@@ -3312,7 +3313,7 @@
                 </a:solidFill>
                 <a:latin typeface="Calibri"/>
               </a:rPr>
-              <a:t>Not Azure AI Foundry-first today · Invoice/actual-spend systems are out of scope</a:t>
+              <a:t>Compare hard-stop when IDs missing · Invoice/actual-spend OOS · Not Foundry-first today</a:t>
             </a:r>
           </a:p>
         </p:txBody>
@@ -3409,6 +3410,761 @@
                 </a:solidFill>
                 <a:latin typeface="Calibri"/>
               </a:rPr>
+              <a:t>8. Optional Future — Azure AI Foundry Deploy</a:t>
+            </a:r>
+          </a:p>
+        </p:txBody>
+      </p:sp>
+      <p:sp>
+        <p:nvSpPr>
+          <p:cNvPr id="4" name="TextBox 3"/>
+          <p:cNvSpPr txBox="1"/>
+          <p:nvPr/>
+        </p:nvSpPr>
+        <p:spPr>
+          <a:xfrm>
+            <a:off x="365760" y="822960"/>
+            <a:ext cx="11430000" cy="320040"/>
+          </a:xfrm>
+          <a:prstGeom prst="rect">
+            <a:avLst/>
+          </a:prstGeom>
+          <a:noFill/>
+        </p:spPr>
+        <p:txBody>
+          <a:bodyPr wrap="none">
+            <a:spAutoFit/>
+          </a:bodyPr>
+          <a:lstStyle/>
+          <a:p>
+            <a:r>
+              <a:rPr sz="1200" b="0">
+                <a:solidFill>
+                  <a:srgbClr val="334155"/>
+                </a:solidFill>
+                <a:latin typeface="Calibri"/>
+              </a:rPr>
+              <a:t>deploy_to_foundry.py is optional; current POC does not require Foundry</a:t>
+            </a:r>
+          </a:p>
+        </p:txBody>
+      </p:sp>
+      <p:sp>
+        <p:nvSpPr>
+          <p:cNvPr id="5" name="Rounded Rectangle 4"/>
+          <p:cNvSpPr/>
+          <p:nvPr/>
+        </p:nvSpPr>
+        <p:spPr>
+          <a:xfrm>
+            <a:off x="365760" y="1828800"/>
+            <a:ext cx="2103120" cy="2011680"/>
+          </a:xfrm>
+          <a:prstGeom prst="roundRect">
+            <a:avLst>
+              <a:gd name="adj" fmla="val 12000"/>
+            </a:avLst>
+          </a:prstGeom>
+          <a:solidFill>
+            <a:srgbClr val="D9F3F3"/>
+          </a:solidFill>
+          <a:ln w="15875">
+            <a:solidFill>
+              <a:srgbClr val="0E6B6B"/>
+            </a:solidFill>
+          </a:ln>
+        </p:spPr>
+        <p:style>
+          <a:lnRef idx="1">
+            <a:schemeClr val="accent1"/>
+          </a:lnRef>
+          <a:fillRef idx="3">
+            <a:schemeClr val="accent1"/>
+          </a:fillRef>
+          <a:effectRef idx="2">
+            <a:schemeClr val="accent1"/>
+          </a:effectRef>
+          <a:fontRef idx="minor">
+            <a:schemeClr val="lt1"/>
+          </a:fontRef>
+        </p:style>
+        <p:txBody>
+          <a:bodyPr rtlCol="0" anchor="ctr" wrap="square"/>
+          <a:lstStyle/>
+          <a:p>
+            <a:pPr algn="ctr"/>
+            <a:r>
+              <a:rPr sz="1300" b="1">
+                <a:solidFill>
+                  <a:srgbClr val="0B1F33"/>
+                </a:solidFill>
+                <a:latin typeface="Calibri"/>
+              </a:rPr>
+              <a:t>Root .env</a:t>
+            </a:r>
+          </a:p>
+          <a:p>
+            <a:pPr algn="ctr"/>
+            <a:r>
+              <a:rPr sz="1100" b="0">
+                <a:solidFill>
+                  <a:srgbClr val="334155"/>
+                </a:solidFill>
+                <a:latin typeface="Calibri"/>
+              </a:rPr>
+              <a:t>AZURE_FOUNDRY_ CONNECTION_STRING</a:t>
+            </a:r>
+          </a:p>
+        </p:txBody>
+      </p:sp>
+      <p:sp>
+        <p:nvSpPr>
+          <p:cNvPr id="6" name="Rounded Rectangle 5"/>
+          <p:cNvSpPr/>
+          <p:nvPr/>
+        </p:nvSpPr>
+        <p:spPr>
+          <a:xfrm>
+            <a:off x="2743200" y="1828800"/>
+            <a:ext cx="2103120" cy="2011680"/>
+          </a:xfrm>
+          <a:prstGeom prst="roundRect">
+            <a:avLst>
+              <a:gd name="adj" fmla="val 12000"/>
+            </a:avLst>
+          </a:prstGeom>
+          <a:solidFill>
+            <a:srgbClr val="FFEDD5"/>
+          </a:solidFill>
+          <a:ln w="15875">
+            <a:solidFill>
+              <a:srgbClr val="C2410C"/>
+            </a:solidFill>
+          </a:ln>
+        </p:spPr>
+        <p:style>
+          <a:lnRef idx="1">
+            <a:schemeClr val="accent1"/>
+          </a:lnRef>
+          <a:fillRef idx="3">
+            <a:schemeClr val="accent1"/>
+          </a:fillRef>
+          <a:effectRef idx="2">
+            <a:schemeClr val="accent1"/>
+          </a:effectRef>
+          <a:fontRef idx="minor">
+            <a:schemeClr val="lt1"/>
+          </a:fontRef>
+        </p:style>
+        <p:txBody>
+          <a:bodyPr rtlCol="0" anchor="ctr" wrap="square"/>
+          <a:lstStyle/>
+          <a:p>
+            <a:pPr algn="ctr"/>
+            <a:r>
+              <a:rPr sz="1300" b="1">
+                <a:solidFill>
+                  <a:srgbClr val="0B1F33"/>
+                </a:solidFill>
+                <a:latin typeface="Calibri"/>
+              </a:rPr>
+              <a:t>Entra auth</a:t>
+            </a:r>
+          </a:p>
+          <a:p>
+            <a:pPr algn="ctr"/>
+            <a:r>
+              <a:rPr sz="1100" b="0">
+                <a:solidFill>
+                  <a:srgbClr val="334155"/>
+                </a:solidFill>
+                <a:latin typeface="Calibri"/>
+              </a:rPr>
+              <a:t>DefaultAzureCredential</a:t>
+            </a:r>
+          </a:p>
+        </p:txBody>
+      </p:sp>
+      <p:sp>
+        <p:nvSpPr>
+          <p:cNvPr id="7" name="Rounded Rectangle 6"/>
+          <p:cNvSpPr/>
+          <p:nvPr/>
+        </p:nvSpPr>
+        <p:spPr>
+          <a:xfrm>
+            <a:off x="5120640" y="1828800"/>
+            <a:ext cx="2103120" cy="2011680"/>
+          </a:xfrm>
+          <a:prstGeom prst="roundRect">
+            <a:avLst>
+              <a:gd name="adj" fmla="val 12000"/>
+            </a:avLst>
+          </a:prstGeom>
+          <a:solidFill>
+            <a:srgbClr val="D1FAE5"/>
+          </a:solidFill>
+          <a:ln w="15875">
+            <a:solidFill>
+              <a:srgbClr val="047857"/>
+            </a:solidFill>
+          </a:ln>
+        </p:spPr>
+        <p:style>
+          <a:lnRef idx="1">
+            <a:schemeClr val="accent1"/>
+          </a:lnRef>
+          <a:fillRef idx="3">
+            <a:schemeClr val="accent1"/>
+          </a:fillRef>
+          <a:effectRef idx="2">
+            <a:schemeClr val="accent1"/>
+          </a:effectRef>
+          <a:fontRef idx="minor">
+            <a:schemeClr val="lt1"/>
+          </a:fontRef>
+        </p:style>
+        <p:txBody>
+          <a:bodyPr rtlCol="0" anchor="ctr" wrap="square"/>
+          <a:lstStyle/>
+          <a:p>
+            <a:pPr algn="ctr"/>
+            <a:r>
+              <a:rPr sz="1300" b="1">
+                <a:solidFill>
+                  <a:srgbClr val="0B1F33"/>
+                </a:solidFill>
+                <a:latin typeface="Calibri"/>
+              </a:rPr>
+              <a:t>Wrap tools</a:t>
+            </a:r>
+          </a:p>
+          <a:p>
+            <a:pPr algn="ctr"/>
+            <a:r>
+              <a:rPr sz="1100" b="0">
+                <a:solidFill>
+                  <a:srgbClr val="334155"/>
+                </a:solidFill>
+                <a:latin typeface="Calibri"/>
+              </a:rPr>
+              <a:t>FunctionTool ToolSet (7 MCP tools)</a:t>
+            </a:r>
+          </a:p>
+        </p:txBody>
+      </p:sp>
+      <p:sp>
+        <p:nvSpPr>
+          <p:cNvPr id="8" name="Rounded Rectangle 7"/>
+          <p:cNvSpPr/>
+          <p:nvPr/>
+        </p:nvSpPr>
+        <p:spPr>
+          <a:xfrm>
+            <a:off x="7498079" y="1828800"/>
+            <a:ext cx="2103120" cy="2011680"/>
+          </a:xfrm>
+          <a:prstGeom prst="roundRect">
+            <a:avLst>
+              <a:gd name="adj" fmla="val 12000"/>
+            </a:avLst>
+          </a:prstGeom>
+          <a:solidFill>
+            <a:srgbClr val="DBEAFE"/>
+          </a:solidFill>
+          <a:ln w="15875">
+            <a:solidFill>
+              <a:srgbClr val="1D4ED8"/>
+            </a:solidFill>
+          </a:ln>
+        </p:spPr>
+        <p:style>
+          <a:lnRef idx="1">
+            <a:schemeClr val="accent1"/>
+          </a:lnRef>
+          <a:fillRef idx="3">
+            <a:schemeClr val="accent1"/>
+          </a:fillRef>
+          <a:effectRef idx="2">
+            <a:schemeClr val="accent1"/>
+          </a:effectRef>
+          <a:fontRef idx="minor">
+            <a:schemeClr val="lt1"/>
+          </a:fontRef>
+        </p:style>
+        <p:txBody>
+          <a:bodyPr rtlCol="0" anchor="ctr" wrap="square"/>
+          <a:lstStyle/>
+          <a:p>
+            <a:pPr algn="ctr"/>
+            <a:r>
+              <a:rPr sz="1300" b="1">
+                <a:solidFill>
+                  <a:srgbClr val="0B1F33"/>
+                </a:solidFill>
+                <a:latin typeface="Calibri"/>
+              </a:rPr>
+              <a:t>create_agent</a:t>
+            </a:r>
+          </a:p>
+          <a:p>
+            <a:pPr algn="ctr"/>
+            <a:r>
+              <a:rPr sz="1100" b="0">
+                <a:solidFill>
+                  <a:srgbClr val="334155"/>
+                </a:solidFill>
+                <a:latin typeface="Calibri"/>
+              </a:rPr>
+              <a:t>SYSTEM_PROMPT hard-stop + OOS</a:t>
+            </a:r>
+          </a:p>
+        </p:txBody>
+      </p:sp>
+      <p:sp>
+        <p:nvSpPr>
+          <p:cNvPr id="9" name="Rounded Rectangle 8"/>
+          <p:cNvSpPr/>
+          <p:nvPr/>
+        </p:nvSpPr>
+        <p:spPr>
+          <a:xfrm>
+            <a:off x="9875520" y="1828800"/>
+            <a:ext cx="2103120" cy="2011680"/>
+          </a:xfrm>
+          <a:prstGeom prst="roundRect">
+            <a:avLst>
+              <a:gd name="adj" fmla="val 12000"/>
+            </a:avLst>
+          </a:prstGeom>
+          <a:solidFill>
+            <a:srgbClr val="EDE9FE"/>
+          </a:solidFill>
+          <a:ln w="15875">
+            <a:solidFill>
+              <a:srgbClr val="6D28D9"/>
+            </a:solidFill>
+          </a:ln>
+        </p:spPr>
+        <p:style>
+          <a:lnRef idx="1">
+            <a:schemeClr val="accent1"/>
+          </a:lnRef>
+          <a:fillRef idx="3">
+            <a:schemeClr val="accent1"/>
+          </a:fillRef>
+          <a:effectRef idx="2">
+            <a:schemeClr val="accent1"/>
+          </a:effectRef>
+          <a:fontRef idx="minor">
+            <a:schemeClr val="lt1"/>
+          </a:fontRef>
+        </p:style>
+        <p:txBody>
+          <a:bodyPr rtlCol="0" anchor="ctr" wrap="square"/>
+          <a:lstStyle/>
+          <a:p>
+            <a:pPr algn="ctr"/>
+            <a:r>
+              <a:rPr sz="1300" b="1">
+                <a:solidFill>
+                  <a:srgbClr val="0B1F33"/>
+                </a:solidFill>
+                <a:latin typeface="Calibri"/>
+              </a:rPr>
+              <a:t>Future host</a:t>
+            </a:r>
+          </a:p>
+          <a:p>
+            <a:pPr algn="ctr"/>
+            <a:r>
+              <a:rPr sz="1100" b="0">
+                <a:solidFill>
+                  <a:srgbClr val="334155"/>
+                </a:solidFill>
+                <a:latin typeface="Calibri"/>
+              </a:rPr>
+              <a:t>Teams / Foundry UI extend ToolSet</a:t>
+            </a:r>
+          </a:p>
+        </p:txBody>
+      </p:sp>
+      <p:sp>
+        <p:nvSpPr>
+          <p:cNvPr id="10" name="Right Arrow 9"/>
+          <p:cNvSpPr/>
+          <p:nvPr/>
+        </p:nvSpPr>
+        <p:spPr>
+          <a:xfrm>
+            <a:off x="2514600" y="2743200"/>
+            <a:ext cx="201168" cy="182880"/>
+          </a:xfrm>
+          <a:prstGeom prst="rightArrow">
+            <a:avLst/>
+          </a:prstGeom>
+          <a:solidFill>
+            <a:srgbClr val="94A3B8"/>
+          </a:solidFill>
+          <a:ln>
+            <a:solidFill>
+              <a:srgbClr val="94A3B8"/>
+            </a:solidFill>
+          </a:ln>
+        </p:spPr>
+        <p:style>
+          <a:lnRef idx="1">
+            <a:schemeClr val="accent1"/>
+          </a:lnRef>
+          <a:fillRef idx="3">
+            <a:schemeClr val="accent1"/>
+          </a:fillRef>
+          <a:effectRef idx="2">
+            <a:schemeClr val="accent1"/>
+          </a:effectRef>
+          <a:fontRef idx="minor">
+            <a:schemeClr val="lt1"/>
+          </a:fontRef>
+        </p:style>
+        <p:txBody>
+          <a:bodyPr rtlCol="0" anchor="ctr"/>
+          <a:lstStyle/>
+          <a:p>
+            <a:pPr algn="ctr"/>
+          </a:p>
+        </p:txBody>
+      </p:sp>
+      <p:sp>
+        <p:nvSpPr>
+          <p:cNvPr id="11" name="Right Arrow 10"/>
+          <p:cNvSpPr/>
+          <p:nvPr/>
+        </p:nvSpPr>
+        <p:spPr>
+          <a:xfrm>
+            <a:off x="4892040" y="2743200"/>
+            <a:ext cx="201168" cy="182880"/>
+          </a:xfrm>
+          <a:prstGeom prst="rightArrow">
+            <a:avLst/>
+          </a:prstGeom>
+          <a:solidFill>
+            <a:srgbClr val="94A3B8"/>
+          </a:solidFill>
+          <a:ln>
+            <a:solidFill>
+              <a:srgbClr val="94A3B8"/>
+            </a:solidFill>
+          </a:ln>
+        </p:spPr>
+        <p:style>
+          <a:lnRef idx="1">
+            <a:schemeClr val="accent1"/>
+          </a:lnRef>
+          <a:fillRef idx="3">
+            <a:schemeClr val="accent1"/>
+          </a:fillRef>
+          <a:effectRef idx="2">
+            <a:schemeClr val="accent1"/>
+          </a:effectRef>
+          <a:fontRef idx="minor">
+            <a:schemeClr val="lt1"/>
+          </a:fontRef>
+        </p:style>
+        <p:txBody>
+          <a:bodyPr rtlCol="0" anchor="ctr"/>
+          <a:lstStyle/>
+          <a:p>
+            <a:pPr algn="ctr"/>
+          </a:p>
+        </p:txBody>
+      </p:sp>
+      <p:sp>
+        <p:nvSpPr>
+          <p:cNvPr id="12" name="Right Arrow 11"/>
+          <p:cNvSpPr/>
+          <p:nvPr/>
+        </p:nvSpPr>
+        <p:spPr>
+          <a:xfrm>
+            <a:off x="7269480" y="2743200"/>
+            <a:ext cx="201168" cy="182880"/>
+          </a:xfrm>
+          <a:prstGeom prst="rightArrow">
+            <a:avLst/>
+          </a:prstGeom>
+          <a:solidFill>
+            <a:srgbClr val="94A3B8"/>
+          </a:solidFill>
+          <a:ln>
+            <a:solidFill>
+              <a:srgbClr val="94A3B8"/>
+            </a:solidFill>
+          </a:ln>
+        </p:spPr>
+        <p:style>
+          <a:lnRef idx="1">
+            <a:schemeClr val="accent1"/>
+          </a:lnRef>
+          <a:fillRef idx="3">
+            <a:schemeClr val="accent1"/>
+          </a:fillRef>
+          <a:effectRef idx="2">
+            <a:schemeClr val="accent1"/>
+          </a:effectRef>
+          <a:fontRef idx="minor">
+            <a:schemeClr val="lt1"/>
+          </a:fontRef>
+        </p:style>
+        <p:txBody>
+          <a:bodyPr rtlCol="0" anchor="ctr"/>
+          <a:lstStyle/>
+          <a:p>
+            <a:pPr algn="ctr"/>
+          </a:p>
+        </p:txBody>
+      </p:sp>
+      <p:sp>
+        <p:nvSpPr>
+          <p:cNvPr id="13" name="Right Arrow 12"/>
+          <p:cNvSpPr/>
+          <p:nvPr/>
+        </p:nvSpPr>
+        <p:spPr>
+          <a:xfrm>
+            <a:off x="9646920" y="2743200"/>
+            <a:ext cx="201168" cy="182880"/>
+          </a:xfrm>
+          <a:prstGeom prst="rightArrow">
+            <a:avLst/>
+          </a:prstGeom>
+          <a:solidFill>
+            <a:srgbClr val="94A3B8"/>
+          </a:solidFill>
+          <a:ln>
+            <a:solidFill>
+              <a:srgbClr val="94A3B8"/>
+            </a:solidFill>
+          </a:ln>
+        </p:spPr>
+        <p:style>
+          <a:lnRef idx="1">
+            <a:schemeClr val="accent1"/>
+          </a:lnRef>
+          <a:fillRef idx="3">
+            <a:schemeClr val="accent1"/>
+          </a:fillRef>
+          <a:effectRef idx="2">
+            <a:schemeClr val="accent1"/>
+          </a:effectRef>
+          <a:fontRef idx="minor">
+            <a:schemeClr val="lt1"/>
+          </a:fontRef>
+        </p:style>
+        <p:txBody>
+          <a:bodyPr rtlCol="0" anchor="ctr"/>
+          <a:lstStyle/>
+          <a:p>
+            <a:pPr algn="ctr"/>
+          </a:p>
+        </p:txBody>
+      </p:sp>
+      <p:sp>
+        <p:nvSpPr>
+          <p:cNvPr id="14" name="Rounded Rectangle 13"/>
+          <p:cNvSpPr/>
+          <p:nvPr/>
+        </p:nvSpPr>
+        <p:spPr>
+          <a:xfrm>
+            <a:off x="457200" y="4206240"/>
+            <a:ext cx="11247120" cy="1645920"/>
+          </a:xfrm>
+          <a:prstGeom prst="roundRect">
+            <a:avLst>
+              <a:gd name="adj" fmla="val 12000"/>
+            </a:avLst>
+          </a:prstGeom>
+          <a:solidFill>
+            <a:srgbClr val="F1F5F9"/>
+          </a:solidFill>
+          <a:ln w="15875">
+            <a:solidFill>
+              <a:srgbClr val="94A3B8"/>
+            </a:solidFill>
+          </a:ln>
+        </p:spPr>
+        <p:style>
+          <a:lnRef idx="1">
+            <a:schemeClr val="accent1"/>
+          </a:lnRef>
+          <a:fillRef idx="3">
+            <a:schemeClr val="accent1"/>
+          </a:fillRef>
+          <a:effectRef idx="2">
+            <a:schemeClr val="accent1"/>
+          </a:effectRef>
+          <a:fontRef idx="minor">
+            <a:schemeClr val="lt1"/>
+          </a:fontRef>
+        </p:style>
+        <p:txBody>
+          <a:bodyPr rtlCol="0" anchor="ctr" wrap="square"/>
+          <a:lstStyle/>
+          <a:p>
+            <a:pPr algn="ctr"/>
+            <a:r>
+              <a:rPr sz="1300" b="1">
+                <a:solidFill>
+                  <a:srgbClr val="0B1F33"/>
+                </a:solidFill>
+                <a:latin typeface="Calibri"/>
+              </a:rPr>
+              <a:t>Deploy script ToolSet today (7 tools) — extend next to full MCP inventory</a:t>
+            </a:r>
+          </a:p>
+          <a:p>
+            <a:pPr algn="ctr"/>
+            <a:r>
+              <a:rPr sz="1100" b="0">
+                <a:solidFill>
+                  <a:srgbClr val="334155"/>
+                </a:solidFill>
+                <a:latin typeface="Calibri"/>
+              </a:rPr>
+              <a:t>search_contracts · get_contract_profile · get_expiring_contracts · get_vendor_spend_summary · find_overlaps · explain_contract_risk · search_cloud_blob_contracts
+Local FastMCP also has compare_contracts + check_missing_contract_fields. SYSTEM_PROMPT encodes compare hard-stop + persona-memory guidance.</a:t>
+            </a:r>
+          </a:p>
+        </p:txBody>
+      </p:sp>
+      <p:sp>
+        <p:nvSpPr>
+          <p:cNvPr id="15" name="TextBox 14"/>
+          <p:cNvSpPr txBox="1"/>
+          <p:nvPr/>
+        </p:nvSpPr>
+        <p:spPr>
+          <a:xfrm>
+            <a:off x="365760" y="6492240"/>
+            <a:ext cx="11430000" cy="274320"/>
+          </a:xfrm>
+          <a:prstGeom prst="rect">
+            <a:avLst/>
+          </a:prstGeom>
+          <a:noFill/>
+        </p:spPr>
+        <p:txBody>
+          <a:bodyPr wrap="none">
+            <a:spAutoFit/>
+          </a:bodyPr>
+          <a:lstStyle/>
+          <a:p>
+            <a:pPr algn="ctr"/>
+            <a:r>
+              <a:rPr sz="900" b="0">
+                <a:solidFill>
+                  <a:srgbClr val="94A3B8"/>
+                </a:solidFill>
+                <a:latin typeface="Calibri"/>
+              </a:rPr>
+              <a:t>Synthetic Contract Intelligence Tool-Layer POC · Slide 10</a:t>
+            </a:r>
+          </a:p>
+        </p:txBody>
+      </p:sp>
+    </p:spTree>
+  </p:cSld>
+  <p:clrMapOvr>
+    <a:masterClrMapping/>
+  </p:clrMapOvr>
+</p:sld>
+</file>
+
+<file path=ppt/slides/slide11.xml><?xml version="1.0" encoding="utf-8"?>
+<p:sld xmlns:a="http://schemas.openxmlformats.org/drawingml/2006/main" xmlns:p="http://schemas.openxmlformats.org/presentationml/2006/main" xmlns:r="http://schemas.openxmlformats.org/officeDocument/2006/relationships">
+  <p:cSld>
+    <p:spTree>
+      <p:nvGrpSpPr>
+        <p:cNvPr id="1" name=""/>
+        <p:cNvGrpSpPr/>
+        <p:nvPr/>
+      </p:nvGrpSpPr>
+      <p:grpSpPr/>
+      <p:sp>
+        <p:nvSpPr>
+          <p:cNvPr id="2" name="Rectangle 1"/>
+          <p:cNvSpPr/>
+          <p:nvPr/>
+        </p:nvSpPr>
+        <p:spPr>
+          <a:xfrm>
+            <a:off x="0" y="0"/>
+            <a:ext cx="12191695" cy="777240"/>
+          </a:xfrm>
+          <a:prstGeom prst="rect">
+            <a:avLst/>
+          </a:prstGeom>
+          <a:solidFill>
+            <a:srgbClr val="0B1F33"/>
+          </a:solidFill>
+          <a:ln>
+            <a:solidFill>
+              <a:srgbClr val="0B1F33"/>
+            </a:solidFill>
+          </a:ln>
+        </p:spPr>
+        <p:style>
+          <a:lnRef idx="1">
+            <a:schemeClr val="accent1"/>
+          </a:lnRef>
+          <a:fillRef idx="3">
+            <a:schemeClr val="accent1"/>
+          </a:fillRef>
+          <a:effectRef idx="2">
+            <a:schemeClr val="accent1"/>
+          </a:effectRef>
+          <a:fontRef idx="minor">
+            <a:schemeClr val="lt1"/>
+          </a:fontRef>
+        </p:style>
+        <p:txBody>
+          <a:bodyPr rtlCol="0" anchor="ctr"/>
+          <a:lstStyle/>
+          <a:p>
+            <a:pPr algn="ctr"/>
+          </a:p>
+        </p:txBody>
+      </p:sp>
+      <p:sp>
+        <p:nvSpPr>
+          <p:cNvPr id="3" name="TextBox 2"/>
+          <p:cNvSpPr txBox="1"/>
+          <p:nvPr/>
+        </p:nvSpPr>
+        <p:spPr>
+          <a:xfrm>
+            <a:off x="365760" y="164592"/>
+            <a:ext cx="11430000" cy="502920"/>
+          </a:xfrm>
+          <a:prstGeom prst="rect">
+            <a:avLst/>
+          </a:prstGeom>
+          <a:noFill/>
+        </p:spPr>
+        <p:txBody>
+          <a:bodyPr wrap="none">
+            <a:spAutoFit/>
+          </a:bodyPr>
+          <a:lstStyle/>
+          <a:p>
+            <a:r>
+              <a:rPr sz="2000" b="1">
+                <a:solidFill>
+                  <a:srgbClr val="FFFFFF"/>
+                </a:solidFill>
+                <a:latin typeface="Calibri"/>
+              </a:rPr>
               <a:t>9. Demo-Ready Slice Summary</a:t>
             </a:r>
           </a:p>
@@ -3555,7 +4311,7 @@
                 </a:solidFill>
                 <a:latin typeface="Calibri"/>
               </a:rPr>
-              <a:t>Invoice/AP/JDE/NetSuite asks → exact OOS refusal; ACV never labeled as invoices</a:t>
+              <a:t>Invoice OOS + compare hard-stop (exact messages; no default CON-* pair)</a:t>
             </a:r>
           </a:p>
         </p:txBody>
@@ -3667,7 +4423,7 @@
                 </a:solidFill>
                 <a:latin typeface="Calibri"/>
               </a:rPr>
-              <a:t>search / profile / overlaps / risk via ContractRepository</a:t>
+              <a:t>search / profile / N-way compare / overlaps / risk via ContractRepository</a:t>
             </a:r>
           </a:p>
         </p:txBody>
@@ -3723,7 +4479,7 @@
                 </a:solidFill>
                 <a:latin typeface="Calibri"/>
               </a:rPr>
-              <a:t>Deterministic demo</a:t>
+              <a:t>Persona memory</a:t>
             </a:r>
           </a:p>
         </p:txBody>
@@ -3779,7 +4535,7 @@
                 </a:solidFill>
                 <a:latin typeface="Calibri"/>
               </a:rPr>
-              <a:t>LinkSquares CON-* fixtures + docs/demo_script.md</a:t>
+              <a:t>SQLite save / pin / filter / recall previous searches per persona</a:t>
             </a:r>
           </a:p>
         </p:txBody>
@@ -3835,7 +4591,7 @@
                 </a:solidFill>
                 <a:latin typeface="Calibri"/>
               </a:rPr>
-              <a:t>Replaceable data</a:t>
+              <a:t>LinkSquares fixtures</a:t>
             </a:r>
           </a:p>
         </p:txBody>
@@ -3891,7 +4647,7 @@
                 </a:solidFill>
                 <a:latin typeface="Calibri"/>
               </a:rPr>
-              <a:t>ContractRepository ready for LinkSquares later</a:t>
+              <a:t>CON-* offline data + docs/demo_script.md; live CLM later</a:t>
             </a:r>
           </a:p>
         </p:txBody>
@@ -4003,7 +4759,7 @@
                 </a:solidFill>
                 <a:latin typeface="Calibri"/>
               </a:rPr>
-              <a:t>Current runtime is Flask+LangChain/offline router, not Foundry-first</a:t>
+              <a:t>Flask + offline router today; Foundry ToolSet wraps 7 tools</a:t>
             </a:r>
           </a:p>
         </p:txBody>
@@ -4038,7 +4794,7 @@
                 </a:solidFill>
                 <a:latin typeface="Calibri"/>
               </a:rPr>
-              <a:t>Synthetic Contract Intelligence Tool-Layer POC · Slide 10</a:t>
+              <a:t>Synthetic Contract Intelligence Tool-Layer POC · Slide 11</a:t>
             </a:r>
           </a:p>
         </p:txBody>
@@ -4237,14 +4993,14 @@
                 </a:solidFill>
                 <a:latin typeface="Calibri"/>
               </a:rPr>
-              <a:t>Streamlit UI
+              <a:t>Streamlit UI + Saved searches
 → Flask POST /api/messages
 → LangChain AgentExecutor
    or offline cognitive router
 → FastMCP tool server
 → ContractRepository
-→ Synthetic Gold fixtures
-   (Fabric SQL / AI Search later)</a:t>
+→ LinkSquares offline fixtures
+→ SQLite persona memory</a:t>
             </a:r>
           </a:p>
         </p:txBody>
@@ -4484,7 +5240,7 @@
                 </a:solidFill>
                 <a:latin typeface="Calibri"/>
               </a:rPr>
-              <a:t>Three layers + replaceable ContractRepository + invoice OOS guardrail</a:t>
+              <a:t>Four layers + persona memory + replaceable ContractRepository</a:t>
             </a:r>
           </a:p>
         </p:txBody>
@@ -4497,8 +5253,8 @@
         </p:nvSpPr>
         <p:spPr>
           <a:xfrm>
-            <a:off x="320040" y="1143000"/>
-            <a:ext cx="11521440" cy="1051560"/>
+            <a:off x="320040" y="1097280"/>
+            <a:ext cx="11521440" cy="960120"/>
           </a:xfrm>
           <a:prstGeom prst="roundRect">
             <a:avLst>
@@ -4534,7 +5290,7 @@
           <a:p>
             <a:pPr algn="ctr"/>
             <a:r>
-              <a:rPr sz="1400" b="1">
+              <a:rPr sz="1300" b="1">
                 <a:solidFill>
                   <a:srgbClr val="0B1F33"/>
                 </a:solidFill>
@@ -4546,13 +5302,13 @@
           <a:p>
             <a:pPr algn="ctr"/>
             <a:r>
-              <a:rPr sz="1200" b="0">
+              <a:rPr sz="1100" b="0">
                 <a:solidFill>
                   <a:srgbClr val="334155"/>
                 </a:solidFill>
                 <a:latin typeface="Calibri"/>
               </a:rPr>
-              <a:t>Streamlit Bot Framework harness → COPILOT_MESSAGES_URL</a:t>
+              <a:t>Streamlit chat · persona picker · Saved searches sidebar → COPILOT_MESSAGES_URL</a:t>
             </a:r>
           </a:p>
         </p:txBody>
@@ -4565,8 +5321,8 @@
         </p:nvSpPr>
         <p:spPr>
           <a:xfrm>
-            <a:off x="320040" y="2331720"/>
-            <a:ext cx="11521440" cy="1554480"/>
+            <a:off x="320040" y="2148840"/>
+            <a:ext cx="11521440" cy="1143000"/>
           </a:xfrm>
           <a:prstGeom prst="roundRect">
             <a:avLst>
@@ -4602,25 +5358,25 @@
           <a:p>
             <a:pPr algn="ctr"/>
             <a:r>
-              <a:rPr sz="1400" b="1">
+              <a:rPr sz="1300" b="1">
                 <a:solidFill>
                   <a:srgbClr val="0B1F33"/>
                 </a:solidFill>
                 <a:latin typeface="Calibri"/>
               </a:rPr>
-              <a:t>Layer 2 — Cognitive Routing (copilot_agent)</a:t>
-            </a:r>
-          </a:p>
-          <a:p>
-            <a:pPr algn="ctr"/>
-            <a:r>
-              <a:rPr sz="1200" b="0">
+              <a:t>Layer 2 — Cognitive Routing + Memory (copilot_agent + memory/)</a:t>
+            </a:r>
+          </a:p>
+          <a:p>
+            <a:pPr algn="ctr"/>
+            <a:r>
+              <a:rPr sz="1100" b="0">
                 <a:solidFill>
                   <a:srgbClr val="334155"/>
                 </a:solidFill>
                 <a:latin typeface="Calibri"/>
               </a:rPr>
-              <a:t>Flask /api/messages · LangChain AzureChatOpenAI / offline_router · SYSTEM_PROMPT · invoice OOS hard-match before tools</a:t>
+              <a:t>Flask /api/messages · /api/memory/* · LangChain / offline_router · SYSTEM_PROMPT · invoice OOS · compare hard-stop · SQLite persona store</a:t>
             </a:r>
           </a:p>
         </p:txBody>
@@ -4633,8 +5389,8 @@
         </p:nvSpPr>
         <p:spPr>
           <a:xfrm>
-            <a:off x="320040" y="4023360"/>
-            <a:ext cx="11521440" cy="2103120"/>
+            <a:off x="320040" y="3429000"/>
+            <a:ext cx="11521440" cy="1417320"/>
           </a:xfrm>
           <a:prstGeom prst="roundRect">
             <a:avLst>
@@ -4670,7 +5426,7 @@
           <a:p>
             <a:pPr algn="ctr"/>
             <a:r>
-              <a:rPr sz="1400" b="1">
+              <a:rPr sz="1300" b="1">
                 <a:solidFill>
                   <a:srgbClr val="0B1F33"/>
                 </a:solidFill>
@@ -4688,15 +5444,83 @@
                 </a:solidFill>
                 <a:latin typeface="Calibri"/>
               </a:rPr>
-              <a:t>ContractRepository → FabricContractRepository (synthetic Gold today)
-Tools: search_contracts · get_contract_profile · find_overlaps · explain_contract_risk · compare_contracts · check_missing_contract_fields · get_expiring_contracts · get_vendor_spend_summary · search_cloud_blob_contracts</a:t>
-            </a:r>
-          </a:p>
-        </p:txBody>
-      </p:sp>
-      <p:sp>
-        <p:nvSpPr>
-          <p:cNvPr id="8" name="TextBox 7"/>
+              <a:t>ContractRepository → analytics / risk helpers
+Tools: search · profile · compare (N-way) · missing-fields · expiring · spend rollup · overlaps · risk · blob search · health</a:t>
+            </a:r>
+          </a:p>
+        </p:txBody>
+      </p:sp>
+      <p:sp>
+        <p:nvSpPr>
+          <p:cNvPr id="8" name="Rounded Rectangle 7"/>
+          <p:cNvSpPr/>
+          <p:nvPr/>
+        </p:nvSpPr>
+        <p:spPr>
+          <a:xfrm>
+            <a:off x="320040" y="4983480"/>
+            <a:ext cx="11521440" cy="1051560"/>
+          </a:xfrm>
+          <a:prstGeom prst="roundRect">
+            <a:avLst>
+              <a:gd name="adj" fmla="val 12000"/>
+            </a:avLst>
+          </a:prstGeom>
+          <a:solidFill>
+            <a:srgbClr val="FEF3C7"/>
+          </a:solidFill>
+          <a:ln w="15875">
+            <a:solidFill>
+              <a:srgbClr val="B45309"/>
+            </a:solidFill>
+          </a:ln>
+        </p:spPr>
+        <p:style>
+          <a:lnRef idx="1">
+            <a:schemeClr val="accent1"/>
+          </a:lnRef>
+          <a:fillRef idx="3">
+            <a:schemeClr val="accent1"/>
+          </a:fillRef>
+          <a:effectRef idx="2">
+            <a:schemeClr val="accent1"/>
+          </a:effectRef>
+          <a:fontRef idx="minor">
+            <a:schemeClr val="lt1"/>
+          </a:fontRef>
+        </p:style>
+        <p:txBody>
+          <a:bodyPr rtlCol="0" anchor="ctr" wrap="square"/>
+          <a:lstStyle/>
+          <a:p>
+            <a:pPr algn="ctr"/>
+            <a:r>
+              <a:rPr sz="1300" b="1">
+                <a:solidFill>
+                  <a:srgbClr val="0B1F33"/>
+                </a:solidFill>
+                <a:latin typeface="Calibri"/>
+              </a:rPr>
+              <a:t>Layer 4 — Synthetic Gold (LinkSquares fixtures)</a:t>
+            </a:r>
+          </a:p>
+          <a:p>
+            <a:pPr algn="ctr"/>
+            <a:r>
+              <a:rPr sz="1100" b="0">
+                <a:solidFill>
+                  <a:srgbClr val="334155"/>
+                </a:solidFill>
+                <a:latin typeface="Calibri"/>
+              </a:rPr>
+              <a:t>LinSquare_Contracts_100_Updated_30bb.json + agreement_9a06.json · future live Fabric / LinkSquares</a:t>
+            </a:r>
+          </a:p>
+        </p:txBody>
+      </p:sp>
+      <p:sp>
+        <p:nvSpPr>
+          <p:cNvPr id="9" name="TextBox 8"/>
           <p:cNvSpPr txBox="1"/>
           <p:nvPr/>
         </p:nvSpPr>
@@ -4868,8 +5692,8 @@
         </p:nvSpPr>
         <p:spPr>
           <a:xfrm>
-            <a:off x="320040" y="1554480"/>
-            <a:ext cx="2148840" cy="1280160"/>
+            <a:off x="320040" y="1417320"/>
+            <a:ext cx="2148840" cy="1143000"/>
           </a:xfrm>
           <a:prstGeom prst="roundRect">
             <a:avLst>
@@ -4905,7 +5729,7 @@
           <a:p>
             <a:pPr algn="ctr"/>
             <a:r>
-              <a:rPr sz="1300" b="1">
+              <a:rPr sz="1200" b="1">
                 <a:solidFill>
                   <a:srgbClr val="0B1F33"/>
                 </a:solidFill>
@@ -4917,7 +5741,7 @@
           <a:p>
             <a:pPr algn="ctr"/>
             <a:r>
-              <a:rPr sz="1100" b="0">
+              <a:rPr sz="1000" b="0">
                 <a:solidFill>
                   <a:srgbClr val="334155"/>
                 </a:solidFill>
@@ -4936,8 +5760,8 @@
         </p:nvSpPr>
         <p:spPr>
           <a:xfrm>
-            <a:off x="2651760" y="1554480"/>
-            <a:ext cx="2148840" cy="1280160"/>
+            <a:off x="2651760" y="1417320"/>
+            <a:ext cx="2148840" cy="1143000"/>
           </a:xfrm>
           <a:prstGeom prst="roundRect">
             <a:avLst>
@@ -4973,25 +5797,25 @@
           <a:p>
             <a:pPr algn="ctr"/>
             <a:r>
-              <a:rPr sz="1300" b="1">
+              <a:rPr sz="1200" b="1">
                 <a:solidFill>
                   <a:srgbClr val="0B1F33"/>
                 </a:solidFill>
                 <a:latin typeface="Calibri"/>
               </a:rPr>
-              <a:t>2. Invoice OOS?</a:t>
-            </a:r>
-          </a:p>
-          <a:p>
-            <a:pPr algn="ctr"/>
-            <a:r>
-              <a:rPr sz="1100" b="0">
+              <a:t>2. Guardrails</a:t>
+            </a:r>
+          </a:p>
+          <a:p>
+            <a:pPr algn="ctr"/>
+            <a:r>
+              <a:rPr sz="1000" b="0">
                 <a:solidFill>
                   <a:srgbClr val="334155"/>
                 </a:solidFill>
                 <a:latin typeface="Calibri"/>
               </a:rPr>
-              <a:t>Hard refuse if invoice/AP</a:t>
+              <a:t>OOS / hard-stop / memory</a:t>
             </a:r>
           </a:p>
         </p:txBody>
@@ -5004,8 +5828,8 @@
         </p:nvSpPr>
         <p:spPr>
           <a:xfrm>
-            <a:off x="4983480" y="1554480"/>
-            <a:ext cx="2148840" cy="1280160"/>
+            <a:off x="4983480" y="1417320"/>
+            <a:ext cx="2148840" cy="1143000"/>
           </a:xfrm>
           <a:prstGeom prst="roundRect">
             <a:avLst>
@@ -5041,7 +5865,7 @@
           <a:p>
             <a:pPr algn="ctr"/>
             <a:r>
-              <a:rPr sz="1300" b="1">
+              <a:rPr sz="1200" b="1">
                 <a:solidFill>
                   <a:srgbClr val="0B1F33"/>
                 </a:solidFill>
@@ -5053,13 +5877,13 @@
           <a:p>
             <a:pPr algn="ctr"/>
             <a:r>
-              <a:rPr sz="1100" b="0">
+              <a:rPr sz="1000" b="0">
                 <a:solidFill>
                   <a:srgbClr val="334155"/>
                 </a:solidFill>
                 <a:latin typeface="Calibri"/>
               </a:rPr>
-              <a:t>offline_router / LLM tools</a:t>
+              <a:t>offline_router / LLM</a:t>
             </a:r>
           </a:p>
         </p:txBody>
@@ -5072,8 +5896,8 @@
         </p:nvSpPr>
         <p:spPr>
           <a:xfrm>
-            <a:off x="7315200" y="1554480"/>
-            <a:ext cx="2148840" cy="1280160"/>
+            <a:off x="7315200" y="1417320"/>
+            <a:ext cx="2148840" cy="1143000"/>
           </a:xfrm>
           <a:prstGeom prst="roundRect">
             <a:avLst>
@@ -5109,7 +5933,7 @@
           <a:p>
             <a:pPr algn="ctr"/>
             <a:r>
-              <a:rPr sz="1300" b="1">
+              <a:rPr sz="1200" b="1">
                 <a:solidFill>
                   <a:srgbClr val="0B1F33"/>
                 </a:solidFill>
@@ -5121,7 +5945,7 @@
           <a:p>
             <a:pPr algn="ctr"/>
             <a:r>
-              <a:rPr sz="1100" b="0">
+              <a:rPr sz="1000" b="0">
                 <a:solidFill>
                   <a:srgbClr val="334155"/>
                 </a:solidFill>
@@ -5140,8 +5964,8 @@
         </p:nvSpPr>
         <p:spPr>
           <a:xfrm>
-            <a:off x="9646920" y="1554480"/>
-            <a:ext cx="2148840" cy="1280160"/>
+            <a:off x="9646920" y="1417320"/>
+            <a:ext cx="2148840" cy="1143000"/>
           </a:xfrm>
           <a:prstGeom prst="roundRect">
             <a:avLst>
@@ -5177,25 +6001,25 @@
           <a:p>
             <a:pPr algn="ctr"/>
             <a:r>
-              <a:rPr sz="1300" b="1">
+              <a:rPr sz="1200" b="1">
                 <a:solidFill>
                   <a:srgbClr val="0B1F33"/>
                 </a:solidFill>
                 <a:latin typeface="Calibri"/>
               </a:rPr>
-              <a:t>5. Markdown reply</a:t>
-            </a:r>
-          </a:p>
-          <a:p>
-            <a:pPr algn="ctr"/>
-            <a:r>
-              <a:rPr sz="1100" b="0">
+              <a:t>5. Reply + save</a:t>
+            </a:r>
+          </a:p>
+          <a:p>
+            <a:pPr algn="ctr"/>
+            <a:r>
+              <a:rPr sz="1000" b="0">
                 <a:solidFill>
                   <a:srgbClr val="334155"/>
                 </a:solidFill>
                 <a:latin typeface="Calibri"/>
               </a:rPr>
-              <a:t>Grounded sections</a:t>
+              <a:t>Markdown · auto-save</a:t>
             </a:r>
           </a:p>
         </p:txBody>
@@ -5208,7 +6032,7 @@
         </p:nvSpPr>
         <p:spPr>
           <a:xfrm>
-            <a:off x="2331720" y="2103120"/>
+            <a:off x="2331720" y="1874519"/>
             <a:ext cx="274320" cy="164592"/>
           </a:xfrm>
           <a:prstGeom prst="rightArrow">
@@ -5253,7 +6077,7 @@
         </p:nvSpPr>
         <p:spPr>
           <a:xfrm>
-            <a:off x="4663440" y="2103120"/>
+            <a:off x="4663440" y="1874519"/>
             <a:ext cx="274320" cy="164592"/>
           </a:xfrm>
           <a:prstGeom prst="rightArrow">
@@ -5298,7 +6122,7 @@
         </p:nvSpPr>
         <p:spPr>
           <a:xfrm>
-            <a:off x="6995160" y="2103120"/>
+            <a:off x="6995160" y="1874519"/>
             <a:ext cx="274320" cy="164592"/>
           </a:xfrm>
           <a:prstGeom prst="rightArrow">
@@ -5343,7 +6167,7 @@
         </p:nvSpPr>
         <p:spPr>
           <a:xfrm>
-            <a:off x="9326880" y="2103120"/>
+            <a:off x="9326880" y="1874519"/>
             <a:ext cx="274320" cy="164592"/>
           </a:xfrm>
           <a:prstGeom prst="rightArrow">
@@ -5388,8 +6212,8 @@
         </p:nvSpPr>
         <p:spPr>
           <a:xfrm>
-            <a:off x="365760" y="3200400"/>
-            <a:ext cx="11430000" cy="2834640"/>
+            <a:off x="365760" y="2788920"/>
+            <a:ext cx="11430000" cy="3246120"/>
           </a:xfrm>
           <a:prstGeom prst="roundRect">
             <a:avLst>
@@ -5425,19 +6249,19 @@
           <a:p>
             <a:pPr algn="ctr"/>
             <a:r>
-              <a:rPr sz="1400" b="1">
+              <a:rPr sz="1300" b="1">
                 <a:solidFill>
                   <a:srgbClr val="0B1F33"/>
                 </a:solidFill>
                 <a:latin typeface="Calibri"/>
               </a:rPr>
-              <a:t>Intent → primary tool</a:t>
-            </a:r>
-          </a:p>
-          <a:p>
-            <a:pPr algn="ctr"/>
-            <a:r>
-              <a:rPr sz="1200" b="0">
+              <a:t>Intent → primary tool / outcome</a:t>
+            </a:r>
+          </a:p>
+          <a:p>
+            <a:pPr algn="ctr"/>
+            <a:r>
+              <a:rPr sz="1100" b="0">
                 <a:solidFill>
                   <a:srgbClr val="334155"/>
                 </a:solidFill>
@@ -5447,9 +6271,10 @@
 Details for CON-0002 → get_contract_profile
 Overlapping contracts → find_overlaps
 Unusual payment / high rates → explain_contract_risk
-Compare CON-0001 vs CON-0002 → compare_contracts
+Compare CON-0001 vs CON-0002 → compare_contracts (N-way any IDs)
+Compare unknown vendor/ID → hard-stop message only (no table / no recommendation)
 Need action next 90 days → get_expiring_contracts
-Missing renewal info → check_missing_contract_fields
+Previous / saved searches → persona memory recall (/api/memory/*)
 Invoice spend also? → exact OOS refusal (no tools)</a:t>
             </a:r>
           </a:p>
@@ -5582,7 +6407,7 @@
                 </a:solidFill>
                 <a:latin typeface="Calibri"/>
               </a:rPr>
-              <a:t>4. ContractRepository Abstraction</a:t>
+              <a:t>3b. Compare Hard-Stop &amp; Persona Memory</a:t>
             </a:r>
           </a:p>
         </p:txBody>
@@ -5616,7 +6441,7 @@
                 </a:solidFill>
                 <a:latin typeface="Calibri"/>
               </a:rPr>
-              <a:t>Data source is replaceable without changing tool contracts</a:t>
+              <a:t>Deterministic offline paths — no LLM default pairs, no invented history</a:t>
             </a:r>
           </a:p>
         </p:txBody>
@@ -5629,8 +6454,85 @@
         </p:nvSpPr>
         <p:spPr>
           <a:xfrm>
-            <a:off x="457200" y="1280160"/>
-            <a:ext cx="3657600" cy="4754880"/>
+            <a:off x="365760" y="1234440"/>
+            <a:ext cx="5669280" cy="4846320"/>
+          </a:xfrm>
+          <a:prstGeom prst="roundRect">
+            <a:avLst>
+              <a:gd name="adj" fmla="val 12000"/>
+            </a:avLst>
+          </a:prstGeom>
+          <a:solidFill>
+            <a:srgbClr val="FEE2E2"/>
+          </a:solidFill>
+          <a:ln w="15875">
+            <a:solidFill>
+              <a:srgbClr val="B91C1C"/>
+            </a:solidFill>
+          </a:ln>
+        </p:spPr>
+        <p:style>
+          <a:lnRef idx="1">
+            <a:schemeClr val="accent1"/>
+          </a:lnRef>
+          <a:fillRef idx="3">
+            <a:schemeClr val="accent1"/>
+          </a:fillRef>
+          <a:effectRef idx="2">
+            <a:schemeClr val="accent1"/>
+          </a:effectRef>
+          <a:fontRef idx="minor">
+            <a:schemeClr val="lt1"/>
+          </a:fontRef>
+        </p:style>
+        <p:txBody>
+          <a:bodyPr rtlCol="0" anchor="ctr" wrap="square"/>
+          <a:lstStyle/>
+          <a:p>
+            <a:pPr algn="ctr"/>
+            <a:r>
+              <a:rPr sz="1500" b="1">
+                <a:solidFill>
+                  <a:srgbClr val="0B1F33"/>
+                </a:solidFill>
+                <a:latin typeface="Calibri"/>
+              </a:rPr>
+              <a:t>Compare hard-stop</a:t>
+            </a:r>
+          </a:p>
+          <a:p>
+            <a:pPr algn="ctr"/>
+            <a:r>
+              <a:rPr sz="1200" b="0">
+                <a:solidFill>
+                  <a:srgbClr val="334155"/>
+                </a:solidFill>
+                <a:latin typeface="Calibri"/>
+              </a:rPr>
+              <a:t>If any requested supplier or contract ID
+cannot be resolved:
+Return ONLY:
+“The contract information requested
+for the comparison is not available
+at the moment”
+• No comparative table
+• No ## Recommendation
+• No CON-0001 vs CON-0002 default
+• Compare intents → offline_router</a:t>
+            </a:r>
+          </a:p>
+        </p:txBody>
+      </p:sp>
+      <p:sp>
+        <p:nvSpPr>
+          <p:cNvPr id="6" name="Rounded Rectangle 5"/>
+          <p:cNvSpPr/>
+          <p:nvPr/>
+        </p:nvSpPr>
+        <p:spPr>
+          <a:xfrm>
+            <a:off x="6309360" y="1234440"/>
+            <a:ext cx="5486400" cy="4846320"/>
           </a:xfrm>
           <a:prstGeom prst="roundRect">
             <a:avLst>
@@ -5666,292 +6568,41 @@
           <a:p>
             <a:pPr algn="ctr"/>
             <a:r>
-              <a:rPr sz="1600" b="1">
+              <a:rPr sz="1500" b="1">
                 <a:solidFill>
                   <a:srgbClr val="0B1F33"/>
                 </a:solidFill>
                 <a:latin typeface="Calibri"/>
               </a:rPr>
-              <a:t>ContractRepository</a:t>
-            </a:r>
-          </a:p>
-          <a:p>
-            <a:pPr algn="ctr"/>
-            <a:r>
-              <a:rPr sz="1400" b="0">
+              <a:t>Persona memory</a:t>
+            </a:r>
+          </a:p>
+          <a:p>
+            <a:pPr algn="ctr"/>
+            <a:r>
+              <a:rPr sz="1200" b="0">
                 <a:solidFill>
                   <a:srgbClr val="334155"/>
                 </a:solidFill>
                 <a:latin typeface="Calibri"/>
               </a:rPr>
-              <a:t>list_all()
-get_by_id(contract_id)
-search(filters)
-get_by_vendor(vendor)</a:t>
-            </a:r>
-          </a:p>
-        </p:txBody>
-      </p:sp>
-      <p:sp>
-        <p:nvSpPr>
-          <p:cNvPr id="6" name="Right Arrow 5"/>
-          <p:cNvSpPr/>
-          <p:nvPr/>
-        </p:nvSpPr>
-        <p:spPr>
-          <a:xfrm>
-            <a:off x="4297680" y="3383280"/>
-            <a:ext cx="457200" cy="256032"/>
-          </a:xfrm>
-          <a:prstGeom prst="rightArrow">
-            <a:avLst/>
-          </a:prstGeom>
-          <a:solidFill>
-            <a:srgbClr val="94A3B8"/>
-          </a:solidFill>
-          <a:ln>
-            <a:solidFill>
-              <a:srgbClr val="94A3B8"/>
-            </a:solidFill>
-          </a:ln>
-        </p:spPr>
-        <p:style>
-          <a:lnRef idx="1">
-            <a:schemeClr val="accent1"/>
-          </a:lnRef>
-          <a:fillRef idx="3">
-            <a:schemeClr val="accent1"/>
-          </a:fillRef>
-          <a:effectRef idx="2">
-            <a:schemeClr val="accent1"/>
-          </a:effectRef>
-          <a:fontRef idx="minor">
-            <a:schemeClr val="lt1"/>
-          </a:fontRef>
-        </p:style>
-        <p:txBody>
-          <a:bodyPr rtlCol="0" anchor="ctr"/>
-          <a:lstStyle/>
-          <a:p>
-            <a:pPr algn="ctr"/>
-          </a:p>
-        </p:txBody>
-      </p:sp>
-      <p:sp>
-        <p:nvSpPr>
-          <p:cNvPr id="7" name="Rounded Rectangle 6"/>
-          <p:cNvSpPr/>
-          <p:nvPr/>
-        </p:nvSpPr>
-        <p:spPr>
-          <a:xfrm>
-            <a:off x="4937760" y="1280160"/>
-            <a:ext cx="3291840" cy="2103120"/>
-          </a:xfrm>
-          <a:prstGeom prst="roundRect">
-            <a:avLst>
-              <a:gd name="adj" fmla="val 12000"/>
-            </a:avLst>
-          </a:prstGeom>
-          <a:solidFill>
-            <a:srgbClr val="D1FAE5"/>
-          </a:solidFill>
-          <a:ln w="15875">
-            <a:solidFill>
-              <a:srgbClr val="047857"/>
-            </a:solidFill>
-          </a:ln>
-        </p:spPr>
-        <p:style>
-          <a:lnRef idx="1">
-            <a:schemeClr val="accent1"/>
-          </a:lnRef>
-          <a:fillRef idx="3">
-            <a:schemeClr val="accent1"/>
-          </a:fillRef>
-          <a:effectRef idx="2">
-            <a:schemeClr val="accent1"/>
-          </a:effectRef>
-          <a:fontRef idx="minor">
-            <a:schemeClr val="lt1"/>
-          </a:fontRef>
-        </p:style>
-        <p:txBody>
-          <a:bodyPr rtlCol="0" anchor="ctr" wrap="square"/>
-          <a:lstStyle/>
-          <a:p>
-            <a:pPr algn="ctr"/>
-            <a:r>
-              <a:rPr sz="1500" b="1">
-                <a:solidFill>
-                  <a:srgbClr val="0B1F33"/>
-                </a:solidFill>
-                <a:latin typeface="Calibri"/>
-              </a:rPr>
-              <a:t>Today</a:t>
-            </a:r>
-          </a:p>
-          <a:p>
-            <a:pPr algn="ctr"/>
-            <a:r>
-              <a:rPr sz="1300" b="0">
-                <a:solidFill>
-                  <a:srgbClr val="334155"/>
-                </a:solidFill>
-                <a:latin typeface="Calibri"/>
-              </a:rPr>
-              <a:t>FabricContractRepository
-→ Gold_Vendor_Contracts
-→ offline fixtures</a:t>
-            </a:r>
-          </a:p>
-        </p:txBody>
-      </p:sp>
-      <p:sp>
-        <p:nvSpPr>
-          <p:cNvPr id="8" name="Rounded Rectangle 7"/>
-          <p:cNvSpPr/>
-          <p:nvPr/>
-        </p:nvSpPr>
-        <p:spPr>
-          <a:xfrm>
-            <a:off x="4937760" y="3657600"/>
-            <a:ext cx="3291840" cy="2377440"/>
-          </a:xfrm>
-          <a:prstGeom prst="roundRect">
-            <a:avLst>
-              <a:gd name="adj" fmla="val 12000"/>
-            </a:avLst>
-          </a:prstGeom>
-          <a:solidFill>
-            <a:srgbClr val="EDE9FE"/>
-          </a:solidFill>
-          <a:ln w="15875">
-            <a:solidFill>
-              <a:srgbClr val="6D28D9"/>
-            </a:solidFill>
-          </a:ln>
-        </p:spPr>
-        <p:style>
-          <a:lnRef idx="1">
-            <a:schemeClr val="accent1"/>
-          </a:lnRef>
-          <a:fillRef idx="3">
-            <a:schemeClr val="accent1"/>
-          </a:fillRef>
-          <a:effectRef idx="2">
-            <a:schemeClr val="accent1"/>
-          </a:effectRef>
-          <a:fontRef idx="minor">
-            <a:schemeClr val="lt1"/>
-          </a:fontRef>
-        </p:style>
-        <p:txBody>
-          <a:bodyPr rtlCol="0" anchor="ctr" wrap="square"/>
-          <a:lstStyle/>
-          <a:p>
-            <a:pPr algn="ctr"/>
-            <a:r>
-              <a:rPr sz="1500" b="1">
-                <a:solidFill>
-                  <a:srgbClr val="0B1F33"/>
-                </a:solidFill>
-                <a:latin typeface="Calibri"/>
-              </a:rPr>
-              <a:t>Later</a:t>
-            </a:r>
-          </a:p>
-          <a:p>
-            <a:pPr algn="ctr"/>
-            <a:r>
-              <a:rPr sz="1300" b="0">
-                <a:solidFill>
-                  <a:srgbClr val="334155"/>
-                </a:solidFill>
-                <a:latin typeface="Calibri"/>
-              </a:rPr>
-              <a:t>LinkSquares / CLM adapter
-same tool signatures
-same snake_case projections</a:t>
-            </a:r>
-          </a:p>
-        </p:txBody>
-      </p:sp>
-      <p:sp>
-        <p:nvSpPr>
-          <p:cNvPr id="9" name="Rounded Rectangle 8"/>
-          <p:cNvSpPr/>
-          <p:nvPr/>
-        </p:nvSpPr>
-        <p:spPr>
-          <a:xfrm>
-            <a:off x="8503920" y="1280160"/>
-            <a:ext cx="3200400" cy="4754880"/>
-          </a:xfrm>
-          <a:prstGeom prst="roundRect">
-            <a:avLst>
-              <a:gd name="adj" fmla="val 12000"/>
-            </a:avLst>
-          </a:prstGeom>
-          <a:solidFill>
-            <a:srgbClr val="FEF3C7"/>
-          </a:solidFill>
-          <a:ln w="15875">
-            <a:solidFill>
-              <a:srgbClr val="B45309"/>
-            </a:solidFill>
-          </a:ln>
-        </p:spPr>
-        <p:style>
-          <a:lnRef idx="1">
-            <a:schemeClr val="accent1"/>
-          </a:lnRef>
-          <a:fillRef idx="3">
-            <a:schemeClr val="accent1"/>
-          </a:fillRef>
-          <a:effectRef idx="2">
-            <a:schemeClr val="accent1"/>
-          </a:effectRef>
-          <a:fontRef idx="minor">
-            <a:schemeClr val="lt1"/>
-          </a:fontRef>
-        </p:style>
-        <p:txBody>
-          <a:bodyPr rtlCol="0" anchor="ctr" wrap="square"/>
-          <a:lstStyle/>
-          <a:p>
-            <a:pPr algn="ctr"/>
-            <a:r>
-              <a:rPr sz="1500" b="1">
-                <a:solidFill>
-                  <a:srgbClr val="0B1F33"/>
-                </a:solidFill>
-                <a:latin typeface="Calibri"/>
-              </a:rPr>
-              <a:t>Consumers</a:t>
-            </a:r>
-          </a:p>
-          <a:p>
-            <a:pPr algn="ctr"/>
-            <a:r>
-              <a:rPr sz="1200" b="0">
-                <a:solidFill>
-                  <a:srgbClr val="334155"/>
-                </a:solidFill>
-                <a:latin typeface="Calibri"/>
-              </a:rPr>
-              <a:t>search_contracts
-get_contract_profile
-find_overlaps
-explain_contract_risk
-compare / missing / expiring</a:t>
-            </a:r>
-          </a:p>
-        </p:txBody>
-      </p:sp>
-      <p:sp>
-        <p:nvSpPr>
-          <p:cNvPr id="10" name="TextBox 9"/>
+              <a:t>SQLite: data/persona_memory.sqlite
+(override VAL_MEMORY_DB)
+• Auto-save search-like queries
+• Pin / filter / delete in sidebar
+• GET/POST /api/memory/searches
+• GET /api/memory/recall
+• Memory-recall → offline store
+• Streamlit owns writes when
+  clientPersistsMemory is set
+memory/store.py + test_ui sidebar</a:t>
+            </a:r>
+          </a:p>
+        </p:txBody>
+      </p:sp>
+      <p:sp>
+        <p:nvSpPr>
+          <p:cNvPr id="7" name="TextBox 6"/>
           <p:cNvSpPr txBox="1"/>
           <p:nvPr/>
         </p:nvSpPr>
@@ -6076,7 +6727,7 @@
                 </a:solidFill>
                 <a:latin typeface="Calibri"/>
               </a:rPr>
-              <a:t>5. Structured Intelligence Tools (P0/P1)</a:t>
+              <a:t>4. ContractRepository Abstraction</a:t>
             </a:r>
           </a:p>
         </p:txBody>
@@ -6110,7 +6761,7 @@
                 </a:solidFill>
                 <a:latin typeface="Calibri"/>
               </a:rPr>
-              <a:t>Grounded metadata tools — not document search</a:t>
+              <a:t>Data source is replaceable without changing tool contracts</a:t>
             </a:r>
           </a:p>
         </p:txBody>
@@ -6123,8 +6774,124 @@
         </p:nvSpPr>
         <p:spPr>
           <a:xfrm>
-            <a:off x="365760" y="1188720"/>
-            <a:ext cx="3566160" cy="2103120"/>
+            <a:off x="457200" y="1280160"/>
+            <a:ext cx="3657600" cy="4754880"/>
+          </a:xfrm>
+          <a:prstGeom prst="roundRect">
+            <a:avLst>
+              <a:gd name="adj" fmla="val 12000"/>
+            </a:avLst>
+          </a:prstGeom>
+          <a:solidFill>
+            <a:srgbClr val="D9F3F3"/>
+          </a:solidFill>
+          <a:ln w="15875">
+            <a:solidFill>
+              <a:srgbClr val="0E6B6B"/>
+            </a:solidFill>
+          </a:ln>
+        </p:spPr>
+        <p:style>
+          <a:lnRef idx="1">
+            <a:schemeClr val="accent1"/>
+          </a:lnRef>
+          <a:fillRef idx="3">
+            <a:schemeClr val="accent1"/>
+          </a:fillRef>
+          <a:effectRef idx="2">
+            <a:schemeClr val="accent1"/>
+          </a:effectRef>
+          <a:fontRef idx="minor">
+            <a:schemeClr val="lt1"/>
+          </a:fontRef>
+        </p:style>
+        <p:txBody>
+          <a:bodyPr rtlCol="0" anchor="ctr" wrap="square"/>
+          <a:lstStyle/>
+          <a:p>
+            <a:pPr algn="ctr"/>
+            <a:r>
+              <a:rPr sz="1600" b="1">
+                <a:solidFill>
+                  <a:srgbClr val="0B1F33"/>
+                </a:solidFill>
+                <a:latin typeface="Calibri"/>
+              </a:rPr>
+              <a:t>ContractRepository</a:t>
+            </a:r>
+          </a:p>
+          <a:p>
+            <a:pPr algn="ctr"/>
+            <a:r>
+              <a:rPr sz="1400" b="0">
+                <a:solidFill>
+                  <a:srgbClr val="334155"/>
+                </a:solidFill>
+                <a:latin typeface="Calibri"/>
+              </a:rPr>
+              <a:t>list_all()
+get_by_id(contract_id)
+search(filters)
+get_by_vendor(vendor)</a:t>
+            </a:r>
+          </a:p>
+        </p:txBody>
+      </p:sp>
+      <p:sp>
+        <p:nvSpPr>
+          <p:cNvPr id="6" name="Right Arrow 5"/>
+          <p:cNvSpPr/>
+          <p:nvPr/>
+        </p:nvSpPr>
+        <p:spPr>
+          <a:xfrm>
+            <a:off x="4297680" y="3383280"/>
+            <a:ext cx="457200" cy="256032"/>
+          </a:xfrm>
+          <a:prstGeom prst="rightArrow">
+            <a:avLst/>
+          </a:prstGeom>
+          <a:solidFill>
+            <a:srgbClr val="94A3B8"/>
+          </a:solidFill>
+          <a:ln>
+            <a:solidFill>
+              <a:srgbClr val="94A3B8"/>
+            </a:solidFill>
+          </a:ln>
+        </p:spPr>
+        <p:style>
+          <a:lnRef idx="1">
+            <a:schemeClr val="accent1"/>
+          </a:lnRef>
+          <a:fillRef idx="3">
+            <a:schemeClr val="accent1"/>
+          </a:fillRef>
+          <a:effectRef idx="2">
+            <a:schemeClr val="accent1"/>
+          </a:effectRef>
+          <a:fontRef idx="minor">
+            <a:schemeClr val="lt1"/>
+          </a:fontRef>
+        </p:style>
+        <p:txBody>
+          <a:bodyPr rtlCol="0" anchor="ctr"/>
+          <a:lstStyle/>
+          <a:p>
+            <a:pPr algn="ctr"/>
+          </a:p>
+        </p:txBody>
+      </p:sp>
+      <p:sp>
+        <p:nvSpPr>
+          <p:cNvPr id="7" name="Rounded Rectangle 6"/>
+          <p:cNvSpPr/>
+          <p:nvPr/>
+        </p:nvSpPr>
+        <p:spPr>
+          <a:xfrm>
+            <a:off x="4937760" y="1280160"/>
+            <a:ext cx="3291840" cy="2103120"/>
           </a:xfrm>
           <a:prstGeom prst="roundRect">
             <a:avLst>
@@ -6160,164 +6927,27 @@
           <a:p>
             <a:pPr algn="ctr"/>
             <a:r>
-              <a:rPr sz="1400" b="1">
+              <a:rPr sz="1500" b="1">
                 <a:solidFill>
                   <a:srgbClr val="0B1F33"/>
                 </a:solidFill>
                 <a:latin typeface="Calibri"/>
               </a:rPr>
-              <a:t>search_contracts</a:t>
-            </a:r>
-          </a:p>
-          <a:p>
-            <a:pPr algn="ctr"/>
-            <a:r>
-              <a:rPr sz="1200" b="0">
+              <a:t>Today</a:t>
+            </a:r>
+          </a:p>
+          <a:p>
+            <a:pPr algn="ctr"/>
+            <a:r>
+              <a:rPr sz="1300" b="0">
                 <a:solidFill>
                   <a:srgbClr val="334155"/>
                 </a:solidFill>
                 <a:latin typeface="Calibri"/>
               </a:rPr>
-              <a:t>Vendor/BU/status/type filters
-Stable snake_case catalog rows</a:t>
-            </a:r>
-          </a:p>
-        </p:txBody>
-      </p:sp>
-      <p:sp>
-        <p:nvSpPr>
-          <p:cNvPr id="6" name="Rounded Rectangle 5"/>
-          <p:cNvSpPr/>
-          <p:nvPr/>
-        </p:nvSpPr>
-        <p:spPr>
-          <a:xfrm>
-            <a:off x="4206240" y="1188720"/>
-            <a:ext cx="3566160" cy="2103120"/>
-          </a:xfrm>
-          <a:prstGeom prst="roundRect">
-            <a:avLst>
-              <a:gd name="adj" fmla="val 12000"/>
-            </a:avLst>
-          </a:prstGeom>
-          <a:solidFill>
-            <a:srgbClr val="D9F3F3"/>
-          </a:solidFill>
-          <a:ln w="15875">
-            <a:solidFill>
-              <a:srgbClr val="0E6B6B"/>
-            </a:solidFill>
-          </a:ln>
-        </p:spPr>
-        <p:style>
-          <a:lnRef idx="1">
-            <a:schemeClr val="accent1"/>
-          </a:lnRef>
-          <a:fillRef idx="3">
-            <a:schemeClr val="accent1"/>
-          </a:fillRef>
-          <a:effectRef idx="2">
-            <a:schemeClr val="accent1"/>
-          </a:effectRef>
-          <a:fontRef idx="minor">
-            <a:schemeClr val="lt1"/>
-          </a:fontRef>
-        </p:style>
-        <p:txBody>
-          <a:bodyPr rtlCol="0" anchor="ctr" wrap="square"/>
-          <a:lstStyle/>
-          <a:p>
-            <a:pPr algn="ctr"/>
-            <a:r>
-              <a:rPr sz="1400" b="1">
-                <a:solidFill>
-                  <a:srgbClr val="0B1F33"/>
-                </a:solidFill>
-                <a:latin typeface="Calibri"/>
-              </a:rPr>
-              <a:t>get_contract_profile</a:t>
-            </a:r>
-          </a:p>
-          <a:p>
-            <a:pPr algn="ctr"/>
-            <a:r>
-              <a:rPr sz="1200" b="0">
-                <a:solidFill>
-                  <a:srgbClr val="334155"/>
-                </a:solidFill>
-                <a:latin typeface="Calibri"/>
-              </a:rPr>
-              <a:t>One contract_id profile
-+ missing_fields</a:t>
-            </a:r>
-          </a:p>
-        </p:txBody>
-      </p:sp>
-      <p:sp>
-        <p:nvSpPr>
-          <p:cNvPr id="7" name="Rounded Rectangle 6"/>
-          <p:cNvSpPr/>
-          <p:nvPr/>
-        </p:nvSpPr>
-        <p:spPr>
-          <a:xfrm>
-            <a:off x="8046720" y="1188720"/>
-            <a:ext cx="3566160" cy="2103120"/>
-          </a:xfrm>
-          <a:prstGeom prst="roundRect">
-            <a:avLst>
-              <a:gd name="adj" fmla="val 12000"/>
-            </a:avLst>
-          </a:prstGeom>
-          <a:solidFill>
-            <a:srgbClr val="FFEDD5"/>
-          </a:solidFill>
-          <a:ln w="15875">
-            <a:solidFill>
-              <a:srgbClr val="C2410C"/>
-            </a:solidFill>
-          </a:ln>
-        </p:spPr>
-        <p:style>
-          <a:lnRef idx="1">
-            <a:schemeClr val="accent1"/>
-          </a:lnRef>
-          <a:fillRef idx="3">
-            <a:schemeClr val="accent1"/>
-          </a:fillRef>
-          <a:effectRef idx="2">
-            <a:schemeClr val="accent1"/>
-          </a:effectRef>
-          <a:fontRef idx="minor">
-            <a:schemeClr val="lt1"/>
-          </a:fontRef>
-        </p:style>
-        <p:txBody>
-          <a:bodyPr rtlCol="0" anchor="ctr" wrap="square"/>
-          <a:lstStyle/>
-          <a:p>
-            <a:pPr algn="ctr"/>
-            <a:r>
-              <a:rPr sz="1400" b="1">
-                <a:solidFill>
-                  <a:srgbClr val="0B1F33"/>
-                </a:solidFill>
-                <a:latin typeface="Calibri"/>
-              </a:rPr>
-              <a:t>find_overlaps</a:t>
-            </a:r>
-          </a:p>
-          <a:p>
-            <a:pPr algn="ctr"/>
-            <a:r>
-              <a:rPr sz="1200" b="0">
-                <a:solidFill>
-                  <a:srgbClr val="334155"/>
-                </a:solidFill>
-                <a:latin typeface="Calibri"/>
-              </a:rPr>
-              <a:t>Same-vendor date overlaps
-contract_a/b + window + why</a:t>
+              <a:t>FabricContractRepository
+→ LinkSquares fixtures
+→ Gold-shaped projections</a:t>
             </a:r>
           </a:p>
         </p:txBody>
@@ -6330,8 +6960,8 @@
         </p:nvSpPr>
         <p:spPr>
           <a:xfrm>
-            <a:off x="365760" y="3657600"/>
-            <a:ext cx="3566160" cy="2103120"/>
+            <a:off x="4937760" y="3657600"/>
+            <a:ext cx="3291840" cy="2377440"/>
           </a:xfrm>
           <a:prstGeom prst="roundRect">
             <a:avLst>
@@ -6367,26 +6997,27 @@
           <a:p>
             <a:pPr algn="ctr"/>
             <a:r>
-              <a:rPr sz="1400" b="1">
+              <a:rPr sz="1500" b="1">
                 <a:solidFill>
                   <a:srgbClr val="0B1F33"/>
                 </a:solidFill>
                 <a:latin typeface="Calibri"/>
               </a:rPr>
-              <a:t>explain_contract_risk</a:t>
-            </a:r>
-          </a:p>
-          <a:p>
-            <a:pPr algn="ctr"/>
-            <a:r>
-              <a:rPr sz="1200" b="0">
+              <a:t>Later</a:t>
+            </a:r>
+          </a:p>
+          <a:p>
+            <a:pPr algn="ctr"/>
+            <a:r>
+              <a:rPr sz="1300" b="0">
                 <a:solidFill>
                   <a:srgbClr val="334155"/>
                 </a:solidFill>
                 <a:latin typeface="Calibri"/>
               </a:rPr>
-              <a:t>known_facts vs computed_risks
-missing_data + review action</a:t>
+              <a:t>Live LinkSquares / CLM
+same tool signatures
+same snake_case projections</a:t>
             </a:r>
           </a:p>
         </p:txBody>
@@ -6399,77 +7030,8 @@
         </p:nvSpPr>
         <p:spPr>
           <a:xfrm>
-            <a:off x="4206240" y="3657600"/>
-            <a:ext cx="3566160" cy="2103120"/>
-          </a:xfrm>
-          <a:prstGeom prst="roundRect">
-            <a:avLst>
-              <a:gd name="adj" fmla="val 12000"/>
-            </a:avLst>
-          </a:prstGeom>
-          <a:solidFill>
-            <a:srgbClr val="FEE2E2"/>
-          </a:solidFill>
-          <a:ln w="15875">
-            <a:solidFill>
-              <a:srgbClr val="B91C1C"/>
-            </a:solidFill>
-          </a:ln>
-        </p:spPr>
-        <p:style>
-          <a:lnRef idx="1">
-            <a:schemeClr val="accent1"/>
-          </a:lnRef>
-          <a:fillRef idx="3">
-            <a:schemeClr val="accent1"/>
-          </a:fillRef>
-          <a:effectRef idx="2">
-            <a:schemeClr val="accent1"/>
-          </a:effectRef>
-          <a:fontRef idx="minor">
-            <a:schemeClr val="lt1"/>
-          </a:fontRef>
-        </p:style>
-        <p:txBody>
-          <a:bodyPr rtlCol="0" anchor="ctr" wrap="square"/>
-          <a:lstStyle/>
-          <a:p>
-            <a:pPr algn="ctr"/>
-            <a:r>
-              <a:rPr sz="1400" b="1">
-                <a:solidFill>
-                  <a:srgbClr val="0B1F33"/>
-                </a:solidFill>
-                <a:latin typeface="Calibri"/>
-              </a:rPr>
-              <a:t>Invoice OOS guardrail</a:t>
-            </a:r>
-          </a:p>
-          <a:p>
-            <a:pPr algn="ctr"/>
-            <a:r>
-              <a:rPr sz="1200" b="0">
-                <a:solidFill>
-                  <a:srgbClr val="334155"/>
-                </a:solidFill>
-                <a:latin typeface="Calibri"/>
-              </a:rPr>
-              <a:t>Exact refusal before tools
-Never treat ACV as invoices</a:t>
-            </a:r>
-          </a:p>
-        </p:txBody>
-      </p:sp>
-      <p:sp>
-        <p:nvSpPr>
-          <p:cNvPr id="10" name="Rounded Rectangle 9"/>
-          <p:cNvSpPr/>
-          <p:nvPr/>
-        </p:nvSpPr>
-        <p:spPr>
-          <a:xfrm>
-            <a:off x="8046720" y="3657600"/>
-            <a:ext cx="3566160" cy="2103120"/>
+            <a:off x="8503920" y="1280160"/>
+            <a:ext cx="3200400" cy="4754880"/>
           </a:xfrm>
           <a:prstGeom prst="roundRect">
             <a:avLst>
@@ -6505,13 +7067,13 @@
           <a:p>
             <a:pPr algn="ctr"/>
             <a:r>
-              <a:rPr sz="1400" b="1">
+              <a:rPr sz="1500" b="1">
                 <a:solidFill>
                   <a:srgbClr val="0B1F33"/>
                 </a:solidFill>
                 <a:latin typeface="Calibri"/>
               </a:rPr>
-              <a:t>Demo fixtures</a:t>
+              <a:t>Consumers</a:t>
             </a:r>
           </a:p>
           <a:p>
@@ -6523,15 +7085,18 @@
                 </a:solidFill>
                 <a:latin typeface="Calibri"/>
               </a:rPr>
-              <a:t>LinkSquares 100 contracts
-Microsoft/AWS overlaps &amp; Net 180</a:t>
-            </a:r>
-          </a:p>
-        </p:txBody>
-      </p:sp>
-      <p:sp>
-        <p:nvSpPr>
-          <p:cNvPr id="11" name="TextBox 10"/>
+              <a:t>search_contracts
+get_contract_profile
+find_overlaps
+explain_contract_risk
+compare / missing / expiring</a:t>
+            </a:r>
+          </a:p>
+        </p:txBody>
+      </p:sp>
+      <p:sp>
+        <p:nvSpPr>
+          <p:cNvPr id="10" name="TextBox 9"/>
           <p:cNvSpPr txBox="1"/>
           <p:nvPr/>
         </p:nvSpPr>
@@ -6656,7 +7221,7 @@
                 </a:solidFill>
                 <a:latin typeface="Calibri"/>
               </a:rPr>
-              <a:t>6. Overlap &amp; Risk Explanation Process Flow</a:t>
+              <a:t>5. Structured Intelligence Tools (P0/P1)</a:t>
             </a:r>
           </a:p>
         </p:txBody>
@@ -6690,7 +7255,7 @@
                 </a:solidFill>
                 <a:latin typeface="Calibri"/>
               </a:rPr>
-              <a:t>Separate facts from computed risks — no invented findings</a:t>
+              <a:t>Grounded metadata tools — not document search</a:t>
             </a:r>
           </a:p>
         </p:txBody>
@@ -6703,8 +7268,146 @@
         </p:nvSpPr>
         <p:spPr>
           <a:xfrm>
-            <a:off x="365760" y="1280160"/>
-            <a:ext cx="3657600" cy="4754880"/>
+            <a:off x="365760" y="1188720"/>
+            <a:ext cx="3566160" cy="2103120"/>
+          </a:xfrm>
+          <a:prstGeom prst="roundRect">
+            <a:avLst>
+              <a:gd name="adj" fmla="val 12000"/>
+            </a:avLst>
+          </a:prstGeom>
+          <a:solidFill>
+            <a:srgbClr val="D1FAE5"/>
+          </a:solidFill>
+          <a:ln w="15875">
+            <a:solidFill>
+              <a:srgbClr val="047857"/>
+            </a:solidFill>
+          </a:ln>
+        </p:spPr>
+        <p:style>
+          <a:lnRef idx="1">
+            <a:schemeClr val="accent1"/>
+          </a:lnRef>
+          <a:fillRef idx="3">
+            <a:schemeClr val="accent1"/>
+          </a:fillRef>
+          <a:effectRef idx="2">
+            <a:schemeClr val="accent1"/>
+          </a:effectRef>
+          <a:fontRef idx="minor">
+            <a:schemeClr val="lt1"/>
+          </a:fontRef>
+        </p:style>
+        <p:txBody>
+          <a:bodyPr rtlCol="0" anchor="ctr" wrap="square"/>
+          <a:lstStyle/>
+          <a:p>
+            <a:pPr algn="ctr"/>
+            <a:r>
+              <a:rPr sz="1400" b="1">
+                <a:solidFill>
+                  <a:srgbClr val="0B1F33"/>
+                </a:solidFill>
+                <a:latin typeface="Calibri"/>
+              </a:rPr>
+              <a:t>search_contracts</a:t>
+            </a:r>
+          </a:p>
+          <a:p>
+            <a:pPr algn="ctr"/>
+            <a:r>
+              <a:rPr sz="1200" b="0">
+                <a:solidFill>
+                  <a:srgbClr val="334155"/>
+                </a:solidFill>
+                <a:latin typeface="Calibri"/>
+              </a:rPr>
+              <a:t>Vendor/BU/status/type filters
+Stable snake_case catalog rows</a:t>
+            </a:r>
+          </a:p>
+        </p:txBody>
+      </p:sp>
+      <p:sp>
+        <p:nvSpPr>
+          <p:cNvPr id="6" name="Rounded Rectangle 5"/>
+          <p:cNvSpPr/>
+          <p:nvPr/>
+        </p:nvSpPr>
+        <p:spPr>
+          <a:xfrm>
+            <a:off x="4206240" y="1188720"/>
+            <a:ext cx="3566160" cy="2103120"/>
+          </a:xfrm>
+          <a:prstGeom prst="roundRect">
+            <a:avLst>
+              <a:gd name="adj" fmla="val 12000"/>
+            </a:avLst>
+          </a:prstGeom>
+          <a:solidFill>
+            <a:srgbClr val="D9F3F3"/>
+          </a:solidFill>
+          <a:ln w="15875">
+            <a:solidFill>
+              <a:srgbClr val="0E6B6B"/>
+            </a:solidFill>
+          </a:ln>
+        </p:spPr>
+        <p:style>
+          <a:lnRef idx="1">
+            <a:schemeClr val="accent1"/>
+          </a:lnRef>
+          <a:fillRef idx="3">
+            <a:schemeClr val="accent1"/>
+          </a:fillRef>
+          <a:effectRef idx="2">
+            <a:schemeClr val="accent1"/>
+          </a:effectRef>
+          <a:fontRef idx="minor">
+            <a:schemeClr val="lt1"/>
+          </a:fontRef>
+        </p:style>
+        <p:txBody>
+          <a:bodyPr rtlCol="0" anchor="ctr" wrap="square"/>
+          <a:lstStyle/>
+          <a:p>
+            <a:pPr algn="ctr"/>
+            <a:r>
+              <a:rPr sz="1400" b="1">
+                <a:solidFill>
+                  <a:srgbClr val="0B1F33"/>
+                </a:solidFill>
+                <a:latin typeface="Calibri"/>
+              </a:rPr>
+              <a:t>get_contract_profile</a:t>
+            </a:r>
+          </a:p>
+          <a:p>
+            <a:pPr algn="ctr"/>
+            <a:r>
+              <a:rPr sz="1200" b="0">
+                <a:solidFill>
+                  <a:srgbClr val="334155"/>
+                </a:solidFill>
+                <a:latin typeface="Calibri"/>
+              </a:rPr>
+              <a:t>One contract_id profile
++ missing_fields</a:t>
+            </a:r>
+          </a:p>
+        </p:txBody>
+      </p:sp>
+      <p:sp>
+        <p:nvSpPr>
+          <p:cNvPr id="7" name="Rounded Rectangle 6"/>
+          <p:cNvSpPr/>
+          <p:nvPr/>
+        </p:nvSpPr>
+        <p:spPr>
+          <a:xfrm>
+            <a:off x="8046720" y="1188720"/>
+            <a:ext cx="3566160" cy="2103120"/>
           </a:xfrm>
           <a:prstGeom prst="roundRect">
             <a:avLst>
@@ -6740,13 +7443,13 @@
           <a:p>
             <a:pPr algn="ctr"/>
             <a:r>
-              <a:rPr sz="1500" b="1">
+              <a:rPr sz="1400" b="1">
                 <a:solidFill>
                   <a:srgbClr val="0B1F33"/>
                 </a:solidFill>
                 <a:latin typeface="Calibri"/>
               </a:rPr>
-              <a:t>find_overlaps</a:t>
+              <a:t>compare_contracts</a:t>
             </a:r>
           </a:p>
           <a:p>
@@ -6758,26 +7461,22 @@
                 </a:solidFill>
                 <a:latin typeface="Calibri"/>
               </a:rPr>
-              <a:t>1. Load contracts via repository
-2. Group by vendor
-3. Prefer OverlapFlag=Yes pairs
-4. Emit overlap_start/end
-5. why_flagged + source
-Demo: CON-0024 ∩ CON-0029</a:t>
-            </a:r>
-          </a:p>
-        </p:txBody>
-      </p:sp>
-      <p:sp>
-        <p:nvSpPr>
-          <p:cNvPr id="6" name="Rounded Rectangle 5"/>
+              <a:t>Pairwise / N-way any IDs
+Hard-stop if unresolved</a:t>
+            </a:r>
+          </a:p>
+        </p:txBody>
+      </p:sp>
+      <p:sp>
+        <p:nvSpPr>
+          <p:cNvPr id="8" name="Rounded Rectangle 7"/>
           <p:cNvSpPr/>
           <p:nvPr/>
         </p:nvSpPr>
         <p:spPr>
           <a:xfrm>
-            <a:off x="4297680" y="1280160"/>
-            <a:ext cx="3657600" cy="4754880"/>
+            <a:off x="365760" y="3657600"/>
+            <a:ext cx="3566160" cy="2103120"/>
           </a:xfrm>
           <a:prstGeom prst="roundRect">
             <a:avLst>
@@ -6813,7 +7512,7 @@
           <a:p>
             <a:pPr algn="ctr"/>
             <a:r>
-              <a:rPr sz="1500" b="1">
+              <a:rPr sz="1400" b="1">
                 <a:solidFill>
                   <a:srgbClr val="0B1F33"/>
                 </a:solidFill>
@@ -6831,28 +7530,22 @@
                 </a:solidFill>
                 <a:latin typeface="Calibri"/>
               </a:rPr>
-              <a:t>Flags only if data supports:
-• missing renewal
-• missing rate card
-• expiring soon
-• Net 90+ terms
-• high ACV outlier
-• high supplier risk
-• overlapping contract</a:t>
-            </a:r>
-          </a:p>
-        </p:txBody>
-      </p:sp>
-      <p:sp>
-        <p:nvSpPr>
-          <p:cNvPr id="7" name="Rounded Rectangle 6"/>
+              <a:t>known_facts vs computed_risks
+missing_data + review action</a:t>
+            </a:r>
+          </a:p>
+        </p:txBody>
+      </p:sp>
+      <p:sp>
+        <p:nvSpPr>
+          <p:cNvPr id="9" name="Rounded Rectangle 8"/>
           <p:cNvSpPr/>
           <p:nvPr/>
         </p:nvSpPr>
         <p:spPr>
           <a:xfrm>
-            <a:off x="8229600" y="1280160"/>
-            <a:ext cx="3566160" cy="4754880"/>
+            <a:off x="4206240" y="3657600"/>
+            <a:ext cx="3566160" cy="2103120"/>
           </a:xfrm>
           <a:prstGeom prst="roundRect">
             <a:avLst>
@@ -6860,11 +7553,11 @@
             </a:avLst>
           </a:prstGeom>
           <a:solidFill>
-            <a:srgbClr val="D9F3F3"/>
+            <a:srgbClr val="DBEAFE"/>
           </a:solidFill>
           <a:ln w="15875">
             <a:solidFill>
-              <a:srgbClr val="0E6B6B"/>
+              <a:srgbClr val="1D4ED8"/>
             </a:solidFill>
           </a:ln>
         </p:spPr>
@@ -6888,13 +7581,13 @@
           <a:p>
             <a:pPr algn="ctr"/>
             <a:r>
-              <a:rPr sz="1500" b="1">
+              <a:rPr sz="1400" b="1">
                 <a:solidFill>
                   <a:srgbClr val="0B1F33"/>
                 </a:solidFill>
                 <a:latin typeface="Calibri"/>
               </a:rPr>
-              <a:t>Response sections</a:t>
+              <a:t>find_overlaps</a:t>
             </a:r>
           </a:p>
           <a:p>
@@ -6906,19 +7599,84 @@
                 </a:solidFill>
                 <a:latin typeface="Calibri"/>
               </a:rPr>
-              <a:t>known_facts
-computed_risks
-missing_data
-recommended_review_action
-source
-Never invent unsupported risks</a:t>
-            </a:r>
-          </a:p>
-        </p:txBody>
-      </p:sp>
-      <p:sp>
-        <p:nvSpPr>
-          <p:cNvPr id="8" name="TextBox 7"/>
+              <a:t>Same-vendor date overlaps
+OverlapFlag-aware pairs</a:t>
+            </a:r>
+          </a:p>
+        </p:txBody>
+      </p:sp>
+      <p:sp>
+        <p:nvSpPr>
+          <p:cNvPr id="10" name="Rounded Rectangle 9"/>
+          <p:cNvSpPr/>
+          <p:nvPr/>
+        </p:nvSpPr>
+        <p:spPr>
+          <a:xfrm>
+            <a:off x="8046720" y="3657600"/>
+            <a:ext cx="3566160" cy="2103120"/>
+          </a:xfrm>
+          <a:prstGeom prst="roundRect">
+            <a:avLst>
+              <a:gd name="adj" fmla="val 12000"/>
+            </a:avLst>
+          </a:prstGeom>
+          <a:solidFill>
+            <a:srgbClr val="FEF3C7"/>
+          </a:solidFill>
+          <a:ln w="15875">
+            <a:solidFill>
+              <a:srgbClr val="B45309"/>
+            </a:solidFill>
+          </a:ln>
+        </p:spPr>
+        <p:style>
+          <a:lnRef idx="1">
+            <a:schemeClr val="accent1"/>
+          </a:lnRef>
+          <a:fillRef idx="3">
+            <a:schemeClr val="accent1"/>
+          </a:fillRef>
+          <a:effectRef idx="2">
+            <a:schemeClr val="accent1"/>
+          </a:effectRef>
+          <a:fontRef idx="minor">
+            <a:schemeClr val="lt1"/>
+          </a:fontRef>
+        </p:style>
+        <p:txBody>
+          <a:bodyPr rtlCol="0" anchor="ctr" wrap="square"/>
+          <a:lstStyle/>
+          <a:p>
+            <a:pPr algn="ctr"/>
+            <a:r>
+              <a:rPr sz="1400" b="1">
+                <a:solidFill>
+                  <a:srgbClr val="0B1F33"/>
+                </a:solidFill>
+                <a:latin typeface="Calibri"/>
+              </a:rPr>
+              <a:t>Demo fixtures</a:t>
+            </a:r>
+          </a:p>
+          <a:p>
+            <a:pPr algn="ctr"/>
+            <a:r>
+              <a:rPr sz="1200" b="0">
+                <a:solidFill>
+                  <a:srgbClr val="334155"/>
+                </a:solidFill>
+                <a:latin typeface="Calibri"/>
+              </a:rPr>
+              <a:t>LinkSquares 100 contracts
+Microsoft/AWS overlaps &amp; Net 180</a:t>
+            </a:r>
+          </a:p>
+        </p:txBody>
+      </p:sp>
+      <p:sp>
+        <p:nvSpPr>
+          <p:cNvPr id="11" name="TextBox 10"/>
           <p:cNvSpPr txBox="1"/>
           <p:nvPr/>
         </p:nvSpPr>
@@ -7043,7 +7801,7 @@
                 </a:solidFill>
                 <a:latin typeface="Calibri"/>
               </a:rPr>
-              <a:t>7. Full MCP Tool Inventory</a:t>
+              <a:t>6. Overlap &amp; Risk Explanation Process Flow</a:t>
             </a:r>
           </a:p>
         </p:txBody>
@@ -7077,7 +7835,7 @@
                 </a:solidFill>
                 <a:latin typeface="Calibri"/>
               </a:rPr>
-              <a:t>fabric_data FastMCP server</a:t>
+              <a:t>Separate facts from computed risks — no invented findings</a:t>
             </a:r>
           </a:p>
         </p:txBody>
@@ -7090,8 +7848,8 @@
         </p:nvSpPr>
         <p:spPr>
           <a:xfrm>
-            <a:off x="457200" y="1280160"/>
-            <a:ext cx="5486400" cy="4389120"/>
+            <a:off x="365760" y="1280160"/>
+            <a:ext cx="3657600" cy="4754880"/>
           </a:xfrm>
           <a:prstGeom prst="roundRect">
             <a:avLst>
@@ -7099,11 +7857,11 @@
             </a:avLst>
           </a:prstGeom>
           <a:solidFill>
-            <a:srgbClr val="D1FAE5"/>
+            <a:srgbClr val="FFEDD5"/>
           </a:solidFill>
           <a:ln w="15875">
             <a:solidFill>
-              <a:srgbClr val="047857"/>
+              <a:srgbClr val="C2410C"/>
             </a:solidFill>
           </a:ln>
         </p:spPr>
@@ -7133,23 +7891,24 @@
                 </a:solidFill>
                 <a:latin typeface="Calibri"/>
               </a:rPr>
-              <a:t>Structured / analytics</a:t>
-            </a:r>
-          </a:p>
-          <a:p>
-            <a:pPr algn="ctr"/>
-            <a:r>
-              <a:rPr sz="1300" b="0">
+              <a:t>find_overlaps</a:t>
+            </a:r>
+          </a:p>
+          <a:p>
+            <a:pPr algn="ctr"/>
+            <a:r>
+              <a:rPr sz="1200" b="0">
                 <a:solidFill>
                   <a:srgbClr val="334155"/>
                 </a:solidFill>
                 <a:latin typeface="Calibri"/>
               </a:rPr>
-              <a:t>search_contracts
-get_contract_profile
-find_overlaps
-explain_contract_risk
-compare_contracts</a:t>
+              <a:t>1. Load contracts via repository
+2. Group by vendor
+3. Prefer OverlapFlag=Yes pairs
+4. Emit overlap_start/end
+5. why_flagged + source
+Demo: CON-0024 ∩ CON-0029</a:t>
             </a:r>
           </a:p>
         </p:txBody>
@@ -7162,8 +7921,8 @@
         </p:nvSpPr>
         <p:spPr>
           <a:xfrm>
-            <a:off x="6309360" y="1280160"/>
-            <a:ext cx="5394960" cy="4389120"/>
+            <a:off x="4297680" y="1280160"/>
+            <a:ext cx="3657600" cy="4754880"/>
           </a:xfrm>
           <a:prstGeom prst="roundRect">
             <a:avLst>
@@ -7171,11 +7930,11 @@
             </a:avLst>
           </a:prstGeom>
           <a:solidFill>
-            <a:srgbClr val="DBEAFE"/>
+            <a:srgbClr val="EDE9FE"/>
           </a:solidFill>
           <a:ln w="15875">
             <a:solidFill>
-              <a:srgbClr val="1D4ED8"/>
+              <a:srgbClr val="6D28D9"/>
             </a:solidFill>
           </a:ln>
         </p:spPr>
@@ -7205,30 +7964,106 @@
                 </a:solidFill>
                 <a:latin typeface="Calibri"/>
               </a:rPr>
-              <a:t>Commercial / docs / health</a:t>
-            </a:r>
-          </a:p>
-          <a:p>
-            <a:pPr algn="ctr"/>
-            <a:r>
-              <a:rPr sz="1300" b="0">
+              <a:t>explain_contract_risk</a:t>
+            </a:r>
+          </a:p>
+          <a:p>
+            <a:pPr algn="ctr"/>
+            <a:r>
+              <a:rPr sz="1200" b="0">
                 <a:solidFill>
                   <a:srgbClr val="334155"/>
                 </a:solidFill>
                 <a:latin typeface="Calibri"/>
               </a:rPr>
-              <a:t>check_missing_contract_fields
-get_expiring_contracts
-get_vendor_spend_summary (ACV rollup only)
-search_cloud_blob_contracts (docs)
-fabric_health_check</a:t>
-            </a:r>
-          </a:p>
-        </p:txBody>
-      </p:sp>
-      <p:sp>
-        <p:nvSpPr>
-          <p:cNvPr id="7" name="TextBox 6"/>
+              <a:t>Flags only if data supports:
+• missing renewal
+• missing rate card
+• expiring soon
+• Net 90+ terms
+• high ACV outlier
+• high supplier risk
+• overlapping contract</a:t>
+            </a:r>
+          </a:p>
+        </p:txBody>
+      </p:sp>
+      <p:sp>
+        <p:nvSpPr>
+          <p:cNvPr id="7" name="Rounded Rectangle 6"/>
+          <p:cNvSpPr/>
+          <p:nvPr/>
+        </p:nvSpPr>
+        <p:spPr>
+          <a:xfrm>
+            <a:off x="8229600" y="1280160"/>
+            <a:ext cx="3566160" cy="4754880"/>
+          </a:xfrm>
+          <a:prstGeom prst="roundRect">
+            <a:avLst>
+              <a:gd name="adj" fmla="val 12000"/>
+            </a:avLst>
+          </a:prstGeom>
+          <a:solidFill>
+            <a:srgbClr val="D9F3F3"/>
+          </a:solidFill>
+          <a:ln w="15875">
+            <a:solidFill>
+              <a:srgbClr val="0E6B6B"/>
+            </a:solidFill>
+          </a:ln>
+        </p:spPr>
+        <p:style>
+          <a:lnRef idx="1">
+            <a:schemeClr val="accent1"/>
+          </a:lnRef>
+          <a:fillRef idx="3">
+            <a:schemeClr val="accent1"/>
+          </a:fillRef>
+          <a:effectRef idx="2">
+            <a:schemeClr val="accent1"/>
+          </a:effectRef>
+          <a:fontRef idx="minor">
+            <a:schemeClr val="lt1"/>
+          </a:fontRef>
+        </p:style>
+        <p:txBody>
+          <a:bodyPr rtlCol="0" anchor="ctr" wrap="square"/>
+          <a:lstStyle/>
+          <a:p>
+            <a:pPr algn="ctr"/>
+            <a:r>
+              <a:rPr sz="1500" b="1">
+                <a:solidFill>
+                  <a:srgbClr val="0B1F33"/>
+                </a:solidFill>
+                <a:latin typeface="Calibri"/>
+              </a:rPr>
+              <a:t>Response sections</a:t>
+            </a:r>
+          </a:p>
+          <a:p>
+            <a:pPr algn="ctr"/>
+            <a:r>
+              <a:rPr sz="1200" b="0">
+                <a:solidFill>
+                  <a:srgbClr val="334155"/>
+                </a:solidFill>
+                <a:latin typeface="Calibri"/>
+              </a:rPr>
+              <a:t>known_facts
+computed_risks
+missing_data
+recommended_review_action
+source
+Never invent unsupported risks</a:t>
+            </a:r>
+          </a:p>
+        </p:txBody>
+      </p:sp>
+      <p:sp>
+        <p:nvSpPr>
+          <p:cNvPr id="8" name="TextBox 7"/>
           <p:cNvSpPr txBox="1"/>
           <p:nvPr/>
         </p:nvSpPr>
@@ -7353,7 +8188,7 @@
                 </a:solidFill>
                 <a:latin typeface="Calibri"/>
               </a:rPr>
-              <a:t>8. Optional Future — Azure AI Foundry Deploy</a:t>
+              <a:t>7. Full MCP Tool Inventory</a:t>
             </a:r>
           </a:p>
         </p:txBody>
@@ -7387,7 +8222,7 @@
                 </a:solidFill>
                 <a:latin typeface="Calibri"/>
               </a:rPr>
-              <a:t>deploy_to_foundry.py is optional; current POC does not require Foundry</a:t>
+              <a:t>fabric_data FastMCP server</a:t>
             </a:r>
           </a:p>
         </p:txBody>
@@ -7400,144 +8235,8 @@
         </p:nvSpPr>
         <p:spPr>
           <a:xfrm>
-            <a:off x="365760" y="1828800"/>
-            <a:ext cx="2103120" cy="2011680"/>
-          </a:xfrm>
-          <a:prstGeom prst="roundRect">
-            <a:avLst>
-              <a:gd name="adj" fmla="val 12000"/>
-            </a:avLst>
-          </a:prstGeom>
-          <a:solidFill>
-            <a:srgbClr val="D9F3F3"/>
-          </a:solidFill>
-          <a:ln w="15875">
-            <a:solidFill>
-              <a:srgbClr val="0E6B6B"/>
-            </a:solidFill>
-          </a:ln>
-        </p:spPr>
-        <p:style>
-          <a:lnRef idx="1">
-            <a:schemeClr val="accent1"/>
-          </a:lnRef>
-          <a:fillRef idx="3">
-            <a:schemeClr val="accent1"/>
-          </a:fillRef>
-          <a:effectRef idx="2">
-            <a:schemeClr val="accent1"/>
-          </a:effectRef>
-          <a:fontRef idx="minor">
-            <a:schemeClr val="lt1"/>
-          </a:fontRef>
-        </p:style>
-        <p:txBody>
-          <a:bodyPr rtlCol="0" anchor="ctr" wrap="square"/>
-          <a:lstStyle/>
-          <a:p>
-            <a:pPr algn="ctr"/>
-            <a:r>
-              <a:rPr sz="1300" b="1">
-                <a:solidFill>
-                  <a:srgbClr val="0B1F33"/>
-                </a:solidFill>
-                <a:latin typeface="Calibri"/>
-              </a:rPr>
-              <a:t>Root .env</a:t>
-            </a:r>
-          </a:p>
-          <a:p>
-            <a:pPr algn="ctr"/>
-            <a:r>
-              <a:rPr sz="1100" b="0">
-                <a:solidFill>
-                  <a:srgbClr val="334155"/>
-                </a:solidFill>
-                <a:latin typeface="Calibri"/>
-              </a:rPr>
-              <a:t>AZURE_FOUNDRY_ CONNECTION_STRING</a:t>
-            </a:r>
-          </a:p>
-        </p:txBody>
-      </p:sp>
-      <p:sp>
-        <p:nvSpPr>
-          <p:cNvPr id="6" name="Rounded Rectangle 5"/>
-          <p:cNvSpPr/>
-          <p:nvPr/>
-        </p:nvSpPr>
-        <p:spPr>
-          <a:xfrm>
-            <a:off x="2743200" y="1828800"/>
-            <a:ext cx="2103120" cy="2011680"/>
-          </a:xfrm>
-          <a:prstGeom prst="roundRect">
-            <a:avLst>
-              <a:gd name="adj" fmla="val 12000"/>
-            </a:avLst>
-          </a:prstGeom>
-          <a:solidFill>
-            <a:srgbClr val="FFEDD5"/>
-          </a:solidFill>
-          <a:ln w="15875">
-            <a:solidFill>
-              <a:srgbClr val="C2410C"/>
-            </a:solidFill>
-          </a:ln>
-        </p:spPr>
-        <p:style>
-          <a:lnRef idx="1">
-            <a:schemeClr val="accent1"/>
-          </a:lnRef>
-          <a:fillRef idx="3">
-            <a:schemeClr val="accent1"/>
-          </a:fillRef>
-          <a:effectRef idx="2">
-            <a:schemeClr val="accent1"/>
-          </a:effectRef>
-          <a:fontRef idx="minor">
-            <a:schemeClr val="lt1"/>
-          </a:fontRef>
-        </p:style>
-        <p:txBody>
-          <a:bodyPr rtlCol="0" anchor="ctr" wrap="square"/>
-          <a:lstStyle/>
-          <a:p>
-            <a:pPr algn="ctr"/>
-            <a:r>
-              <a:rPr sz="1300" b="1">
-                <a:solidFill>
-                  <a:srgbClr val="0B1F33"/>
-                </a:solidFill>
-                <a:latin typeface="Calibri"/>
-              </a:rPr>
-              <a:t>Entra auth</a:t>
-            </a:r>
-          </a:p>
-          <a:p>
-            <a:pPr algn="ctr"/>
-            <a:r>
-              <a:rPr sz="1100" b="0">
-                <a:solidFill>
-                  <a:srgbClr val="334155"/>
-                </a:solidFill>
-                <a:latin typeface="Calibri"/>
-              </a:rPr>
-              <a:t>DefaultAzureCredential</a:t>
-            </a:r>
-          </a:p>
-        </p:txBody>
-      </p:sp>
-      <p:sp>
-        <p:nvSpPr>
-          <p:cNvPr id="7" name="Rounded Rectangle 6"/>
-          <p:cNvSpPr/>
-          <p:nvPr/>
-        </p:nvSpPr>
-        <p:spPr>
-          <a:xfrm>
-            <a:off x="5120640" y="1828800"/>
-            <a:ext cx="2103120" cy="2011680"/>
+            <a:off x="457200" y="1280160"/>
+            <a:ext cx="5486400" cy="4389120"/>
           </a:xfrm>
           <a:prstGeom prst="roundRect">
             <a:avLst>
@@ -7573,39 +8272,43 @@
           <a:p>
             <a:pPr algn="ctr"/>
             <a:r>
-              <a:rPr sz="1300" b="1">
+              <a:rPr sz="1500" b="1">
                 <a:solidFill>
                   <a:srgbClr val="0B1F33"/>
                 </a:solidFill>
                 <a:latin typeface="Calibri"/>
               </a:rPr>
-              <a:t>Wrap tools</a:t>
-            </a:r>
-          </a:p>
-          <a:p>
-            <a:pPr algn="ctr"/>
-            <a:r>
-              <a:rPr sz="1100" b="0">
+              <a:t>Structured / analytics</a:t>
+            </a:r>
+          </a:p>
+          <a:p>
+            <a:pPr algn="ctr"/>
+            <a:r>
+              <a:rPr sz="1300" b="0">
                 <a:solidFill>
                   <a:srgbClr val="334155"/>
                 </a:solidFill>
                 <a:latin typeface="Calibri"/>
               </a:rPr>
-              <a:t>FunctionTool ToolSet (7 MCP tools)</a:t>
-            </a:r>
-          </a:p>
-        </p:txBody>
-      </p:sp>
-      <p:sp>
-        <p:nvSpPr>
-          <p:cNvPr id="8" name="Rounded Rectangle 7"/>
+              <a:t>search_contracts
+get_contract_profile
+find_overlaps
+explain_contract_risk
+compare_contracts (N-way; hard-stop)</a:t>
+            </a:r>
+          </a:p>
+        </p:txBody>
+      </p:sp>
+      <p:sp>
+        <p:nvSpPr>
+          <p:cNvPr id="6" name="Rounded Rectangle 5"/>
           <p:cNvSpPr/>
           <p:nvPr/>
         </p:nvSpPr>
         <p:spPr>
           <a:xfrm>
-            <a:off x="7498079" y="1828800"/>
-            <a:ext cx="2103120" cy="2011680"/>
+            <a:off x="6309360" y="1280160"/>
+            <a:ext cx="5394960" cy="4389120"/>
           </a:xfrm>
           <a:prstGeom prst="roundRect">
             <a:avLst>
@@ -7641,349 +8344,36 @@
           <a:p>
             <a:pPr algn="ctr"/>
             <a:r>
-              <a:rPr sz="1300" b="1">
+              <a:rPr sz="1500" b="1">
                 <a:solidFill>
                   <a:srgbClr val="0B1F33"/>
                 </a:solidFill>
                 <a:latin typeface="Calibri"/>
               </a:rPr>
-              <a:t>create_agent</a:t>
-            </a:r>
-          </a:p>
-          <a:p>
-            <a:pPr algn="ctr"/>
-            <a:r>
-              <a:rPr sz="1100" b="0">
+              <a:t>Commercial / docs / health</a:t>
+            </a:r>
+          </a:p>
+          <a:p>
+            <a:pPr algn="ctr"/>
+            <a:r>
+              <a:rPr sz="1300" b="0">
                 <a:solidFill>
                   <a:srgbClr val="334155"/>
                 </a:solidFill>
                 <a:latin typeface="Calibri"/>
               </a:rPr>
-              <a:t>SYSTEM_PROMPT + OOS guardrail</a:t>
-            </a:r>
-          </a:p>
-        </p:txBody>
-      </p:sp>
-      <p:sp>
-        <p:nvSpPr>
-          <p:cNvPr id="9" name="Rounded Rectangle 8"/>
-          <p:cNvSpPr/>
-          <p:nvPr/>
-        </p:nvSpPr>
-        <p:spPr>
-          <a:xfrm>
-            <a:off x="9875520" y="1828800"/>
-            <a:ext cx="2103120" cy="2011680"/>
-          </a:xfrm>
-          <a:prstGeom prst="roundRect">
-            <a:avLst>
-              <a:gd name="adj" fmla="val 12000"/>
-            </a:avLst>
-          </a:prstGeom>
-          <a:solidFill>
-            <a:srgbClr val="EDE9FE"/>
-          </a:solidFill>
-          <a:ln w="15875">
-            <a:solidFill>
-              <a:srgbClr val="6D28D9"/>
-            </a:solidFill>
-          </a:ln>
-        </p:spPr>
-        <p:style>
-          <a:lnRef idx="1">
-            <a:schemeClr val="accent1"/>
-          </a:lnRef>
-          <a:fillRef idx="3">
-            <a:schemeClr val="accent1"/>
-          </a:fillRef>
-          <a:effectRef idx="2">
-            <a:schemeClr val="accent1"/>
-          </a:effectRef>
-          <a:fontRef idx="minor">
-            <a:schemeClr val="lt1"/>
-          </a:fontRef>
-        </p:style>
-        <p:txBody>
-          <a:bodyPr rtlCol="0" anchor="ctr" wrap="square"/>
-          <a:lstStyle/>
-          <a:p>
-            <a:pPr algn="ctr"/>
-            <a:r>
-              <a:rPr sz="1300" b="1">
-                <a:solidFill>
-                  <a:srgbClr val="0B1F33"/>
-                </a:solidFill>
-                <a:latin typeface="Calibri"/>
-              </a:rPr>
-              <a:t>Future host</a:t>
-            </a:r>
-          </a:p>
-          <a:p>
-            <a:pPr algn="ctr"/>
-            <a:r>
-              <a:rPr sz="1100" b="0">
-                <a:solidFill>
-                  <a:srgbClr val="334155"/>
-                </a:solidFill>
-                <a:latin typeface="Calibri"/>
-              </a:rPr>
-              <a:t>Teams / Foundry UI same tool contracts</a:t>
-            </a:r>
-          </a:p>
-        </p:txBody>
-      </p:sp>
-      <p:sp>
-        <p:nvSpPr>
-          <p:cNvPr id="10" name="Right Arrow 9"/>
-          <p:cNvSpPr/>
-          <p:nvPr/>
-        </p:nvSpPr>
-        <p:spPr>
-          <a:xfrm>
-            <a:off x="2514600" y="2743200"/>
-            <a:ext cx="201168" cy="182880"/>
-          </a:xfrm>
-          <a:prstGeom prst="rightArrow">
-            <a:avLst/>
-          </a:prstGeom>
-          <a:solidFill>
-            <a:srgbClr val="94A3B8"/>
-          </a:solidFill>
-          <a:ln>
-            <a:solidFill>
-              <a:srgbClr val="94A3B8"/>
-            </a:solidFill>
-          </a:ln>
-        </p:spPr>
-        <p:style>
-          <a:lnRef idx="1">
-            <a:schemeClr val="accent1"/>
-          </a:lnRef>
-          <a:fillRef idx="3">
-            <a:schemeClr val="accent1"/>
-          </a:fillRef>
-          <a:effectRef idx="2">
-            <a:schemeClr val="accent1"/>
-          </a:effectRef>
-          <a:fontRef idx="minor">
-            <a:schemeClr val="lt1"/>
-          </a:fontRef>
-        </p:style>
-        <p:txBody>
-          <a:bodyPr rtlCol="0" anchor="ctr"/>
-          <a:lstStyle/>
-          <a:p>
-            <a:pPr algn="ctr"/>
-          </a:p>
-        </p:txBody>
-      </p:sp>
-      <p:sp>
-        <p:nvSpPr>
-          <p:cNvPr id="11" name="Right Arrow 10"/>
-          <p:cNvSpPr/>
-          <p:nvPr/>
-        </p:nvSpPr>
-        <p:spPr>
-          <a:xfrm>
-            <a:off x="4892040" y="2743200"/>
-            <a:ext cx="201168" cy="182880"/>
-          </a:xfrm>
-          <a:prstGeom prst="rightArrow">
-            <a:avLst/>
-          </a:prstGeom>
-          <a:solidFill>
-            <a:srgbClr val="94A3B8"/>
-          </a:solidFill>
-          <a:ln>
-            <a:solidFill>
-              <a:srgbClr val="94A3B8"/>
-            </a:solidFill>
-          </a:ln>
-        </p:spPr>
-        <p:style>
-          <a:lnRef idx="1">
-            <a:schemeClr val="accent1"/>
-          </a:lnRef>
-          <a:fillRef idx="3">
-            <a:schemeClr val="accent1"/>
-          </a:fillRef>
-          <a:effectRef idx="2">
-            <a:schemeClr val="accent1"/>
-          </a:effectRef>
-          <a:fontRef idx="minor">
-            <a:schemeClr val="lt1"/>
-          </a:fontRef>
-        </p:style>
-        <p:txBody>
-          <a:bodyPr rtlCol="0" anchor="ctr"/>
-          <a:lstStyle/>
-          <a:p>
-            <a:pPr algn="ctr"/>
-          </a:p>
-        </p:txBody>
-      </p:sp>
-      <p:sp>
-        <p:nvSpPr>
-          <p:cNvPr id="12" name="Right Arrow 11"/>
-          <p:cNvSpPr/>
-          <p:nvPr/>
-        </p:nvSpPr>
-        <p:spPr>
-          <a:xfrm>
-            <a:off x="7269480" y="2743200"/>
-            <a:ext cx="201168" cy="182880"/>
-          </a:xfrm>
-          <a:prstGeom prst="rightArrow">
-            <a:avLst/>
-          </a:prstGeom>
-          <a:solidFill>
-            <a:srgbClr val="94A3B8"/>
-          </a:solidFill>
-          <a:ln>
-            <a:solidFill>
-              <a:srgbClr val="94A3B8"/>
-            </a:solidFill>
-          </a:ln>
-        </p:spPr>
-        <p:style>
-          <a:lnRef idx="1">
-            <a:schemeClr val="accent1"/>
-          </a:lnRef>
-          <a:fillRef idx="3">
-            <a:schemeClr val="accent1"/>
-          </a:fillRef>
-          <a:effectRef idx="2">
-            <a:schemeClr val="accent1"/>
-          </a:effectRef>
-          <a:fontRef idx="minor">
-            <a:schemeClr val="lt1"/>
-          </a:fontRef>
-        </p:style>
-        <p:txBody>
-          <a:bodyPr rtlCol="0" anchor="ctr"/>
-          <a:lstStyle/>
-          <a:p>
-            <a:pPr algn="ctr"/>
-          </a:p>
-        </p:txBody>
-      </p:sp>
-      <p:sp>
-        <p:nvSpPr>
-          <p:cNvPr id="13" name="Right Arrow 12"/>
-          <p:cNvSpPr/>
-          <p:nvPr/>
-        </p:nvSpPr>
-        <p:spPr>
-          <a:xfrm>
-            <a:off x="9646920" y="2743200"/>
-            <a:ext cx="201168" cy="182880"/>
-          </a:xfrm>
-          <a:prstGeom prst="rightArrow">
-            <a:avLst/>
-          </a:prstGeom>
-          <a:solidFill>
-            <a:srgbClr val="94A3B8"/>
-          </a:solidFill>
-          <a:ln>
-            <a:solidFill>
-              <a:srgbClr val="94A3B8"/>
-            </a:solidFill>
-          </a:ln>
-        </p:spPr>
-        <p:style>
-          <a:lnRef idx="1">
-            <a:schemeClr val="accent1"/>
-          </a:lnRef>
-          <a:fillRef idx="3">
-            <a:schemeClr val="accent1"/>
-          </a:fillRef>
-          <a:effectRef idx="2">
-            <a:schemeClr val="accent1"/>
-          </a:effectRef>
-          <a:fontRef idx="minor">
-            <a:schemeClr val="lt1"/>
-          </a:fontRef>
-        </p:style>
-        <p:txBody>
-          <a:bodyPr rtlCol="0" anchor="ctr"/>
-          <a:lstStyle/>
-          <a:p>
-            <a:pPr algn="ctr"/>
-          </a:p>
-        </p:txBody>
-      </p:sp>
-      <p:sp>
-        <p:nvSpPr>
-          <p:cNvPr id="14" name="Rounded Rectangle 13"/>
-          <p:cNvSpPr/>
-          <p:nvPr/>
-        </p:nvSpPr>
-        <p:spPr>
-          <a:xfrm>
-            <a:off x="457200" y="4206240"/>
-            <a:ext cx="11247120" cy="1645920"/>
-          </a:xfrm>
-          <a:prstGeom prst="roundRect">
-            <a:avLst>
-              <a:gd name="adj" fmla="val 12000"/>
-            </a:avLst>
-          </a:prstGeom>
-          <a:solidFill>
-            <a:srgbClr val="F1F5F9"/>
-          </a:solidFill>
-          <a:ln w="15875">
-            <a:solidFill>
-              <a:srgbClr val="94A3B8"/>
-            </a:solidFill>
-          </a:ln>
-        </p:spPr>
-        <p:style>
-          <a:lnRef idx="1">
-            <a:schemeClr val="accent1"/>
-          </a:lnRef>
-          <a:fillRef idx="3">
-            <a:schemeClr val="accent1"/>
-          </a:fillRef>
-          <a:effectRef idx="2">
-            <a:schemeClr val="accent1"/>
-          </a:effectRef>
-          <a:fontRef idx="minor">
-            <a:schemeClr val="lt1"/>
-          </a:fontRef>
-        </p:style>
-        <p:txBody>
-          <a:bodyPr rtlCol="0" anchor="ctr" wrap="square"/>
-          <a:lstStyle/>
-          <a:p>
-            <a:pPr algn="ctr"/>
-            <a:r>
-              <a:rPr sz="1400" b="1">
-                <a:solidFill>
-                  <a:srgbClr val="0B1F33"/>
-                </a:solidFill>
-                <a:latin typeface="Calibri"/>
-              </a:rPr>
-              <a:t>Deploy script ToolSet (aligned with POC structured surface)</a:t>
-            </a:r>
-          </a:p>
-          <a:p>
-            <a:pPr algn="ctr"/>
-            <a:r>
-              <a:rPr sz="1200" b="0">
-                <a:solidFill>
-                  <a:srgbClr val="334155"/>
-                </a:solidFill>
-                <a:latin typeface="Calibri"/>
-              </a:rPr>
-              <a:t>search_contracts · get_contract_profile · get_expiring_contracts · get_vendor_spend_summary · find_overlaps · explain_contract_risk · search_cloud_blob_contracts
-Current demos still use Flask + FastMCP locally; Foundry is optional hosting for the same tools.</a:t>
-            </a:r>
-          </a:p>
-        </p:txBody>
-      </p:sp>
-      <p:sp>
-        <p:nvSpPr>
-          <p:cNvPr id="15" name="TextBox 14"/>
+              <a:t>check_missing_contract_fields
+get_expiring_contracts
+get_vendor_spend_summary (ACV rollup only)
+search_cloud_blob_contracts (docs)
+fabric_health_check</a:t>
+            </a:r>
+          </a:p>
+        </p:txBody>
+      </p:sp>
+      <p:sp>
+        <p:nvSpPr>
+          <p:cNvPr id="7" name="TextBox 6"/>
           <p:cNvSpPr txBox="1"/>
           <p:nvPr/>
         </p:nvSpPr>

</xml_diff>

<commit_message>
feat: delete prior conversations and remove Foundry deploy code
Add persona-scoped conversation delete (store, Flask APIs, Streamlit
sidebar) and strip Azure AI Foundry deploy script, guide, and deps for a
clean local Streamlit → Flask → MCP POC copy.

Co-authored-by: booshank <booshank@users.noreply.github.com>
</commit_message>
<xml_diff>
--- a/docs/VAL_CoPilot_Architecture_and_Process_Flow.pptx
+++ b/docs/VAL_CoPilot_Architecture_and_Process_Flow.pptx
@@ -15,7 +15,6 @@
     <p:sldId id="263" r:id="rId14"/>
     <p:sldId id="264" r:id="rId15"/>
     <p:sldId id="265" r:id="rId16"/>
-    <p:sldId id="266" r:id="rId17"/>
   </p:sldIdLst>
   <p:sldSz cx="12191695" cy="6858000" type="screen4x3"/>
   <p:notesSz cx="6858000" cy="9144000"/>
@@ -3301,7 +3300,7 @@
                 </a:solidFill>
                 <a:latin typeface="Calibri"/>
               </a:rPr>
-              <a:t>Future: Streamlit/Teams → Azure AI Foundry Agent → same MCP/API tools → live LinkSquares later</a:t>
+              <a:t>Persona memory: save / pin / filter / recall / delete prior searches and conversations</a:t>
             </a:r>
           </a:p>
           <a:p>
@@ -3313,7 +3312,7 @@
                 </a:solidFill>
                 <a:latin typeface="Calibri"/>
               </a:rPr>
-              <a:t>Compare hard-stop when IDs missing · Invoice/actual-spend OOS · Not Foundry-first today</a:t>
+              <a:t>Compare hard-stop when IDs missing · Invoice/actual-spend OOS</a:t>
             </a:r>
           </a:p>
         </p:txBody>
@@ -3410,7 +3409,7 @@
                 </a:solidFill>
                 <a:latin typeface="Calibri"/>
               </a:rPr>
-              <a:t>8. Optional Future — Azure AI Foundry Deploy</a:t>
+              <a:t>8. Demo-Ready Slice Summary</a:t>
             </a:r>
           </a:p>
         </p:txBody>
@@ -3444,7 +3443,7 @@
                 </a:solidFill>
                 <a:latin typeface="Calibri"/>
               </a:rPr>
-              <a:t>deploy_to_foundry.py is optional; current POC does not require Foundry</a:t>
+              <a:t>Reliable · safe · synthetic</a:t>
             </a:r>
           </a:p>
         </p:txBody>
@@ -3457,8 +3456,232 @@
         </p:nvSpPr>
         <p:spPr>
           <a:xfrm>
-            <a:off x="365760" y="1828800"/>
-            <a:ext cx="2103120" cy="2011680"/>
+            <a:off x="457200" y="1143000"/>
+            <a:ext cx="2377440" cy="777240"/>
+          </a:xfrm>
+          <a:prstGeom prst="roundRect">
+            <a:avLst>
+              <a:gd name="adj" fmla="val 12000"/>
+            </a:avLst>
+          </a:prstGeom>
+          <a:solidFill>
+            <a:srgbClr val="FEE2E2"/>
+          </a:solidFill>
+          <a:ln w="15875">
+            <a:solidFill>
+              <a:srgbClr val="B91C1C"/>
+            </a:solidFill>
+          </a:ln>
+        </p:spPr>
+        <p:style>
+          <a:lnRef idx="1">
+            <a:schemeClr val="accent1"/>
+          </a:lnRef>
+          <a:fillRef idx="3">
+            <a:schemeClr val="accent1"/>
+          </a:fillRef>
+          <a:effectRef idx="2">
+            <a:schemeClr val="accent1"/>
+          </a:effectRef>
+          <a:fontRef idx="minor">
+            <a:schemeClr val="lt1"/>
+          </a:fontRef>
+        </p:style>
+        <p:txBody>
+          <a:bodyPr rtlCol="0" anchor="ctr" wrap="square"/>
+          <a:lstStyle/>
+          <a:p>
+            <a:pPr algn="ctr"/>
+            <a:r>
+              <a:rPr sz="1400" b="1">
+                <a:solidFill>
+                  <a:srgbClr val="B91C1C"/>
+                </a:solidFill>
+                <a:latin typeface="Calibri"/>
+              </a:rPr>
+              <a:t>Safe</a:t>
+            </a:r>
+          </a:p>
+        </p:txBody>
+      </p:sp>
+      <p:sp>
+        <p:nvSpPr>
+          <p:cNvPr id="6" name="Rounded Rectangle 5"/>
+          <p:cNvSpPr/>
+          <p:nvPr/>
+        </p:nvSpPr>
+        <p:spPr>
+          <a:xfrm>
+            <a:off x="3017520" y="1143000"/>
+            <a:ext cx="8686800" cy="777240"/>
+          </a:xfrm>
+          <a:prstGeom prst="roundRect">
+            <a:avLst>
+              <a:gd name="adj" fmla="val 12000"/>
+            </a:avLst>
+          </a:prstGeom>
+          <a:solidFill>
+            <a:srgbClr val="FFFFFF"/>
+          </a:solidFill>
+          <a:ln w="15875">
+            <a:solidFill>
+              <a:srgbClr val="B91C1C"/>
+            </a:solidFill>
+          </a:ln>
+        </p:spPr>
+        <p:style>
+          <a:lnRef idx="1">
+            <a:schemeClr val="accent1"/>
+          </a:lnRef>
+          <a:fillRef idx="3">
+            <a:schemeClr val="accent1"/>
+          </a:fillRef>
+          <a:effectRef idx="2">
+            <a:schemeClr val="accent1"/>
+          </a:effectRef>
+          <a:fontRef idx="minor">
+            <a:schemeClr val="lt1"/>
+          </a:fontRef>
+        </p:style>
+        <p:txBody>
+          <a:bodyPr rtlCol="0" anchor="ctr" wrap="square"/>
+          <a:lstStyle/>
+          <a:p>
+            <a:pPr algn="ctr"/>
+            <a:r>
+              <a:rPr sz="1300" b="1">
+                <a:solidFill>
+                  <a:srgbClr val="0B1F33"/>
+                </a:solidFill>
+                <a:latin typeface="Calibri"/>
+              </a:rPr>
+              <a:t>Invoice OOS + compare hard-stop (exact messages; no default CON-* pair)</a:t>
+            </a:r>
+          </a:p>
+        </p:txBody>
+      </p:sp>
+      <p:sp>
+        <p:nvSpPr>
+          <p:cNvPr id="7" name="Rounded Rectangle 6"/>
+          <p:cNvSpPr/>
+          <p:nvPr/>
+        </p:nvSpPr>
+        <p:spPr>
+          <a:xfrm>
+            <a:off x="457200" y="2103120"/>
+            <a:ext cx="2377440" cy="777240"/>
+          </a:xfrm>
+          <a:prstGeom prst="roundRect">
+            <a:avLst>
+              <a:gd name="adj" fmla="val 12000"/>
+            </a:avLst>
+          </a:prstGeom>
+          <a:solidFill>
+            <a:srgbClr val="D1FAE5"/>
+          </a:solidFill>
+          <a:ln w="15875">
+            <a:solidFill>
+              <a:srgbClr val="047857"/>
+            </a:solidFill>
+          </a:ln>
+        </p:spPr>
+        <p:style>
+          <a:lnRef idx="1">
+            <a:schemeClr val="accent1"/>
+          </a:lnRef>
+          <a:fillRef idx="3">
+            <a:schemeClr val="accent1"/>
+          </a:fillRef>
+          <a:effectRef idx="2">
+            <a:schemeClr val="accent1"/>
+          </a:effectRef>
+          <a:fontRef idx="minor">
+            <a:schemeClr val="lt1"/>
+          </a:fontRef>
+        </p:style>
+        <p:txBody>
+          <a:bodyPr rtlCol="0" anchor="ctr" wrap="square"/>
+          <a:lstStyle/>
+          <a:p>
+            <a:pPr algn="ctr"/>
+            <a:r>
+              <a:rPr sz="1400" b="1">
+                <a:solidFill>
+                  <a:srgbClr val="047857"/>
+                </a:solidFill>
+                <a:latin typeface="Calibri"/>
+              </a:rPr>
+              <a:t>Structured tools</a:t>
+            </a:r>
+          </a:p>
+        </p:txBody>
+      </p:sp>
+      <p:sp>
+        <p:nvSpPr>
+          <p:cNvPr id="8" name="Rounded Rectangle 7"/>
+          <p:cNvSpPr/>
+          <p:nvPr/>
+        </p:nvSpPr>
+        <p:spPr>
+          <a:xfrm>
+            <a:off x="3017520" y="2103120"/>
+            <a:ext cx="8686800" cy="777240"/>
+          </a:xfrm>
+          <a:prstGeom prst="roundRect">
+            <a:avLst>
+              <a:gd name="adj" fmla="val 12000"/>
+            </a:avLst>
+          </a:prstGeom>
+          <a:solidFill>
+            <a:srgbClr val="FFFFFF"/>
+          </a:solidFill>
+          <a:ln w="15875">
+            <a:solidFill>
+              <a:srgbClr val="047857"/>
+            </a:solidFill>
+          </a:ln>
+        </p:spPr>
+        <p:style>
+          <a:lnRef idx="1">
+            <a:schemeClr val="accent1"/>
+          </a:lnRef>
+          <a:fillRef idx="3">
+            <a:schemeClr val="accent1"/>
+          </a:fillRef>
+          <a:effectRef idx="2">
+            <a:schemeClr val="accent1"/>
+          </a:effectRef>
+          <a:fontRef idx="minor">
+            <a:schemeClr val="lt1"/>
+          </a:fontRef>
+        </p:style>
+        <p:txBody>
+          <a:bodyPr rtlCol="0" anchor="ctr" wrap="square"/>
+          <a:lstStyle/>
+          <a:p>
+            <a:pPr algn="ctr"/>
+            <a:r>
+              <a:rPr sz="1300" b="1">
+                <a:solidFill>
+                  <a:srgbClr val="0B1F33"/>
+                </a:solidFill>
+                <a:latin typeface="Calibri"/>
+              </a:rPr>
+              <a:t>search / profile / N-way compare / overlaps / risk via ContractRepository</a:t>
+            </a:r>
+          </a:p>
+        </p:txBody>
+      </p:sp>
+      <p:sp>
+        <p:nvSpPr>
+          <p:cNvPr id="9" name="Rounded Rectangle 8"/>
+          <p:cNvSpPr/>
+          <p:nvPr/>
+        </p:nvSpPr>
+        <p:spPr>
+          <a:xfrm>
+            <a:off x="457200" y="3063240"/>
+            <a:ext cx="2377440" cy="777240"/>
           </a:xfrm>
           <a:prstGeom prst="roundRect">
             <a:avLst>
@@ -3494,39 +3717,27 @@
           <a:p>
             <a:pPr algn="ctr"/>
             <a:r>
-              <a:rPr sz="1300" b="1">
-                <a:solidFill>
-                  <a:srgbClr val="0B1F33"/>
-                </a:solidFill>
-                <a:latin typeface="Calibri"/>
-              </a:rPr>
-              <a:t>Root .env</a:t>
-            </a:r>
-          </a:p>
-          <a:p>
-            <a:pPr algn="ctr"/>
-            <a:r>
-              <a:rPr sz="1100" b="0">
-                <a:solidFill>
-                  <a:srgbClr val="334155"/>
-                </a:solidFill>
-                <a:latin typeface="Calibri"/>
-              </a:rPr>
-              <a:t>AZURE_FOUNDRY_ CONNECTION_STRING</a:t>
-            </a:r>
-          </a:p>
-        </p:txBody>
-      </p:sp>
-      <p:sp>
-        <p:nvSpPr>
-          <p:cNvPr id="6" name="Rounded Rectangle 5"/>
+              <a:rPr sz="1400" b="1">
+                <a:solidFill>
+                  <a:srgbClr val="0E6B6B"/>
+                </a:solidFill>
+                <a:latin typeface="Calibri"/>
+              </a:rPr>
+              <a:t>Persona memory</a:t>
+            </a:r>
+          </a:p>
+        </p:txBody>
+      </p:sp>
+      <p:sp>
+        <p:nvSpPr>
+          <p:cNvPr id="10" name="Rounded Rectangle 9"/>
           <p:cNvSpPr/>
           <p:nvPr/>
         </p:nvSpPr>
         <p:spPr>
           <a:xfrm>
-            <a:off x="2743200" y="1828800"/>
-            <a:ext cx="2103120" cy="2011680"/>
+            <a:off x="3017520" y="3063240"/>
+            <a:ext cx="8686800" cy="777240"/>
           </a:xfrm>
           <a:prstGeom prst="roundRect">
             <a:avLst>
@@ -3534,11 +3745,11 @@
             </a:avLst>
           </a:prstGeom>
           <a:solidFill>
-            <a:srgbClr val="FFEDD5"/>
+            <a:srgbClr val="FFFFFF"/>
           </a:solidFill>
           <a:ln w="15875">
             <a:solidFill>
-              <a:srgbClr val="C2410C"/>
+              <a:srgbClr val="0E6B6B"/>
             </a:solidFill>
           </a:ln>
         </p:spPr>
@@ -3568,169 +3779,21 @@
                 </a:solidFill>
                 <a:latin typeface="Calibri"/>
               </a:rPr>
-              <a:t>Entra auth</a:t>
-            </a:r>
-          </a:p>
-          <a:p>
-            <a:pPr algn="ctr"/>
-            <a:r>
-              <a:rPr sz="1100" b="0">
-                <a:solidFill>
-                  <a:srgbClr val="334155"/>
-                </a:solidFill>
-                <a:latin typeface="Calibri"/>
-              </a:rPr>
-              <a:t>DefaultAzureCredential</a:t>
-            </a:r>
-          </a:p>
-        </p:txBody>
-      </p:sp>
-      <p:sp>
-        <p:nvSpPr>
-          <p:cNvPr id="7" name="Rounded Rectangle 6"/>
+              <a:t>SQLite save / pin / filter / recall / delete searches and conversations</a:t>
+            </a:r>
+          </a:p>
+        </p:txBody>
+      </p:sp>
+      <p:sp>
+        <p:nvSpPr>
+          <p:cNvPr id="11" name="Rounded Rectangle 10"/>
           <p:cNvSpPr/>
           <p:nvPr/>
         </p:nvSpPr>
         <p:spPr>
           <a:xfrm>
-            <a:off x="5120640" y="1828800"/>
-            <a:ext cx="2103120" cy="2011680"/>
-          </a:xfrm>
-          <a:prstGeom prst="roundRect">
-            <a:avLst>
-              <a:gd name="adj" fmla="val 12000"/>
-            </a:avLst>
-          </a:prstGeom>
-          <a:solidFill>
-            <a:srgbClr val="D1FAE5"/>
-          </a:solidFill>
-          <a:ln w="15875">
-            <a:solidFill>
-              <a:srgbClr val="047857"/>
-            </a:solidFill>
-          </a:ln>
-        </p:spPr>
-        <p:style>
-          <a:lnRef idx="1">
-            <a:schemeClr val="accent1"/>
-          </a:lnRef>
-          <a:fillRef idx="3">
-            <a:schemeClr val="accent1"/>
-          </a:fillRef>
-          <a:effectRef idx="2">
-            <a:schemeClr val="accent1"/>
-          </a:effectRef>
-          <a:fontRef idx="minor">
-            <a:schemeClr val="lt1"/>
-          </a:fontRef>
-        </p:style>
-        <p:txBody>
-          <a:bodyPr rtlCol="0" anchor="ctr" wrap="square"/>
-          <a:lstStyle/>
-          <a:p>
-            <a:pPr algn="ctr"/>
-            <a:r>
-              <a:rPr sz="1300" b="1">
-                <a:solidFill>
-                  <a:srgbClr val="0B1F33"/>
-                </a:solidFill>
-                <a:latin typeface="Calibri"/>
-              </a:rPr>
-              <a:t>Wrap tools</a:t>
-            </a:r>
-          </a:p>
-          <a:p>
-            <a:pPr algn="ctr"/>
-            <a:r>
-              <a:rPr sz="1100" b="0">
-                <a:solidFill>
-                  <a:srgbClr val="334155"/>
-                </a:solidFill>
-                <a:latin typeface="Calibri"/>
-              </a:rPr>
-              <a:t>FunctionTool ToolSet (7 MCP tools)</a:t>
-            </a:r>
-          </a:p>
-        </p:txBody>
-      </p:sp>
-      <p:sp>
-        <p:nvSpPr>
-          <p:cNvPr id="8" name="Rounded Rectangle 7"/>
-          <p:cNvSpPr/>
-          <p:nvPr/>
-        </p:nvSpPr>
-        <p:spPr>
-          <a:xfrm>
-            <a:off x="7498079" y="1828800"/>
-            <a:ext cx="2103120" cy="2011680"/>
-          </a:xfrm>
-          <a:prstGeom prst="roundRect">
-            <a:avLst>
-              <a:gd name="adj" fmla="val 12000"/>
-            </a:avLst>
-          </a:prstGeom>
-          <a:solidFill>
-            <a:srgbClr val="DBEAFE"/>
-          </a:solidFill>
-          <a:ln w="15875">
-            <a:solidFill>
-              <a:srgbClr val="1D4ED8"/>
-            </a:solidFill>
-          </a:ln>
-        </p:spPr>
-        <p:style>
-          <a:lnRef idx="1">
-            <a:schemeClr val="accent1"/>
-          </a:lnRef>
-          <a:fillRef idx="3">
-            <a:schemeClr val="accent1"/>
-          </a:fillRef>
-          <a:effectRef idx="2">
-            <a:schemeClr val="accent1"/>
-          </a:effectRef>
-          <a:fontRef idx="minor">
-            <a:schemeClr val="lt1"/>
-          </a:fontRef>
-        </p:style>
-        <p:txBody>
-          <a:bodyPr rtlCol="0" anchor="ctr" wrap="square"/>
-          <a:lstStyle/>
-          <a:p>
-            <a:pPr algn="ctr"/>
-            <a:r>
-              <a:rPr sz="1300" b="1">
-                <a:solidFill>
-                  <a:srgbClr val="0B1F33"/>
-                </a:solidFill>
-                <a:latin typeface="Calibri"/>
-              </a:rPr>
-              <a:t>create_agent</a:t>
-            </a:r>
-          </a:p>
-          <a:p>
-            <a:pPr algn="ctr"/>
-            <a:r>
-              <a:rPr sz="1100" b="0">
-                <a:solidFill>
-                  <a:srgbClr val="334155"/>
-                </a:solidFill>
-                <a:latin typeface="Calibri"/>
-              </a:rPr>
-              <a:t>SYSTEM_PROMPT hard-stop + OOS</a:t>
-            </a:r>
-          </a:p>
-        </p:txBody>
-      </p:sp>
-      <p:sp>
-        <p:nvSpPr>
-          <p:cNvPr id="9" name="Rounded Rectangle 8"/>
-          <p:cNvSpPr/>
-          <p:nvPr/>
-        </p:nvSpPr>
-        <p:spPr>
-          <a:xfrm>
-            <a:off x="9875520" y="1828800"/>
-            <a:ext cx="2103120" cy="2011680"/>
+            <a:off x="457200" y="4023360"/>
+            <a:ext cx="2377440" cy="777240"/>
           </a:xfrm>
           <a:prstGeom prst="roundRect">
             <a:avLst>
@@ -3766,825 +3829,6 @@
           <a:p>
             <a:pPr algn="ctr"/>
             <a:r>
-              <a:rPr sz="1300" b="1">
-                <a:solidFill>
-                  <a:srgbClr val="0B1F33"/>
-                </a:solidFill>
-                <a:latin typeface="Calibri"/>
-              </a:rPr>
-              <a:t>Future host</a:t>
-            </a:r>
-          </a:p>
-          <a:p>
-            <a:pPr algn="ctr"/>
-            <a:r>
-              <a:rPr sz="1100" b="0">
-                <a:solidFill>
-                  <a:srgbClr val="334155"/>
-                </a:solidFill>
-                <a:latin typeface="Calibri"/>
-              </a:rPr>
-              <a:t>Teams / Foundry UI extend ToolSet</a:t>
-            </a:r>
-          </a:p>
-        </p:txBody>
-      </p:sp>
-      <p:sp>
-        <p:nvSpPr>
-          <p:cNvPr id="10" name="Right Arrow 9"/>
-          <p:cNvSpPr/>
-          <p:nvPr/>
-        </p:nvSpPr>
-        <p:spPr>
-          <a:xfrm>
-            <a:off x="2514600" y="2743200"/>
-            <a:ext cx="201168" cy="182880"/>
-          </a:xfrm>
-          <a:prstGeom prst="rightArrow">
-            <a:avLst/>
-          </a:prstGeom>
-          <a:solidFill>
-            <a:srgbClr val="94A3B8"/>
-          </a:solidFill>
-          <a:ln>
-            <a:solidFill>
-              <a:srgbClr val="94A3B8"/>
-            </a:solidFill>
-          </a:ln>
-        </p:spPr>
-        <p:style>
-          <a:lnRef idx="1">
-            <a:schemeClr val="accent1"/>
-          </a:lnRef>
-          <a:fillRef idx="3">
-            <a:schemeClr val="accent1"/>
-          </a:fillRef>
-          <a:effectRef idx="2">
-            <a:schemeClr val="accent1"/>
-          </a:effectRef>
-          <a:fontRef idx="minor">
-            <a:schemeClr val="lt1"/>
-          </a:fontRef>
-        </p:style>
-        <p:txBody>
-          <a:bodyPr rtlCol="0" anchor="ctr"/>
-          <a:lstStyle/>
-          <a:p>
-            <a:pPr algn="ctr"/>
-          </a:p>
-        </p:txBody>
-      </p:sp>
-      <p:sp>
-        <p:nvSpPr>
-          <p:cNvPr id="11" name="Right Arrow 10"/>
-          <p:cNvSpPr/>
-          <p:nvPr/>
-        </p:nvSpPr>
-        <p:spPr>
-          <a:xfrm>
-            <a:off x="4892040" y="2743200"/>
-            <a:ext cx="201168" cy="182880"/>
-          </a:xfrm>
-          <a:prstGeom prst="rightArrow">
-            <a:avLst/>
-          </a:prstGeom>
-          <a:solidFill>
-            <a:srgbClr val="94A3B8"/>
-          </a:solidFill>
-          <a:ln>
-            <a:solidFill>
-              <a:srgbClr val="94A3B8"/>
-            </a:solidFill>
-          </a:ln>
-        </p:spPr>
-        <p:style>
-          <a:lnRef idx="1">
-            <a:schemeClr val="accent1"/>
-          </a:lnRef>
-          <a:fillRef idx="3">
-            <a:schemeClr val="accent1"/>
-          </a:fillRef>
-          <a:effectRef idx="2">
-            <a:schemeClr val="accent1"/>
-          </a:effectRef>
-          <a:fontRef idx="minor">
-            <a:schemeClr val="lt1"/>
-          </a:fontRef>
-        </p:style>
-        <p:txBody>
-          <a:bodyPr rtlCol="0" anchor="ctr"/>
-          <a:lstStyle/>
-          <a:p>
-            <a:pPr algn="ctr"/>
-          </a:p>
-        </p:txBody>
-      </p:sp>
-      <p:sp>
-        <p:nvSpPr>
-          <p:cNvPr id="12" name="Right Arrow 11"/>
-          <p:cNvSpPr/>
-          <p:nvPr/>
-        </p:nvSpPr>
-        <p:spPr>
-          <a:xfrm>
-            <a:off x="7269480" y="2743200"/>
-            <a:ext cx="201168" cy="182880"/>
-          </a:xfrm>
-          <a:prstGeom prst="rightArrow">
-            <a:avLst/>
-          </a:prstGeom>
-          <a:solidFill>
-            <a:srgbClr val="94A3B8"/>
-          </a:solidFill>
-          <a:ln>
-            <a:solidFill>
-              <a:srgbClr val="94A3B8"/>
-            </a:solidFill>
-          </a:ln>
-        </p:spPr>
-        <p:style>
-          <a:lnRef idx="1">
-            <a:schemeClr val="accent1"/>
-          </a:lnRef>
-          <a:fillRef idx="3">
-            <a:schemeClr val="accent1"/>
-          </a:fillRef>
-          <a:effectRef idx="2">
-            <a:schemeClr val="accent1"/>
-          </a:effectRef>
-          <a:fontRef idx="minor">
-            <a:schemeClr val="lt1"/>
-          </a:fontRef>
-        </p:style>
-        <p:txBody>
-          <a:bodyPr rtlCol="0" anchor="ctr"/>
-          <a:lstStyle/>
-          <a:p>
-            <a:pPr algn="ctr"/>
-          </a:p>
-        </p:txBody>
-      </p:sp>
-      <p:sp>
-        <p:nvSpPr>
-          <p:cNvPr id="13" name="Right Arrow 12"/>
-          <p:cNvSpPr/>
-          <p:nvPr/>
-        </p:nvSpPr>
-        <p:spPr>
-          <a:xfrm>
-            <a:off x="9646920" y="2743200"/>
-            <a:ext cx="201168" cy="182880"/>
-          </a:xfrm>
-          <a:prstGeom prst="rightArrow">
-            <a:avLst/>
-          </a:prstGeom>
-          <a:solidFill>
-            <a:srgbClr val="94A3B8"/>
-          </a:solidFill>
-          <a:ln>
-            <a:solidFill>
-              <a:srgbClr val="94A3B8"/>
-            </a:solidFill>
-          </a:ln>
-        </p:spPr>
-        <p:style>
-          <a:lnRef idx="1">
-            <a:schemeClr val="accent1"/>
-          </a:lnRef>
-          <a:fillRef idx="3">
-            <a:schemeClr val="accent1"/>
-          </a:fillRef>
-          <a:effectRef idx="2">
-            <a:schemeClr val="accent1"/>
-          </a:effectRef>
-          <a:fontRef idx="minor">
-            <a:schemeClr val="lt1"/>
-          </a:fontRef>
-        </p:style>
-        <p:txBody>
-          <a:bodyPr rtlCol="0" anchor="ctr"/>
-          <a:lstStyle/>
-          <a:p>
-            <a:pPr algn="ctr"/>
-          </a:p>
-        </p:txBody>
-      </p:sp>
-      <p:sp>
-        <p:nvSpPr>
-          <p:cNvPr id="14" name="Rounded Rectangle 13"/>
-          <p:cNvSpPr/>
-          <p:nvPr/>
-        </p:nvSpPr>
-        <p:spPr>
-          <a:xfrm>
-            <a:off x="457200" y="4206240"/>
-            <a:ext cx="11247120" cy="1645920"/>
-          </a:xfrm>
-          <a:prstGeom prst="roundRect">
-            <a:avLst>
-              <a:gd name="adj" fmla="val 12000"/>
-            </a:avLst>
-          </a:prstGeom>
-          <a:solidFill>
-            <a:srgbClr val="F1F5F9"/>
-          </a:solidFill>
-          <a:ln w="15875">
-            <a:solidFill>
-              <a:srgbClr val="94A3B8"/>
-            </a:solidFill>
-          </a:ln>
-        </p:spPr>
-        <p:style>
-          <a:lnRef idx="1">
-            <a:schemeClr val="accent1"/>
-          </a:lnRef>
-          <a:fillRef idx="3">
-            <a:schemeClr val="accent1"/>
-          </a:fillRef>
-          <a:effectRef idx="2">
-            <a:schemeClr val="accent1"/>
-          </a:effectRef>
-          <a:fontRef idx="minor">
-            <a:schemeClr val="lt1"/>
-          </a:fontRef>
-        </p:style>
-        <p:txBody>
-          <a:bodyPr rtlCol="0" anchor="ctr" wrap="square"/>
-          <a:lstStyle/>
-          <a:p>
-            <a:pPr algn="ctr"/>
-            <a:r>
-              <a:rPr sz="1300" b="1">
-                <a:solidFill>
-                  <a:srgbClr val="0B1F33"/>
-                </a:solidFill>
-                <a:latin typeface="Calibri"/>
-              </a:rPr>
-              <a:t>Deploy script ToolSet today (7 tools) — extend next to full MCP inventory</a:t>
-            </a:r>
-          </a:p>
-          <a:p>
-            <a:pPr algn="ctr"/>
-            <a:r>
-              <a:rPr sz="1100" b="0">
-                <a:solidFill>
-                  <a:srgbClr val="334155"/>
-                </a:solidFill>
-                <a:latin typeface="Calibri"/>
-              </a:rPr>
-              <a:t>search_contracts · get_contract_profile · get_expiring_contracts · get_vendor_spend_summary · find_overlaps · explain_contract_risk · search_cloud_blob_contracts
-Local FastMCP also has compare_contracts + check_missing_contract_fields. SYSTEM_PROMPT encodes compare hard-stop + persona-memory guidance.</a:t>
-            </a:r>
-          </a:p>
-        </p:txBody>
-      </p:sp>
-      <p:sp>
-        <p:nvSpPr>
-          <p:cNvPr id="15" name="TextBox 14"/>
-          <p:cNvSpPr txBox="1"/>
-          <p:nvPr/>
-        </p:nvSpPr>
-        <p:spPr>
-          <a:xfrm>
-            <a:off x="365760" y="6492240"/>
-            <a:ext cx="11430000" cy="274320"/>
-          </a:xfrm>
-          <a:prstGeom prst="rect">
-            <a:avLst/>
-          </a:prstGeom>
-          <a:noFill/>
-        </p:spPr>
-        <p:txBody>
-          <a:bodyPr wrap="none">
-            <a:spAutoFit/>
-          </a:bodyPr>
-          <a:lstStyle/>
-          <a:p>
-            <a:pPr algn="ctr"/>
-            <a:r>
-              <a:rPr sz="900" b="0">
-                <a:solidFill>
-                  <a:srgbClr val="94A3B8"/>
-                </a:solidFill>
-                <a:latin typeface="Calibri"/>
-              </a:rPr>
-              <a:t>Synthetic Contract Intelligence Tool-Layer POC · Slide 10</a:t>
-            </a:r>
-          </a:p>
-        </p:txBody>
-      </p:sp>
-    </p:spTree>
-  </p:cSld>
-  <p:clrMapOvr>
-    <a:masterClrMapping/>
-  </p:clrMapOvr>
-</p:sld>
-</file>
-
-<file path=ppt/slides/slide11.xml><?xml version="1.0" encoding="utf-8"?>
-<p:sld xmlns:a="http://schemas.openxmlformats.org/drawingml/2006/main" xmlns:p="http://schemas.openxmlformats.org/presentationml/2006/main" xmlns:r="http://schemas.openxmlformats.org/officeDocument/2006/relationships">
-  <p:cSld>
-    <p:spTree>
-      <p:nvGrpSpPr>
-        <p:cNvPr id="1" name=""/>
-        <p:cNvGrpSpPr/>
-        <p:nvPr/>
-      </p:nvGrpSpPr>
-      <p:grpSpPr/>
-      <p:sp>
-        <p:nvSpPr>
-          <p:cNvPr id="2" name="Rectangle 1"/>
-          <p:cNvSpPr/>
-          <p:nvPr/>
-        </p:nvSpPr>
-        <p:spPr>
-          <a:xfrm>
-            <a:off x="0" y="0"/>
-            <a:ext cx="12191695" cy="777240"/>
-          </a:xfrm>
-          <a:prstGeom prst="rect">
-            <a:avLst/>
-          </a:prstGeom>
-          <a:solidFill>
-            <a:srgbClr val="0B1F33"/>
-          </a:solidFill>
-          <a:ln>
-            <a:solidFill>
-              <a:srgbClr val="0B1F33"/>
-            </a:solidFill>
-          </a:ln>
-        </p:spPr>
-        <p:style>
-          <a:lnRef idx="1">
-            <a:schemeClr val="accent1"/>
-          </a:lnRef>
-          <a:fillRef idx="3">
-            <a:schemeClr val="accent1"/>
-          </a:fillRef>
-          <a:effectRef idx="2">
-            <a:schemeClr val="accent1"/>
-          </a:effectRef>
-          <a:fontRef idx="minor">
-            <a:schemeClr val="lt1"/>
-          </a:fontRef>
-        </p:style>
-        <p:txBody>
-          <a:bodyPr rtlCol="0" anchor="ctr"/>
-          <a:lstStyle/>
-          <a:p>
-            <a:pPr algn="ctr"/>
-          </a:p>
-        </p:txBody>
-      </p:sp>
-      <p:sp>
-        <p:nvSpPr>
-          <p:cNvPr id="3" name="TextBox 2"/>
-          <p:cNvSpPr txBox="1"/>
-          <p:nvPr/>
-        </p:nvSpPr>
-        <p:spPr>
-          <a:xfrm>
-            <a:off x="365760" y="164592"/>
-            <a:ext cx="11430000" cy="502920"/>
-          </a:xfrm>
-          <a:prstGeom prst="rect">
-            <a:avLst/>
-          </a:prstGeom>
-          <a:noFill/>
-        </p:spPr>
-        <p:txBody>
-          <a:bodyPr wrap="none">
-            <a:spAutoFit/>
-          </a:bodyPr>
-          <a:lstStyle/>
-          <a:p>
-            <a:r>
-              <a:rPr sz="2000" b="1">
-                <a:solidFill>
-                  <a:srgbClr val="FFFFFF"/>
-                </a:solidFill>
-                <a:latin typeface="Calibri"/>
-              </a:rPr>
-              <a:t>9. Demo-Ready Slice Summary</a:t>
-            </a:r>
-          </a:p>
-        </p:txBody>
-      </p:sp>
-      <p:sp>
-        <p:nvSpPr>
-          <p:cNvPr id="4" name="TextBox 3"/>
-          <p:cNvSpPr txBox="1"/>
-          <p:nvPr/>
-        </p:nvSpPr>
-        <p:spPr>
-          <a:xfrm>
-            <a:off x="365760" y="822960"/>
-            <a:ext cx="11430000" cy="320040"/>
-          </a:xfrm>
-          <a:prstGeom prst="rect">
-            <a:avLst/>
-          </a:prstGeom>
-          <a:noFill/>
-        </p:spPr>
-        <p:txBody>
-          <a:bodyPr wrap="none">
-            <a:spAutoFit/>
-          </a:bodyPr>
-          <a:lstStyle/>
-          <a:p>
-            <a:r>
-              <a:rPr sz="1200" b="0">
-                <a:solidFill>
-                  <a:srgbClr val="334155"/>
-                </a:solidFill>
-                <a:latin typeface="Calibri"/>
-              </a:rPr>
-              <a:t>Reliable · safe · synthetic</a:t>
-            </a:r>
-          </a:p>
-        </p:txBody>
-      </p:sp>
-      <p:sp>
-        <p:nvSpPr>
-          <p:cNvPr id="5" name="Rounded Rectangle 4"/>
-          <p:cNvSpPr/>
-          <p:nvPr/>
-        </p:nvSpPr>
-        <p:spPr>
-          <a:xfrm>
-            <a:off x="457200" y="1143000"/>
-            <a:ext cx="2377440" cy="777240"/>
-          </a:xfrm>
-          <a:prstGeom prst="roundRect">
-            <a:avLst>
-              <a:gd name="adj" fmla="val 12000"/>
-            </a:avLst>
-          </a:prstGeom>
-          <a:solidFill>
-            <a:srgbClr val="FEE2E2"/>
-          </a:solidFill>
-          <a:ln w="15875">
-            <a:solidFill>
-              <a:srgbClr val="B91C1C"/>
-            </a:solidFill>
-          </a:ln>
-        </p:spPr>
-        <p:style>
-          <a:lnRef idx="1">
-            <a:schemeClr val="accent1"/>
-          </a:lnRef>
-          <a:fillRef idx="3">
-            <a:schemeClr val="accent1"/>
-          </a:fillRef>
-          <a:effectRef idx="2">
-            <a:schemeClr val="accent1"/>
-          </a:effectRef>
-          <a:fontRef idx="minor">
-            <a:schemeClr val="lt1"/>
-          </a:fontRef>
-        </p:style>
-        <p:txBody>
-          <a:bodyPr rtlCol="0" anchor="ctr" wrap="square"/>
-          <a:lstStyle/>
-          <a:p>
-            <a:pPr algn="ctr"/>
-            <a:r>
-              <a:rPr sz="1400" b="1">
-                <a:solidFill>
-                  <a:srgbClr val="B91C1C"/>
-                </a:solidFill>
-                <a:latin typeface="Calibri"/>
-              </a:rPr>
-              <a:t>Safe</a:t>
-            </a:r>
-          </a:p>
-        </p:txBody>
-      </p:sp>
-      <p:sp>
-        <p:nvSpPr>
-          <p:cNvPr id="6" name="Rounded Rectangle 5"/>
-          <p:cNvSpPr/>
-          <p:nvPr/>
-        </p:nvSpPr>
-        <p:spPr>
-          <a:xfrm>
-            <a:off x="3017520" y="1143000"/>
-            <a:ext cx="8686800" cy="777240"/>
-          </a:xfrm>
-          <a:prstGeom prst="roundRect">
-            <a:avLst>
-              <a:gd name="adj" fmla="val 12000"/>
-            </a:avLst>
-          </a:prstGeom>
-          <a:solidFill>
-            <a:srgbClr val="FFFFFF"/>
-          </a:solidFill>
-          <a:ln w="15875">
-            <a:solidFill>
-              <a:srgbClr val="B91C1C"/>
-            </a:solidFill>
-          </a:ln>
-        </p:spPr>
-        <p:style>
-          <a:lnRef idx="1">
-            <a:schemeClr val="accent1"/>
-          </a:lnRef>
-          <a:fillRef idx="3">
-            <a:schemeClr val="accent1"/>
-          </a:fillRef>
-          <a:effectRef idx="2">
-            <a:schemeClr val="accent1"/>
-          </a:effectRef>
-          <a:fontRef idx="minor">
-            <a:schemeClr val="lt1"/>
-          </a:fontRef>
-        </p:style>
-        <p:txBody>
-          <a:bodyPr rtlCol="0" anchor="ctr" wrap="square"/>
-          <a:lstStyle/>
-          <a:p>
-            <a:pPr algn="ctr"/>
-            <a:r>
-              <a:rPr sz="1300" b="1">
-                <a:solidFill>
-                  <a:srgbClr val="0B1F33"/>
-                </a:solidFill>
-                <a:latin typeface="Calibri"/>
-              </a:rPr>
-              <a:t>Invoice OOS + compare hard-stop (exact messages; no default CON-* pair)</a:t>
-            </a:r>
-          </a:p>
-        </p:txBody>
-      </p:sp>
-      <p:sp>
-        <p:nvSpPr>
-          <p:cNvPr id="7" name="Rounded Rectangle 6"/>
-          <p:cNvSpPr/>
-          <p:nvPr/>
-        </p:nvSpPr>
-        <p:spPr>
-          <a:xfrm>
-            <a:off x="457200" y="2103120"/>
-            <a:ext cx="2377440" cy="777240"/>
-          </a:xfrm>
-          <a:prstGeom prst="roundRect">
-            <a:avLst>
-              <a:gd name="adj" fmla="val 12000"/>
-            </a:avLst>
-          </a:prstGeom>
-          <a:solidFill>
-            <a:srgbClr val="D1FAE5"/>
-          </a:solidFill>
-          <a:ln w="15875">
-            <a:solidFill>
-              <a:srgbClr val="047857"/>
-            </a:solidFill>
-          </a:ln>
-        </p:spPr>
-        <p:style>
-          <a:lnRef idx="1">
-            <a:schemeClr val="accent1"/>
-          </a:lnRef>
-          <a:fillRef idx="3">
-            <a:schemeClr val="accent1"/>
-          </a:fillRef>
-          <a:effectRef idx="2">
-            <a:schemeClr val="accent1"/>
-          </a:effectRef>
-          <a:fontRef idx="minor">
-            <a:schemeClr val="lt1"/>
-          </a:fontRef>
-        </p:style>
-        <p:txBody>
-          <a:bodyPr rtlCol="0" anchor="ctr" wrap="square"/>
-          <a:lstStyle/>
-          <a:p>
-            <a:pPr algn="ctr"/>
-            <a:r>
-              <a:rPr sz="1400" b="1">
-                <a:solidFill>
-                  <a:srgbClr val="047857"/>
-                </a:solidFill>
-                <a:latin typeface="Calibri"/>
-              </a:rPr>
-              <a:t>Structured tools</a:t>
-            </a:r>
-          </a:p>
-        </p:txBody>
-      </p:sp>
-      <p:sp>
-        <p:nvSpPr>
-          <p:cNvPr id="8" name="Rounded Rectangle 7"/>
-          <p:cNvSpPr/>
-          <p:nvPr/>
-        </p:nvSpPr>
-        <p:spPr>
-          <a:xfrm>
-            <a:off x="3017520" y="2103120"/>
-            <a:ext cx="8686800" cy="777240"/>
-          </a:xfrm>
-          <a:prstGeom prst="roundRect">
-            <a:avLst>
-              <a:gd name="adj" fmla="val 12000"/>
-            </a:avLst>
-          </a:prstGeom>
-          <a:solidFill>
-            <a:srgbClr val="FFFFFF"/>
-          </a:solidFill>
-          <a:ln w="15875">
-            <a:solidFill>
-              <a:srgbClr val="047857"/>
-            </a:solidFill>
-          </a:ln>
-        </p:spPr>
-        <p:style>
-          <a:lnRef idx="1">
-            <a:schemeClr val="accent1"/>
-          </a:lnRef>
-          <a:fillRef idx="3">
-            <a:schemeClr val="accent1"/>
-          </a:fillRef>
-          <a:effectRef idx="2">
-            <a:schemeClr val="accent1"/>
-          </a:effectRef>
-          <a:fontRef idx="minor">
-            <a:schemeClr val="lt1"/>
-          </a:fontRef>
-        </p:style>
-        <p:txBody>
-          <a:bodyPr rtlCol="0" anchor="ctr" wrap="square"/>
-          <a:lstStyle/>
-          <a:p>
-            <a:pPr algn="ctr"/>
-            <a:r>
-              <a:rPr sz="1300" b="1">
-                <a:solidFill>
-                  <a:srgbClr val="0B1F33"/>
-                </a:solidFill>
-                <a:latin typeface="Calibri"/>
-              </a:rPr>
-              <a:t>search / profile / N-way compare / overlaps / risk via ContractRepository</a:t>
-            </a:r>
-          </a:p>
-        </p:txBody>
-      </p:sp>
-      <p:sp>
-        <p:nvSpPr>
-          <p:cNvPr id="9" name="Rounded Rectangle 8"/>
-          <p:cNvSpPr/>
-          <p:nvPr/>
-        </p:nvSpPr>
-        <p:spPr>
-          <a:xfrm>
-            <a:off x="457200" y="3063240"/>
-            <a:ext cx="2377440" cy="777240"/>
-          </a:xfrm>
-          <a:prstGeom prst="roundRect">
-            <a:avLst>
-              <a:gd name="adj" fmla="val 12000"/>
-            </a:avLst>
-          </a:prstGeom>
-          <a:solidFill>
-            <a:srgbClr val="D9F3F3"/>
-          </a:solidFill>
-          <a:ln w="15875">
-            <a:solidFill>
-              <a:srgbClr val="0E6B6B"/>
-            </a:solidFill>
-          </a:ln>
-        </p:spPr>
-        <p:style>
-          <a:lnRef idx="1">
-            <a:schemeClr val="accent1"/>
-          </a:lnRef>
-          <a:fillRef idx="3">
-            <a:schemeClr val="accent1"/>
-          </a:fillRef>
-          <a:effectRef idx="2">
-            <a:schemeClr val="accent1"/>
-          </a:effectRef>
-          <a:fontRef idx="minor">
-            <a:schemeClr val="lt1"/>
-          </a:fontRef>
-        </p:style>
-        <p:txBody>
-          <a:bodyPr rtlCol="0" anchor="ctr" wrap="square"/>
-          <a:lstStyle/>
-          <a:p>
-            <a:pPr algn="ctr"/>
-            <a:r>
-              <a:rPr sz="1400" b="1">
-                <a:solidFill>
-                  <a:srgbClr val="0E6B6B"/>
-                </a:solidFill>
-                <a:latin typeface="Calibri"/>
-              </a:rPr>
-              <a:t>Persona memory</a:t>
-            </a:r>
-          </a:p>
-        </p:txBody>
-      </p:sp>
-      <p:sp>
-        <p:nvSpPr>
-          <p:cNvPr id="10" name="Rounded Rectangle 9"/>
-          <p:cNvSpPr/>
-          <p:nvPr/>
-        </p:nvSpPr>
-        <p:spPr>
-          <a:xfrm>
-            <a:off x="3017520" y="3063240"/>
-            <a:ext cx="8686800" cy="777240"/>
-          </a:xfrm>
-          <a:prstGeom prst="roundRect">
-            <a:avLst>
-              <a:gd name="adj" fmla="val 12000"/>
-            </a:avLst>
-          </a:prstGeom>
-          <a:solidFill>
-            <a:srgbClr val="FFFFFF"/>
-          </a:solidFill>
-          <a:ln w="15875">
-            <a:solidFill>
-              <a:srgbClr val="0E6B6B"/>
-            </a:solidFill>
-          </a:ln>
-        </p:spPr>
-        <p:style>
-          <a:lnRef idx="1">
-            <a:schemeClr val="accent1"/>
-          </a:lnRef>
-          <a:fillRef idx="3">
-            <a:schemeClr val="accent1"/>
-          </a:fillRef>
-          <a:effectRef idx="2">
-            <a:schemeClr val="accent1"/>
-          </a:effectRef>
-          <a:fontRef idx="minor">
-            <a:schemeClr val="lt1"/>
-          </a:fontRef>
-        </p:style>
-        <p:txBody>
-          <a:bodyPr rtlCol="0" anchor="ctr" wrap="square"/>
-          <a:lstStyle/>
-          <a:p>
-            <a:pPr algn="ctr"/>
-            <a:r>
-              <a:rPr sz="1300" b="1">
-                <a:solidFill>
-                  <a:srgbClr val="0B1F33"/>
-                </a:solidFill>
-                <a:latin typeface="Calibri"/>
-              </a:rPr>
-              <a:t>SQLite save / pin / filter / recall previous searches per persona</a:t>
-            </a:r>
-          </a:p>
-        </p:txBody>
-      </p:sp>
-      <p:sp>
-        <p:nvSpPr>
-          <p:cNvPr id="11" name="Rounded Rectangle 10"/>
-          <p:cNvSpPr/>
-          <p:nvPr/>
-        </p:nvSpPr>
-        <p:spPr>
-          <a:xfrm>
-            <a:off x="457200" y="4023360"/>
-            <a:ext cx="2377440" cy="777240"/>
-          </a:xfrm>
-          <a:prstGeom prst="roundRect">
-            <a:avLst>
-              <a:gd name="adj" fmla="val 12000"/>
-            </a:avLst>
-          </a:prstGeom>
-          <a:solidFill>
-            <a:srgbClr val="EDE9FE"/>
-          </a:solidFill>
-          <a:ln w="15875">
-            <a:solidFill>
-              <a:srgbClr val="6D28D9"/>
-            </a:solidFill>
-          </a:ln>
-        </p:spPr>
-        <p:style>
-          <a:lnRef idx="1">
-            <a:schemeClr val="accent1"/>
-          </a:lnRef>
-          <a:fillRef idx="3">
-            <a:schemeClr val="accent1"/>
-          </a:fillRef>
-          <a:effectRef idx="2">
-            <a:schemeClr val="accent1"/>
-          </a:effectRef>
-          <a:fontRef idx="minor">
-            <a:schemeClr val="lt1"/>
-          </a:fontRef>
-        </p:style>
-        <p:txBody>
-          <a:bodyPr rtlCol="0" anchor="ctr" wrap="square"/>
-          <a:lstStyle/>
-          <a:p>
-            <a:pPr algn="ctr"/>
-            <a:r>
               <a:rPr sz="1400" b="1">
                 <a:solidFill>
                   <a:srgbClr val="6D28D9"/>
@@ -4703,7 +3947,7 @@
                 </a:solidFill>
                 <a:latin typeface="Calibri"/>
               </a:rPr>
-              <a:t>Foundry optional</a:t>
+              <a:t>Local runtime</a:t>
             </a:r>
           </a:p>
         </p:txBody>
@@ -4759,7 +4003,7 @@
                 </a:solidFill>
                 <a:latin typeface="Calibri"/>
               </a:rPr>
-              <a:t>Flask + offline router today; Foundry ToolSet wraps 7 tools</a:t>
+              <a:t>Streamlit → Flask → FastMCP is the sole validated POC path</a:t>
             </a:r>
           </a:p>
         </p:txBody>
@@ -4794,7 +4038,7 @@
                 </a:solidFill>
                 <a:latin typeface="Calibri"/>
               </a:rPr>
-              <a:t>Synthetic Contract Intelligence Tool-Layer POC · Slide 11</a:t>
+              <a:t>Synthetic Contract Intelligence Tool-Layer POC · Slide 10</a:t>
             </a:r>
           </a:p>
         </p:txBody>
@@ -4891,7 +4135,7 @@
                 </a:solidFill>
                 <a:latin typeface="Calibri"/>
               </a:rPr>
-              <a:t>1. Current vs Future Architecture</a:t>
+              <a:t>1. Runtime Architecture</a:t>
             </a:r>
           </a:p>
         </p:txBody>
@@ -4925,7 +4169,7 @@
                 </a:solidFill>
                 <a:latin typeface="Calibri"/>
               </a:rPr>
-              <a:t>Keep the tool layer stable; swap the cognitive host later</a:t>
+              <a:t>Keep the tool layer stable; swap data sources later</a:t>
             </a:r>
           </a:p>
         </p:txBody>
@@ -5056,7 +4300,7 @@
                 </a:solidFill>
                 <a:latin typeface="Calibri"/>
               </a:rPr>
-              <a:t>FUTURE — Foundry-hosted agent</a:t>
+              <a:t>EVOLUTION — Data source swap</a:t>
             </a:r>
           </a:p>
           <a:p>
@@ -5068,12 +4312,12 @@
                 </a:solidFill>
                 <a:latin typeface="Calibri"/>
               </a:rPr>
-              <a:t>Streamlit or Teams UI
-→ Azure AI Foundry Agent
+              <a:t>Same Streamlit / Flask host
 → Same MCP / API tools
 → ContractRepository
-→ Synthetic contract data now
-→ LinkSquares / CLM later
+→ Synthetic fixtures today
+→ Live Fabric SQL later
+→ Live LinkSquares / CLM later
 → Grounded answers</a:t>
             </a:r>
           </a:p>
@@ -6589,8 +5833,10 @@
               <a:t>SQLite: data/persona_memory.sqlite
 (override VAL_MEMORY_DB)
 • Auto-save search-like queries
-• Pin / filter / delete in sidebar
+• Pin / filter / delete searches
+• Delete prior conversations
 • GET/POST /api/memory/searches
+• DELETE /api/memory/conversations
 • GET /api/memory/recall
 • Memory-recall → offline store
 • Streamlit owns writes when

</xml_diff>

<commit_message>
feat: delete prior conversations and remove Foundry deploy code (#22)
Add persona-scoped conversation delete (store, Flask APIs, Streamlit
sidebar) and strip Azure AI Foundry deploy script, guide, and deps for a
clean local Streamlit → Flask → MCP POC copy.

Co-authored-by: Cursor Agent <cursoragent@cursor.com>
Co-authored-by: booshank <booshank@users.noreply.github.com>
</commit_message>
<xml_diff>
--- a/docs/VAL_CoPilot_Architecture_and_Process_Flow.pptx
+++ b/docs/VAL_CoPilot_Architecture_and_Process_Flow.pptx
@@ -15,7 +15,6 @@
     <p:sldId id="263" r:id="rId14"/>
     <p:sldId id="264" r:id="rId15"/>
     <p:sldId id="265" r:id="rId16"/>
-    <p:sldId id="266" r:id="rId17"/>
   </p:sldIdLst>
   <p:sldSz cx="12191695" cy="6858000" type="screen4x3"/>
   <p:notesSz cx="6858000" cy="9144000"/>
@@ -3301,7 +3300,7 @@
                 </a:solidFill>
                 <a:latin typeface="Calibri"/>
               </a:rPr>
-              <a:t>Future: Streamlit/Teams → Azure AI Foundry Agent → same MCP/API tools → live LinkSquares later</a:t>
+              <a:t>Persona memory: save / pin / filter / recall / delete prior searches and conversations</a:t>
             </a:r>
           </a:p>
           <a:p>
@@ -3313,7 +3312,7 @@
                 </a:solidFill>
                 <a:latin typeface="Calibri"/>
               </a:rPr>
-              <a:t>Compare hard-stop when IDs missing · Invoice/actual-spend OOS · Not Foundry-first today</a:t>
+              <a:t>Compare hard-stop when IDs missing · Invoice/actual-spend OOS</a:t>
             </a:r>
           </a:p>
         </p:txBody>
@@ -3410,7 +3409,7 @@
                 </a:solidFill>
                 <a:latin typeface="Calibri"/>
               </a:rPr>
-              <a:t>8. Optional Future — Azure AI Foundry Deploy</a:t>
+              <a:t>8. Demo-Ready Slice Summary</a:t>
             </a:r>
           </a:p>
         </p:txBody>
@@ -3444,7 +3443,7 @@
                 </a:solidFill>
                 <a:latin typeface="Calibri"/>
               </a:rPr>
-              <a:t>deploy_to_foundry.py is optional; current POC does not require Foundry</a:t>
+              <a:t>Reliable · safe · synthetic</a:t>
             </a:r>
           </a:p>
         </p:txBody>
@@ -3457,8 +3456,232 @@
         </p:nvSpPr>
         <p:spPr>
           <a:xfrm>
-            <a:off x="365760" y="1828800"/>
-            <a:ext cx="2103120" cy="2011680"/>
+            <a:off x="457200" y="1143000"/>
+            <a:ext cx="2377440" cy="777240"/>
+          </a:xfrm>
+          <a:prstGeom prst="roundRect">
+            <a:avLst>
+              <a:gd name="adj" fmla="val 12000"/>
+            </a:avLst>
+          </a:prstGeom>
+          <a:solidFill>
+            <a:srgbClr val="FEE2E2"/>
+          </a:solidFill>
+          <a:ln w="15875">
+            <a:solidFill>
+              <a:srgbClr val="B91C1C"/>
+            </a:solidFill>
+          </a:ln>
+        </p:spPr>
+        <p:style>
+          <a:lnRef idx="1">
+            <a:schemeClr val="accent1"/>
+          </a:lnRef>
+          <a:fillRef idx="3">
+            <a:schemeClr val="accent1"/>
+          </a:fillRef>
+          <a:effectRef idx="2">
+            <a:schemeClr val="accent1"/>
+          </a:effectRef>
+          <a:fontRef idx="minor">
+            <a:schemeClr val="lt1"/>
+          </a:fontRef>
+        </p:style>
+        <p:txBody>
+          <a:bodyPr rtlCol="0" anchor="ctr" wrap="square"/>
+          <a:lstStyle/>
+          <a:p>
+            <a:pPr algn="ctr"/>
+            <a:r>
+              <a:rPr sz="1400" b="1">
+                <a:solidFill>
+                  <a:srgbClr val="B91C1C"/>
+                </a:solidFill>
+                <a:latin typeface="Calibri"/>
+              </a:rPr>
+              <a:t>Safe</a:t>
+            </a:r>
+          </a:p>
+        </p:txBody>
+      </p:sp>
+      <p:sp>
+        <p:nvSpPr>
+          <p:cNvPr id="6" name="Rounded Rectangle 5"/>
+          <p:cNvSpPr/>
+          <p:nvPr/>
+        </p:nvSpPr>
+        <p:spPr>
+          <a:xfrm>
+            <a:off x="3017520" y="1143000"/>
+            <a:ext cx="8686800" cy="777240"/>
+          </a:xfrm>
+          <a:prstGeom prst="roundRect">
+            <a:avLst>
+              <a:gd name="adj" fmla="val 12000"/>
+            </a:avLst>
+          </a:prstGeom>
+          <a:solidFill>
+            <a:srgbClr val="FFFFFF"/>
+          </a:solidFill>
+          <a:ln w="15875">
+            <a:solidFill>
+              <a:srgbClr val="B91C1C"/>
+            </a:solidFill>
+          </a:ln>
+        </p:spPr>
+        <p:style>
+          <a:lnRef idx="1">
+            <a:schemeClr val="accent1"/>
+          </a:lnRef>
+          <a:fillRef idx="3">
+            <a:schemeClr val="accent1"/>
+          </a:fillRef>
+          <a:effectRef idx="2">
+            <a:schemeClr val="accent1"/>
+          </a:effectRef>
+          <a:fontRef idx="minor">
+            <a:schemeClr val="lt1"/>
+          </a:fontRef>
+        </p:style>
+        <p:txBody>
+          <a:bodyPr rtlCol="0" anchor="ctr" wrap="square"/>
+          <a:lstStyle/>
+          <a:p>
+            <a:pPr algn="ctr"/>
+            <a:r>
+              <a:rPr sz="1300" b="1">
+                <a:solidFill>
+                  <a:srgbClr val="0B1F33"/>
+                </a:solidFill>
+                <a:latin typeface="Calibri"/>
+              </a:rPr>
+              <a:t>Invoice OOS + compare hard-stop (exact messages; no default CON-* pair)</a:t>
+            </a:r>
+          </a:p>
+        </p:txBody>
+      </p:sp>
+      <p:sp>
+        <p:nvSpPr>
+          <p:cNvPr id="7" name="Rounded Rectangle 6"/>
+          <p:cNvSpPr/>
+          <p:nvPr/>
+        </p:nvSpPr>
+        <p:spPr>
+          <a:xfrm>
+            <a:off x="457200" y="2103120"/>
+            <a:ext cx="2377440" cy="777240"/>
+          </a:xfrm>
+          <a:prstGeom prst="roundRect">
+            <a:avLst>
+              <a:gd name="adj" fmla="val 12000"/>
+            </a:avLst>
+          </a:prstGeom>
+          <a:solidFill>
+            <a:srgbClr val="D1FAE5"/>
+          </a:solidFill>
+          <a:ln w="15875">
+            <a:solidFill>
+              <a:srgbClr val="047857"/>
+            </a:solidFill>
+          </a:ln>
+        </p:spPr>
+        <p:style>
+          <a:lnRef idx="1">
+            <a:schemeClr val="accent1"/>
+          </a:lnRef>
+          <a:fillRef idx="3">
+            <a:schemeClr val="accent1"/>
+          </a:fillRef>
+          <a:effectRef idx="2">
+            <a:schemeClr val="accent1"/>
+          </a:effectRef>
+          <a:fontRef idx="minor">
+            <a:schemeClr val="lt1"/>
+          </a:fontRef>
+        </p:style>
+        <p:txBody>
+          <a:bodyPr rtlCol="0" anchor="ctr" wrap="square"/>
+          <a:lstStyle/>
+          <a:p>
+            <a:pPr algn="ctr"/>
+            <a:r>
+              <a:rPr sz="1400" b="1">
+                <a:solidFill>
+                  <a:srgbClr val="047857"/>
+                </a:solidFill>
+                <a:latin typeface="Calibri"/>
+              </a:rPr>
+              <a:t>Structured tools</a:t>
+            </a:r>
+          </a:p>
+        </p:txBody>
+      </p:sp>
+      <p:sp>
+        <p:nvSpPr>
+          <p:cNvPr id="8" name="Rounded Rectangle 7"/>
+          <p:cNvSpPr/>
+          <p:nvPr/>
+        </p:nvSpPr>
+        <p:spPr>
+          <a:xfrm>
+            <a:off x="3017520" y="2103120"/>
+            <a:ext cx="8686800" cy="777240"/>
+          </a:xfrm>
+          <a:prstGeom prst="roundRect">
+            <a:avLst>
+              <a:gd name="adj" fmla="val 12000"/>
+            </a:avLst>
+          </a:prstGeom>
+          <a:solidFill>
+            <a:srgbClr val="FFFFFF"/>
+          </a:solidFill>
+          <a:ln w="15875">
+            <a:solidFill>
+              <a:srgbClr val="047857"/>
+            </a:solidFill>
+          </a:ln>
+        </p:spPr>
+        <p:style>
+          <a:lnRef idx="1">
+            <a:schemeClr val="accent1"/>
+          </a:lnRef>
+          <a:fillRef idx="3">
+            <a:schemeClr val="accent1"/>
+          </a:fillRef>
+          <a:effectRef idx="2">
+            <a:schemeClr val="accent1"/>
+          </a:effectRef>
+          <a:fontRef idx="minor">
+            <a:schemeClr val="lt1"/>
+          </a:fontRef>
+        </p:style>
+        <p:txBody>
+          <a:bodyPr rtlCol="0" anchor="ctr" wrap="square"/>
+          <a:lstStyle/>
+          <a:p>
+            <a:pPr algn="ctr"/>
+            <a:r>
+              <a:rPr sz="1300" b="1">
+                <a:solidFill>
+                  <a:srgbClr val="0B1F33"/>
+                </a:solidFill>
+                <a:latin typeface="Calibri"/>
+              </a:rPr>
+              <a:t>search / profile / N-way compare / overlaps / risk via ContractRepository</a:t>
+            </a:r>
+          </a:p>
+        </p:txBody>
+      </p:sp>
+      <p:sp>
+        <p:nvSpPr>
+          <p:cNvPr id="9" name="Rounded Rectangle 8"/>
+          <p:cNvSpPr/>
+          <p:nvPr/>
+        </p:nvSpPr>
+        <p:spPr>
+          <a:xfrm>
+            <a:off x="457200" y="3063240"/>
+            <a:ext cx="2377440" cy="777240"/>
           </a:xfrm>
           <a:prstGeom prst="roundRect">
             <a:avLst>
@@ -3494,39 +3717,27 @@
           <a:p>
             <a:pPr algn="ctr"/>
             <a:r>
-              <a:rPr sz="1300" b="1">
-                <a:solidFill>
-                  <a:srgbClr val="0B1F33"/>
-                </a:solidFill>
-                <a:latin typeface="Calibri"/>
-              </a:rPr>
-              <a:t>Root .env</a:t>
-            </a:r>
-          </a:p>
-          <a:p>
-            <a:pPr algn="ctr"/>
-            <a:r>
-              <a:rPr sz="1100" b="0">
-                <a:solidFill>
-                  <a:srgbClr val="334155"/>
-                </a:solidFill>
-                <a:latin typeface="Calibri"/>
-              </a:rPr>
-              <a:t>AZURE_FOUNDRY_ CONNECTION_STRING</a:t>
-            </a:r>
-          </a:p>
-        </p:txBody>
-      </p:sp>
-      <p:sp>
-        <p:nvSpPr>
-          <p:cNvPr id="6" name="Rounded Rectangle 5"/>
+              <a:rPr sz="1400" b="1">
+                <a:solidFill>
+                  <a:srgbClr val="0E6B6B"/>
+                </a:solidFill>
+                <a:latin typeface="Calibri"/>
+              </a:rPr>
+              <a:t>Persona memory</a:t>
+            </a:r>
+          </a:p>
+        </p:txBody>
+      </p:sp>
+      <p:sp>
+        <p:nvSpPr>
+          <p:cNvPr id="10" name="Rounded Rectangle 9"/>
           <p:cNvSpPr/>
           <p:nvPr/>
         </p:nvSpPr>
         <p:spPr>
           <a:xfrm>
-            <a:off x="2743200" y="1828800"/>
-            <a:ext cx="2103120" cy="2011680"/>
+            <a:off x="3017520" y="3063240"/>
+            <a:ext cx="8686800" cy="777240"/>
           </a:xfrm>
           <a:prstGeom prst="roundRect">
             <a:avLst>
@@ -3534,11 +3745,11 @@
             </a:avLst>
           </a:prstGeom>
           <a:solidFill>
-            <a:srgbClr val="FFEDD5"/>
+            <a:srgbClr val="FFFFFF"/>
           </a:solidFill>
           <a:ln w="15875">
             <a:solidFill>
-              <a:srgbClr val="C2410C"/>
+              <a:srgbClr val="0E6B6B"/>
             </a:solidFill>
           </a:ln>
         </p:spPr>
@@ -3568,169 +3779,21 @@
                 </a:solidFill>
                 <a:latin typeface="Calibri"/>
               </a:rPr>
-              <a:t>Entra auth</a:t>
-            </a:r>
-          </a:p>
-          <a:p>
-            <a:pPr algn="ctr"/>
-            <a:r>
-              <a:rPr sz="1100" b="0">
-                <a:solidFill>
-                  <a:srgbClr val="334155"/>
-                </a:solidFill>
-                <a:latin typeface="Calibri"/>
-              </a:rPr>
-              <a:t>DefaultAzureCredential</a:t>
-            </a:r>
-          </a:p>
-        </p:txBody>
-      </p:sp>
-      <p:sp>
-        <p:nvSpPr>
-          <p:cNvPr id="7" name="Rounded Rectangle 6"/>
+              <a:t>SQLite save / pin / filter / recall / delete searches and conversations</a:t>
+            </a:r>
+          </a:p>
+        </p:txBody>
+      </p:sp>
+      <p:sp>
+        <p:nvSpPr>
+          <p:cNvPr id="11" name="Rounded Rectangle 10"/>
           <p:cNvSpPr/>
           <p:nvPr/>
         </p:nvSpPr>
         <p:spPr>
           <a:xfrm>
-            <a:off x="5120640" y="1828800"/>
-            <a:ext cx="2103120" cy="2011680"/>
-          </a:xfrm>
-          <a:prstGeom prst="roundRect">
-            <a:avLst>
-              <a:gd name="adj" fmla="val 12000"/>
-            </a:avLst>
-          </a:prstGeom>
-          <a:solidFill>
-            <a:srgbClr val="D1FAE5"/>
-          </a:solidFill>
-          <a:ln w="15875">
-            <a:solidFill>
-              <a:srgbClr val="047857"/>
-            </a:solidFill>
-          </a:ln>
-        </p:spPr>
-        <p:style>
-          <a:lnRef idx="1">
-            <a:schemeClr val="accent1"/>
-          </a:lnRef>
-          <a:fillRef idx="3">
-            <a:schemeClr val="accent1"/>
-          </a:fillRef>
-          <a:effectRef idx="2">
-            <a:schemeClr val="accent1"/>
-          </a:effectRef>
-          <a:fontRef idx="minor">
-            <a:schemeClr val="lt1"/>
-          </a:fontRef>
-        </p:style>
-        <p:txBody>
-          <a:bodyPr rtlCol="0" anchor="ctr" wrap="square"/>
-          <a:lstStyle/>
-          <a:p>
-            <a:pPr algn="ctr"/>
-            <a:r>
-              <a:rPr sz="1300" b="1">
-                <a:solidFill>
-                  <a:srgbClr val="0B1F33"/>
-                </a:solidFill>
-                <a:latin typeface="Calibri"/>
-              </a:rPr>
-              <a:t>Wrap tools</a:t>
-            </a:r>
-          </a:p>
-          <a:p>
-            <a:pPr algn="ctr"/>
-            <a:r>
-              <a:rPr sz="1100" b="0">
-                <a:solidFill>
-                  <a:srgbClr val="334155"/>
-                </a:solidFill>
-                <a:latin typeface="Calibri"/>
-              </a:rPr>
-              <a:t>FunctionTool ToolSet (7 MCP tools)</a:t>
-            </a:r>
-          </a:p>
-        </p:txBody>
-      </p:sp>
-      <p:sp>
-        <p:nvSpPr>
-          <p:cNvPr id="8" name="Rounded Rectangle 7"/>
-          <p:cNvSpPr/>
-          <p:nvPr/>
-        </p:nvSpPr>
-        <p:spPr>
-          <a:xfrm>
-            <a:off x="7498079" y="1828800"/>
-            <a:ext cx="2103120" cy="2011680"/>
-          </a:xfrm>
-          <a:prstGeom prst="roundRect">
-            <a:avLst>
-              <a:gd name="adj" fmla="val 12000"/>
-            </a:avLst>
-          </a:prstGeom>
-          <a:solidFill>
-            <a:srgbClr val="DBEAFE"/>
-          </a:solidFill>
-          <a:ln w="15875">
-            <a:solidFill>
-              <a:srgbClr val="1D4ED8"/>
-            </a:solidFill>
-          </a:ln>
-        </p:spPr>
-        <p:style>
-          <a:lnRef idx="1">
-            <a:schemeClr val="accent1"/>
-          </a:lnRef>
-          <a:fillRef idx="3">
-            <a:schemeClr val="accent1"/>
-          </a:fillRef>
-          <a:effectRef idx="2">
-            <a:schemeClr val="accent1"/>
-          </a:effectRef>
-          <a:fontRef idx="minor">
-            <a:schemeClr val="lt1"/>
-          </a:fontRef>
-        </p:style>
-        <p:txBody>
-          <a:bodyPr rtlCol="0" anchor="ctr" wrap="square"/>
-          <a:lstStyle/>
-          <a:p>
-            <a:pPr algn="ctr"/>
-            <a:r>
-              <a:rPr sz="1300" b="1">
-                <a:solidFill>
-                  <a:srgbClr val="0B1F33"/>
-                </a:solidFill>
-                <a:latin typeface="Calibri"/>
-              </a:rPr>
-              <a:t>create_agent</a:t>
-            </a:r>
-          </a:p>
-          <a:p>
-            <a:pPr algn="ctr"/>
-            <a:r>
-              <a:rPr sz="1100" b="0">
-                <a:solidFill>
-                  <a:srgbClr val="334155"/>
-                </a:solidFill>
-                <a:latin typeface="Calibri"/>
-              </a:rPr>
-              <a:t>SYSTEM_PROMPT hard-stop + OOS</a:t>
-            </a:r>
-          </a:p>
-        </p:txBody>
-      </p:sp>
-      <p:sp>
-        <p:nvSpPr>
-          <p:cNvPr id="9" name="Rounded Rectangle 8"/>
-          <p:cNvSpPr/>
-          <p:nvPr/>
-        </p:nvSpPr>
-        <p:spPr>
-          <a:xfrm>
-            <a:off x="9875520" y="1828800"/>
-            <a:ext cx="2103120" cy="2011680"/>
+            <a:off x="457200" y="4023360"/>
+            <a:ext cx="2377440" cy="777240"/>
           </a:xfrm>
           <a:prstGeom prst="roundRect">
             <a:avLst>
@@ -3766,825 +3829,6 @@
           <a:p>
             <a:pPr algn="ctr"/>
             <a:r>
-              <a:rPr sz="1300" b="1">
-                <a:solidFill>
-                  <a:srgbClr val="0B1F33"/>
-                </a:solidFill>
-                <a:latin typeface="Calibri"/>
-              </a:rPr>
-              <a:t>Future host</a:t>
-            </a:r>
-          </a:p>
-          <a:p>
-            <a:pPr algn="ctr"/>
-            <a:r>
-              <a:rPr sz="1100" b="0">
-                <a:solidFill>
-                  <a:srgbClr val="334155"/>
-                </a:solidFill>
-                <a:latin typeface="Calibri"/>
-              </a:rPr>
-              <a:t>Teams / Foundry UI extend ToolSet</a:t>
-            </a:r>
-          </a:p>
-        </p:txBody>
-      </p:sp>
-      <p:sp>
-        <p:nvSpPr>
-          <p:cNvPr id="10" name="Right Arrow 9"/>
-          <p:cNvSpPr/>
-          <p:nvPr/>
-        </p:nvSpPr>
-        <p:spPr>
-          <a:xfrm>
-            <a:off x="2514600" y="2743200"/>
-            <a:ext cx="201168" cy="182880"/>
-          </a:xfrm>
-          <a:prstGeom prst="rightArrow">
-            <a:avLst/>
-          </a:prstGeom>
-          <a:solidFill>
-            <a:srgbClr val="94A3B8"/>
-          </a:solidFill>
-          <a:ln>
-            <a:solidFill>
-              <a:srgbClr val="94A3B8"/>
-            </a:solidFill>
-          </a:ln>
-        </p:spPr>
-        <p:style>
-          <a:lnRef idx="1">
-            <a:schemeClr val="accent1"/>
-          </a:lnRef>
-          <a:fillRef idx="3">
-            <a:schemeClr val="accent1"/>
-          </a:fillRef>
-          <a:effectRef idx="2">
-            <a:schemeClr val="accent1"/>
-          </a:effectRef>
-          <a:fontRef idx="minor">
-            <a:schemeClr val="lt1"/>
-          </a:fontRef>
-        </p:style>
-        <p:txBody>
-          <a:bodyPr rtlCol="0" anchor="ctr"/>
-          <a:lstStyle/>
-          <a:p>
-            <a:pPr algn="ctr"/>
-          </a:p>
-        </p:txBody>
-      </p:sp>
-      <p:sp>
-        <p:nvSpPr>
-          <p:cNvPr id="11" name="Right Arrow 10"/>
-          <p:cNvSpPr/>
-          <p:nvPr/>
-        </p:nvSpPr>
-        <p:spPr>
-          <a:xfrm>
-            <a:off x="4892040" y="2743200"/>
-            <a:ext cx="201168" cy="182880"/>
-          </a:xfrm>
-          <a:prstGeom prst="rightArrow">
-            <a:avLst/>
-          </a:prstGeom>
-          <a:solidFill>
-            <a:srgbClr val="94A3B8"/>
-          </a:solidFill>
-          <a:ln>
-            <a:solidFill>
-              <a:srgbClr val="94A3B8"/>
-            </a:solidFill>
-          </a:ln>
-        </p:spPr>
-        <p:style>
-          <a:lnRef idx="1">
-            <a:schemeClr val="accent1"/>
-          </a:lnRef>
-          <a:fillRef idx="3">
-            <a:schemeClr val="accent1"/>
-          </a:fillRef>
-          <a:effectRef idx="2">
-            <a:schemeClr val="accent1"/>
-          </a:effectRef>
-          <a:fontRef idx="minor">
-            <a:schemeClr val="lt1"/>
-          </a:fontRef>
-        </p:style>
-        <p:txBody>
-          <a:bodyPr rtlCol="0" anchor="ctr"/>
-          <a:lstStyle/>
-          <a:p>
-            <a:pPr algn="ctr"/>
-          </a:p>
-        </p:txBody>
-      </p:sp>
-      <p:sp>
-        <p:nvSpPr>
-          <p:cNvPr id="12" name="Right Arrow 11"/>
-          <p:cNvSpPr/>
-          <p:nvPr/>
-        </p:nvSpPr>
-        <p:spPr>
-          <a:xfrm>
-            <a:off x="7269480" y="2743200"/>
-            <a:ext cx="201168" cy="182880"/>
-          </a:xfrm>
-          <a:prstGeom prst="rightArrow">
-            <a:avLst/>
-          </a:prstGeom>
-          <a:solidFill>
-            <a:srgbClr val="94A3B8"/>
-          </a:solidFill>
-          <a:ln>
-            <a:solidFill>
-              <a:srgbClr val="94A3B8"/>
-            </a:solidFill>
-          </a:ln>
-        </p:spPr>
-        <p:style>
-          <a:lnRef idx="1">
-            <a:schemeClr val="accent1"/>
-          </a:lnRef>
-          <a:fillRef idx="3">
-            <a:schemeClr val="accent1"/>
-          </a:fillRef>
-          <a:effectRef idx="2">
-            <a:schemeClr val="accent1"/>
-          </a:effectRef>
-          <a:fontRef idx="minor">
-            <a:schemeClr val="lt1"/>
-          </a:fontRef>
-        </p:style>
-        <p:txBody>
-          <a:bodyPr rtlCol="0" anchor="ctr"/>
-          <a:lstStyle/>
-          <a:p>
-            <a:pPr algn="ctr"/>
-          </a:p>
-        </p:txBody>
-      </p:sp>
-      <p:sp>
-        <p:nvSpPr>
-          <p:cNvPr id="13" name="Right Arrow 12"/>
-          <p:cNvSpPr/>
-          <p:nvPr/>
-        </p:nvSpPr>
-        <p:spPr>
-          <a:xfrm>
-            <a:off x="9646920" y="2743200"/>
-            <a:ext cx="201168" cy="182880"/>
-          </a:xfrm>
-          <a:prstGeom prst="rightArrow">
-            <a:avLst/>
-          </a:prstGeom>
-          <a:solidFill>
-            <a:srgbClr val="94A3B8"/>
-          </a:solidFill>
-          <a:ln>
-            <a:solidFill>
-              <a:srgbClr val="94A3B8"/>
-            </a:solidFill>
-          </a:ln>
-        </p:spPr>
-        <p:style>
-          <a:lnRef idx="1">
-            <a:schemeClr val="accent1"/>
-          </a:lnRef>
-          <a:fillRef idx="3">
-            <a:schemeClr val="accent1"/>
-          </a:fillRef>
-          <a:effectRef idx="2">
-            <a:schemeClr val="accent1"/>
-          </a:effectRef>
-          <a:fontRef idx="minor">
-            <a:schemeClr val="lt1"/>
-          </a:fontRef>
-        </p:style>
-        <p:txBody>
-          <a:bodyPr rtlCol="0" anchor="ctr"/>
-          <a:lstStyle/>
-          <a:p>
-            <a:pPr algn="ctr"/>
-          </a:p>
-        </p:txBody>
-      </p:sp>
-      <p:sp>
-        <p:nvSpPr>
-          <p:cNvPr id="14" name="Rounded Rectangle 13"/>
-          <p:cNvSpPr/>
-          <p:nvPr/>
-        </p:nvSpPr>
-        <p:spPr>
-          <a:xfrm>
-            <a:off x="457200" y="4206240"/>
-            <a:ext cx="11247120" cy="1645920"/>
-          </a:xfrm>
-          <a:prstGeom prst="roundRect">
-            <a:avLst>
-              <a:gd name="adj" fmla="val 12000"/>
-            </a:avLst>
-          </a:prstGeom>
-          <a:solidFill>
-            <a:srgbClr val="F1F5F9"/>
-          </a:solidFill>
-          <a:ln w="15875">
-            <a:solidFill>
-              <a:srgbClr val="94A3B8"/>
-            </a:solidFill>
-          </a:ln>
-        </p:spPr>
-        <p:style>
-          <a:lnRef idx="1">
-            <a:schemeClr val="accent1"/>
-          </a:lnRef>
-          <a:fillRef idx="3">
-            <a:schemeClr val="accent1"/>
-          </a:fillRef>
-          <a:effectRef idx="2">
-            <a:schemeClr val="accent1"/>
-          </a:effectRef>
-          <a:fontRef idx="minor">
-            <a:schemeClr val="lt1"/>
-          </a:fontRef>
-        </p:style>
-        <p:txBody>
-          <a:bodyPr rtlCol="0" anchor="ctr" wrap="square"/>
-          <a:lstStyle/>
-          <a:p>
-            <a:pPr algn="ctr"/>
-            <a:r>
-              <a:rPr sz="1300" b="1">
-                <a:solidFill>
-                  <a:srgbClr val="0B1F33"/>
-                </a:solidFill>
-                <a:latin typeface="Calibri"/>
-              </a:rPr>
-              <a:t>Deploy script ToolSet today (7 tools) — extend next to full MCP inventory</a:t>
-            </a:r>
-          </a:p>
-          <a:p>
-            <a:pPr algn="ctr"/>
-            <a:r>
-              <a:rPr sz="1100" b="0">
-                <a:solidFill>
-                  <a:srgbClr val="334155"/>
-                </a:solidFill>
-                <a:latin typeface="Calibri"/>
-              </a:rPr>
-              <a:t>search_contracts · get_contract_profile · get_expiring_contracts · get_vendor_spend_summary · find_overlaps · explain_contract_risk · search_cloud_blob_contracts
-Local FastMCP also has compare_contracts + check_missing_contract_fields. SYSTEM_PROMPT encodes compare hard-stop + persona-memory guidance.</a:t>
-            </a:r>
-          </a:p>
-        </p:txBody>
-      </p:sp>
-      <p:sp>
-        <p:nvSpPr>
-          <p:cNvPr id="15" name="TextBox 14"/>
-          <p:cNvSpPr txBox="1"/>
-          <p:nvPr/>
-        </p:nvSpPr>
-        <p:spPr>
-          <a:xfrm>
-            <a:off x="365760" y="6492240"/>
-            <a:ext cx="11430000" cy="274320"/>
-          </a:xfrm>
-          <a:prstGeom prst="rect">
-            <a:avLst/>
-          </a:prstGeom>
-          <a:noFill/>
-        </p:spPr>
-        <p:txBody>
-          <a:bodyPr wrap="none">
-            <a:spAutoFit/>
-          </a:bodyPr>
-          <a:lstStyle/>
-          <a:p>
-            <a:pPr algn="ctr"/>
-            <a:r>
-              <a:rPr sz="900" b="0">
-                <a:solidFill>
-                  <a:srgbClr val="94A3B8"/>
-                </a:solidFill>
-                <a:latin typeface="Calibri"/>
-              </a:rPr>
-              <a:t>Synthetic Contract Intelligence Tool-Layer POC · Slide 10</a:t>
-            </a:r>
-          </a:p>
-        </p:txBody>
-      </p:sp>
-    </p:spTree>
-  </p:cSld>
-  <p:clrMapOvr>
-    <a:masterClrMapping/>
-  </p:clrMapOvr>
-</p:sld>
-</file>
-
-<file path=ppt/slides/slide11.xml><?xml version="1.0" encoding="utf-8"?>
-<p:sld xmlns:a="http://schemas.openxmlformats.org/drawingml/2006/main" xmlns:p="http://schemas.openxmlformats.org/presentationml/2006/main" xmlns:r="http://schemas.openxmlformats.org/officeDocument/2006/relationships">
-  <p:cSld>
-    <p:spTree>
-      <p:nvGrpSpPr>
-        <p:cNvPr id="1" name=""/>
-        <p:cNvGrpSpPr/>
-        <p:nvPr/>
-      </p:nvGrpSpPr>
-      <p:grpSpPr/>
-      <p:sp>
-        <p:nvSpPr>
-          <p:cNvPr id="2" name="Rectangle 1"/>
-          <p:cNvSpPr/>
-          <p:nvPr/>
-        </p:nvSpPr>
-        <p:spPr>
-          <a:xfrm>
-            <a:off x="0" y="0"/>
-            <a:ext cx="12191695" cy="777240"/>
-          </a:xfrm>
-          <a:prstGeom prst="rect">
-            <a:avLst/>
-          </a:prstGeom>
-          <a:solidFill>
-            <a:srgbClr val="0B1F33"/>
-          </a:solidFill>
-          <a:ln>
-            <a:solidFill>
-              <a:srgbClr val="0B1F33"/>
-            </a:solidFill>
-          </a:ln>
-        </p:spPr>
-        <p:style>
-          <a:lnRef idx="1">
-            <a:schemeClr val="accent1"/>
-          </a:lnRef>
-          <a:fillRef idx="3">
-            <a:schemeClr val="accent1"/>
-          </a:fillRef>
-          <a:effectRef idx="2">
-            <a:schemeClr val="accent1"/>
-          </a:effectRef>
-          <a:fontRef idx="minor">
-            <a:schemeClr val="lt1"/>
-          </a:fontRef>
-        </p:style>
-        <p:txBody>
-          <a:bodyPr rtlCol="0" anchor="ctr"/>
-          <a:lstStyle/>
-          <a:p>
-            <a:pPr algn="ctr"/>
-          </a:p>
-        </p:txBody>
-      </p:sp>
-      <p:sp>
-        <p:nvSpPr>
-          <p:cNvPr id="3" name="TextBox 2"/>
-          <p:cNvSpPr txBox="1"/>
-          <p:nvPr/>
-        </p:nvSpPr>
-        <p:spPr>
-          <a:xfrm>
-            <a:off x="365760" y="164592"/>
-            <a:ext cx="11430000" cy="502920"/>
-          </a:xfrm>
-          <a:prstGeom prst="rect">
-            <a:avLst/>
-          </a:prstGeom>
-          <a:noFill/>
-        </p:spPr>
-        <p:txBody>
-          <a:bodyPr wrap="none">
-            <a:spAutoFit/>
-          </a:bodyPr>
-          <a:lstStyle/>
-          <a:p>
-            <a:r>
-              <a:rPr sz="2000" b="1">
-                <a:solidFill>
-                  <a:srgbClr val="FFFFFF"/>
-                </a:solidFill>
-                <a:latin typeface="Calibri"/>
-              </a:rPr>
-              <a:t>9. Demo-Ready Slice Summary</a:t>
-            </a:r>
-          </a:p>
-        </p:txBody>
-      </p:sp>
-      <p:sp>
-        <p:nvSpPr>
-          <p:cNvPr id="4" name="TextBox 3"/>
-          <p:cNvSpPr txBox="1"/>
-          <p:nvPr/>
-        </p:nvSpPr>
-        <p:spPr>
-          <a:xfrm>
-            <a:off x="365760" y="822960"/>
-            <a:ext cx="11430000" cy="320040"/>
-          </a:xfrm>
-          <a:prstGeom prst="rect">
-            <a:avLst/>
-          </a:prstGeom>
-          <a:noFill/>
-        </p:spPr>
-        <p:txBody>
-          <a:bodyPr wrap="none">
-            <a:spAutoFit/>
-          </a:bodyPr>
-          <a:lstStyle/>
-          <a:p>
-            <a:r>
-              <a:rPr sz="1200" b="0">
-                <a:solidFill>
-                  <a:srgbClr val="334155"/>
-                </a:solidFill>
-                <a:latin typeface="Calibri"/>
-              </a:rPr>
-              <a:t>Reliable · safe · synthetic</a:t>
-            </a:r>
-          </a:p>
-        </p:txBody>
-      </p:sp>
-      <p:sp>
-        <p:nvSpPr>
-          <p:cNvPr id="5" name="Rounded Rectangle 4"/>
-          <p:cNvSpPr/>
-          <p:nvPr/>
-        </p:nvSpPr>
-        <p:spPr>
-          <a:xfrm>
-            <a:off x="457200" y="1143000"/>
-            <a:ext cx="2377440" cy="777240"/>
-          </a:xfrm>
-          <a:prstGeom prst="roundRect">
-            <a:avLst>
-              <a:gd name="adj" fmla="val 12000"/>
-            </a:avLst>
-          </a:prstGeom>
-          <a:solidFill>
-            <a:srgbClr val="FEE2E2"/>
-          </a:solidFill>
-          <a:ln w="15875">
-            <a:solidFill>
-              <a:srgbClr val="B91C1C"/>
-            </a:solidFill>
-          </a:ln>
-        </p:spPr>
-        <p:style>
-          <a:lnRef idx="1">
-            <a:schemeClr val="accent1"/>
-          </a:lnRef>
-          <a:fillRef idx="3">
-            <a:schemeClr val="accent1"/>
-          </a:fillRef>
-          <a:effectRef idx="2">
-            <a:schemeClr val="accent1"/>
-          </a:effectRef>
-          <a:fontRef idx="minor">
-            <a:schemeClr val="lt1"/>
-          </a:fontRef>
-        </p:style>
-        <p:txBody>
-          <a:bodyPr rtlCol="0" anchor="ctr" wrap="square"/>
-          <a:lstStyle/>
-          <a:p>
-            <a:pPr algn="ctr"/>
-            <a:r>
-              <a:rPr sz="1400" b="1">
-                <a:solidFill>
-                  <a:srgbClr val="B91C1C"/>
-                </a:solidFill>
-                <a:latin typeface="Calibri"/>
-              </a:rPr>
-              <a:t>Safe</a:t>
-            </a:r>
-          </a:p>
-        </p:txBody>
-      </p:sp>
-      <p:sp>
-        <p:nvSpPr>
-          <p:cNvPr id="6" name="Rounded Rectangle 5"/>
-          <p:cNvSpPr/>
-          <p:nvPr/>
-        </p:nvSpPr>
-        <p:spPr>
-          <a:xfrm>
-            <a:off x="3017520" y="1143000"/>
-            <a:ext cx="8686800" cy="777240"/>
-          </a:xfrm>
-          <a:prstGeom prst="roundRect">
-            <a:avLst>
-              <a:gd name="adj" fmla="val 12000"/>
-            </a:avLst>
-          </a:prstGeom>
-          <a:solidFill>
-            <a:srgbClr val="FFFFFF"/>
-          </a:solidFill>
-          <a:ln w="15875">
-            <a:solidFill>
-              <a:srgbClr val="B91C1C"/>
-            </a:solidFill>
-          </a:ln>
-        </p:spPr>
-        <p:style>
-          <a:lnRef idx="1">
-            <a:schemeClr val="accent1"/>
-          </a:lnRef>
-          <a:fillRef idx="3">
-            <a:schemeClr val="accent1"/>
-          </a:fillRef>
-          <a:effectRef idx="2">
-            <a:schemeClr val="accent1"/>
-          </a:effectRef>
-          <a:fontRef idx="minor">
-            <a:schemeClr val="lt1"/>
-          </a:fontRef>
-        </p:style>
-        <p:txBody>
-          <a:bodyPr rtlCol="0" anchor="ctr" wrap="square"/>
-          <a:lstStyle/>
-          <a:p>
-            <a:pPr algn="ctr"/>
-            <a:r>
-              <a:rPr sz="1300" b="1">
-                <a:solidFill>
-                  <a:srgbClr val="0B1F33"/>
-                </a:solidFill>
-                <a:latin typeface="Calibri"/>
-              </a:rPr>
-              <a:t>Invoice OOS + compare hard-stop (exact messages; no default CON-* pair)</a:t>
-            </a:r>
-          </a:p>
-        </p:txBody>
-      </p:sp>
-      <p:sp>
-        <p:nvSpPr>
-          <p:cNvPr id="7" name="Rounded Rectangle 6"/>
-          <p:cNvSpPr/>
-          <p:nvPr/>
-        </p:nvSpPr>
-        <p:spPr>
-          <a:xfrm>
-            <a:off x="457200" y="2103120"/>
-            <a:ext cx="2377440" cy="777240"/>
-          </a:xfrm>
-          <a:prstGeom prst="roundRect">
-            <a:avLst>
-              <a:gd name="adj" fmla="val 12000"/>
-            </a:avLst>
-          </a:prstGeom>
-          <a:solidFill>
-            <a:srgbClr val="D1FAE5"/>
-          </a:solidFill>
-          <a:ln w="15875">
-            <a:solidFill>
-              <a:srgbClr val="047857"/>
-            </a:solidFill>
-          </a:ln>
-        </p:spPr>
-        <p:style>
-          <a:lnRef idx="1">
-            <a:schemeClr val="accent1"/>
-          </a:lnRef>
-          <a:fillRef idx="3">
-            <a:schemeClr val="accent1"/>
-          </a:fillRef>
-          <a:effectRef idx="2">
-            <a:schemeClr val="accent1"/>
-          </a:effectRef>
-          <a:fontRef idx="minor">
-            <a:schemeClr val="lt1"/>
-          </a:fontRef>
-        </p:style>
-        <p:txBody>
-          <a:bodyPr rtlCol="0" anchor="ctr" wrap="square"/>
-          <a:lstStyle/>
-          <a:p>
-            <a:pPr algn="ctr"/>
-            <a:r>
-              <a:rPr sz="1400" b="1">
-                <a:solidFill>
-                  <a:srgbClr val="047857"/>
-                </a:solidFill>
-                <a:latin typeface="Calibri"/>
-              </a:rPr>
-              <a:t>Structured tools</a:t>
-            </a:r>
-          </a:p>
-        </p:txBody>
-      </p:sp>
-      <p:sp>
-        <p:nvSpPr>
-          <p:cNvPr id="8" name="Rounded Rectangle 7"/>
-          <p:cNvSpPr/>
-          <p:nvPr/>
-        </p:nvSpPr>
-        <p:spPr>
-          <a:xfrm>
-            <a:off x="3017520" y="2103120"/>
-            <a:ext cx="8686800" cy="777240"/>
-          </a:xfrm>
-          <a:prstGeom prst="roundRect">
-            <a:avLst>
-              <a:gd name="adj" fmla="val 12000"/>
-            </a:avLst>
-          </a:prstGeom>
-          <a:solidFill>
-            <a:srgbClr val="FFFFFF"/>
-          </a:solidFill>
-          <a:ln w="15875">
-            <a:solidFill>
-              <a:srgbClr val="047857"/>
-            </a:solidFill>
-          </a:ln>
-        </p:spPr>
-        <p:style>
-          <a:lnRef idx="1">
-            <a:schemeClr val="accent1"/>
-          </a:lnRef>
-          <a:fillRef idx="3">
-            <a:schemeClr val="accent1"/>
-          </a:fillRef>
-          <a:effectRef idx="2">
-            <a:schemeClr val="accent1"/>
-          </a:effectRef>
-          <a:fontRef idx="minor">
-            <a:schemeClr val="lt1"/>
-          </a:fontRef>
-        </p:style>
-        <p:txBody>
-          <a:bodyPr rtlCol="0" anchor="ctr" wrap="square"/>
-          <a:lstStyle/>
-          <a:p>
-            <a:pPr algn="ctr"/>
-            <a:r>
-              <a:rPr sz="1300" b="1">
-                <a:solidFill>
-                  <a:srgbClr val="0B1F33"/>
-                </a:solidFill>
-                <a:latin typeface="Calibri"/>
-              </a:rPr>
-              <a:t>search / profile / N-way compare / overlaps / risk via ContractRepository</a:t>
-            </a:r>
-          </a:p>
-        </p:txBody>
-      </p:sp>
-      <p:sp>
-        <p:nvSpPr>
-          <p:cNvPr id="9" name="Rounded Rectangle 8"/>
-          <p:cNvSpPr/>
-          <p:nvPr/>
-        </p:nvSpPr>
-        <p:spPr>
-          <a:xfrm>
-            <a:off x="457200" y="3063240"/>
-            <a:ext cx="2377440" cy="777240"/>
-          </a:xfrm>
-          <a:prstGeom prst="roundRect">
-            <a:avLst>
-              <a:gd name="adj" fmla="val 12000"/>
-            </a:avLst>
-          </a:prstGeom>
-          <a:solidFill>
-            <a:srgbClr val="D9F3F3"/>
-          </a:solidFill>
-          <a:ln w="15875">
-            <a:solidFill>
-              <a:srgbClr val="0E6B6B"/>
-            </a:solidFill>
-          </a:ln>
-        </p:spPr>
-        <p:style>
-          <a:lnRef idx="1">
-            <a:schemeClr val="accent1"/>
-          </a:lnRef>
-          <a:fillRef idx="3">
-            <a:schemeClr val="accent1"/>
-          </a:fillRef>
-          <a:effectRef idx="2">
-            <a:schemeClr val="accent1"/>
-          </a:effectRef>
-          <a:fontRef idx="minor">
-            <a:schemeClr val="lt1"/>
-          </a:fontRef>
-        </p:style>
-        <p:txBody>
-          <a:bodyPr rtlCol="0" anchor="ctr" wrap="square"/>
-          <a:lstStyle/>
-          <a:p>
-            <a:pPr algn="ctr"/>
-            <a:r>
-              <a:rPr sz="1400" b="1">
-                <a:solidFill>
-                  <a:srgbClr val="0E6B6B"/>
-                </a:solidFill>
-                <a:latin typeface="Calibri"/>
-              </a:rPr>
-              <a:t>Persona memory</a:t>
-            </a:r>
-          </a:p>
-        </p:txBody>
-      </p:sp>
-      <p:sp>
-        <p:nvSpPr>
-          <p:cNvPr id="10" name="Rounded Rectangle 9"/>
-          <p:cNvSpPr/>
-          <p:nvPr/>
-        </p:nvSpPr>
-        <p:spPr>
-          <a:xfrm>
-            <a:off x="3017520" y="3063240"/>
-            <a:ext cx="8686800" cy="777240"/>
-          </a:xfrm>
-          <a:prstGeom prst="roundRect">
-            <a:avLst>
-              <a:gd name="adj" fmla="val 12000"/>
-            </a:avLst>
-          </a:prstGeom>
-          <a:solidFill>
-            <a:srgbClr val="FFFFFF"/>
-          </a:solidFill>
-          <a:ln w="15875">
-            <a:solidFill>
-              <a:srgbClr val="0E6B6B"/>
-            </a:solidFill>
-          </a:ln>
-        </p:spPr>
-        <p:style>
-          <a:lnRef idx="1">
-            <a:schemeClr val="accent1"/>
-          </a:lnRef>
-          <a:fillRef idx="3">
-            <a:schemeClr val="accent1"/>
-          </a:fillRef>
-          <a:effectRef idx="2">
-            <a:schemeClr val="accent1"/>
-          </a:effectRef>
-          <a:fontRef idx="minor">
-            <a:schemeClr val="lt1"/>
-          </a:fontRef>
-        </p:style>
-        <p:txBody>
-          <a:bodyPr rtlCol="0" anchor="ctr" wrap="square"/>
-          <a:lstStyle/>
-          <a:p>
-            <a:pPr algn="ctr"/>
-            <a:r>
-              <a:rPr sz="1300" b="1">
-                <a:solidFill>
-                  <a:srgbClr val="0B1F33"/>
-                </a:solidFill>
-                <a:latin typeface="Calibri"/>
-              </a:rPr>
-              <a:t>SQLite save / pin / filter / recall previous searches per persona</a:t>
-            </a:r>
-          </a:p>
-        </p:txBody>
-      </p:sp>
-      <p:sp>
-        <p:nvSpPr>
-          <p:cNvPr id="11" name="Rounded Rectangle 10"/>
-          <p:cNvSpPr/>
-          <p:nvPr/>
-        </p:nvSpPr>
-        <p:spPr>
-          <a:xfrm>
-            <a:off x="457200" y="4023360"/>
-            <a:ext cx="2377440" cy="777240"/>
-          </a:xfrm>
-          <a:prstGeom prst="roundRect">
-            <a:avLst>
-              <a:gd name="adj" fmla="val 12000"/>
-            </a:avLst>
-          </a:prstGeom>
-          <a:solidFill>
-            <a:srgbClr val="EDE9FE"/>
-          </a:solidFill>
-          <a:ln w="15875">
-            <a:solidFill>
-              <a:srgbClr val="6D28D9"/>
-            </a:solidFill>
-          </a:ln>
-        </p:spPr>
-        <p:style>
-          <a:lnRef idx="1">
-            <a:schemeClr val="accent1"/>
-          </a:lnRef>
-          <a:fillRef idx="3">
-            <a:schemeClr val="accent1"/>
-          </a:fillRef>
-          <a:effectRef idx="2">
-            <a:schemeClr val="accent1"/>
-          </a:effectRef>
-          <a:fontRef idx="minor">
-            <a:schemeClr val="lt1"/>
-          </a:fontRef>
-        </p:style>
-        <p:txBody>
-          <a:bodyPr rtlCol="0" anchor="ctr" wrap="square"/>
-          <a:lstStyle/>
-          <a:p>
-            <a:pPr algn="ctr"/>
-            <a:r>
               <a:rPr sz="1400" b="1">
                 <a:solidFill>
                   <a:srgbClr val="6D28D9"/>
@@ -4703,7 +3947,7 @@
                 </a:solidFill>
                 <a:latin typeface="Calibri"/>
               </a:rPr>
-              <a:t>Foundry optional</a:t>
+              <a:t>Local runtime</a:t>
             </a:r>
           </a:p>
         </p:txBody>
@@ -4759,7 +4003,7 @@
                 </a:solidFill>
                 <a:latin typeface="Calibri"/>
               </a:rPr>
-              <a:t>Flask + offline router today; Foundry ToolSet wraps 7 tools</a:t>
+              <a:t>Streamlit → Flask → FastMCP is the sole validated POC path</a:t>
             </a:r>
           </a:p>
         </p:txBody>
@@ -4794,7 +4038,7 @@
                 </a:solidFill>
                 <a:latin typeface="Calibri"/>
               </a:rPr>
-              <a:t>Synthetic Contract Intelligence Tool-Layer POC · Slide 11</a:t>
+              <a:t>Synthetic Contract Intelligence Tool-Layer POC · Slide 10</a:t>
             </a:r>
           </a:p>
         </p:txBody>
@@ -4891,7 +4135,7 @@
                 </a:solidFill>
                 <a:latin typeface="Calibri"/>
               </a:rPr>
-              <a:t>1. Current vs Future Architecture</a:t>
+              <a:t>1. Runtime Architecture</a:t>
             </a:r>
           </a:p>
         </p:txBody>
@@ -4925,7 +4169,7 @@
                 </a:solidFill>
                 <a:latin typeface="Calibri"/>
               </a:rPr>
-              <a:t>Keep the tool layer stable; swap the cognitive host later</a:t>
+              <a:t>Keep the tool layer stable; swap data sources later</a:t>
             </a:r>
           </a:p>
         </p:txBody>
@@ -5056,7 +4300,7 @@
                 </a:solidFill>
                 <a:latin typeface="Calibri"/>
               </a:rPr>
-              <a:t>FUTURE — Foundry-hosted agent</a:t>
+              <a:t>EVOLUTION — Data source swap</a:t>
             </a:r>
           </a:p>
           <a:p>
@@ -5068,12 +4312,12 @@
                 </a:solidFill>
                 <a:latin typeface="Calibri"/>
               </a:rPr>
-              <a:t>Streamlit or Teams UI
-→ Azure AI Foundry Agent
+              <a:t>Same Streamlit / Flask host
 → Same MCP / API tools
 → ContractRepository
-→ Synthetic contract data now
-→ LinkSquares / CLM later
+→ Synthetic fixtures today
+→ Live Fabric SQL later
+→ Live LinkSquares / CLM later
 → Grounded answers</a:t>
             </a:r>
           </a:p>
@@ -6589,8 +5833,10 @@
               <a:t>SQLite: data/persona_memory.sqlite
 (override VAL_MEMORY_DB)
 • Auto-save search-like queries
-• Pin / filter / delete in sidebar
+• Pin / filter / delete searches
+• Delete prior conversations
 • GET/POST /api/memory/searches
+• DELETE /api/memory/conversations
 • GET /api/memory/recall
 • Memory-recall → offline store
 • Streamlit owns writes when

</xml_diff>